<commit_message>
Gyerekfókusz, 6+6 helyszín (határon túli magyar roma közösségek), hazai pályázatok
- Célcsoport: hátrányos helyzetű roma gyerekek (6-18 év) és családjaik
- Helyszínek fele határon túli: Fülek, Rimaszombat (Felvidék-Gömör),
  Nagyvárad, Szatmárnémeti (Partium), Szabadka (Vajdaság), Beregszász
  (Kárpátalja)
- Pályázati térkép bővítése: EFOP+ Tanoda (5,5 Mrd Ft), BM roma nemzetiségi
  felhívások (770 M Ft), EFOP+ 3.3.3-25, Bethlen Gábor Alap (határon túli)
- Költségvetés 72,7 M Ft-ra frissítve (határon túli útiköltség)
- Prezentáció, PDF-ek és összefoglaló újragenerálva

Co-Authored-By: Claude Fable 5 <noreply@anthropic.com>
Claude-Session: https://claude.ai/code/session_01NZWQf1ukuiw862VxFPR9wy
</commit_message>
<xml_diff>
--- a/eu-roma-program/prezentacio/FELUT_EU_Roma_Felzarkoztatasi_Program.pptx
+++ b/eu-roma-program/prezentacio/FELUT_EU_Roma_Felzarkoztatasi_Program.pptx
@@ -199,13 +199,13 @@
                     <c:v>Projektmenedzsment</c:v>
                   </c:pt>
                   <c:pt idx="4">
+                    <c:v>Utazás, szállás (határon túli)</c:v>
+                  </c:pt>
+                  <c:pt idx="5">
                     <c:v>Tartalék (5%)</c:v>
                   </c:pt>
-                  <c:pt idx="5">
+                  <c:pt idx="6">
                     <c:v>Helyszín, szervezés</c:v>
-                  </c:pt>
-                  <c:pt idx="6">
-                    <c:v>Utazás, szállás</c:v>
                   </c:pt>
                   <c:pt idx="7">
                     <c:v>Monitoring, hatásmérés</c:v>
@@ -239,13 +239,13 @@
                   <c:v>4.5</c:v>
                 </c:pt>
                 <c:pt idx="4">
-                  <c:v>3.4</c:v>
+                  <c:v>3.6</c:v>
                 </c:pt>
                 <c:pt idx="5">
-                  <c:v>3</c:v>
+                  <c:v>3.5</c:v>
                 </c:pt>
                 <c:pt idx="6">
-                  <c:v>2.4</c:v>
+                  <c:v>3</c:v>
                 </c:pt>
                 <c:pt idx="7">
                   <c:v>2</c:v>
@@ -1064,7 +1064,7 @@
           <a:p>
             <a:r>
               <a:rPr lang="en-US" dirty="0"/>
-              <a:t>KB. 2 PERC – A helyszínlista Észak-Magyarországtól a Dél-Dunántúlig fedi le a magas roma népességarányú térségeket. Két helyszín (Debrecen, Heves) pontos telephelye a helyi roma nemzetiségi önkormányzattal való egyeztetés után véglegesedik. Pécsen szimbolikus választás a Gandhi Gimnázium.</a:t>
+              <a:t>KB. 2 PERC – A hazai hat helyszín a magas roma népességarányú térségeket fedi le, a határon túli hat pedig a Kárpát-medence magyar ajkú roma közösségeit: Gömör (Fülek, Rimaszombat), Partium (Nagyvárad, Szatmárnémeti), Vajdaság (Szabadka), Kárpátalja (Beregszász). A határon túli termek pontos címét a helyi magyar művelődési intézményekkel való egyeztetés rögzíti. Szlovákia és Románia EU-tag (ESF+/Erasmus+ jogosult), a szerb és ukrán helyszínek a Bethlen Gábor Alapból finanszírozhatók.</a:t>
             </a:r>
             <a:endParaRPr lang="en-US" dirty="0"/>
           </a:p>
@@ -1152,7 +1152,7 @@
           <a:p>
             <a:r>
               <a:rPr lang="en-US" dirty="0"/>
-              <a:t>KB. 2,5 PERC – A nagyköveti díj a költségvetés legnagyobb tétele, és ezt nyíltan vállaljuk: a 3,5 M Ft/alkalom a kieső kereskedelmi fellépések ellentételezése, cserébe teljes napos jelenlét + médiafeladatok. A fajlagos mutató a döntéshozói kulcsszám: 70 Ft/elérés az online eléréssel együtt.</a:t>
+              <a:t>KB. 2,5 PERC – A nagyköveti díj a költségvetés legnagyobb tétele, és ezt nyíltan vállaljuk: a 3,5 M Ft/alkalom a kieső kereskedelmi fellépések ellentételezése, cserébe teljes napos jelenlét + médiafeladatok. A megemelt utazási sor a 6 határon túli alkalom többlet-útiköltségét fedezi. A fajlagos mutató a döntéshozói kulcsszám: ~72 Ft/elérés az online eléréssel együtt.</a:t>
             </a:r>
             <a:endParaRPr lang="en-US" dirty="0"/>
           </a:p>
@@ -1240,7 +1240,7 @@
           <a:p>
             <a:r>
               <a:rPr lang="en-US" dirty="0"/>
-              <a:t>KB. 2 PERC – A fő pálya az ESF+ Roma NEETs felhívás, 2026. szeptember 30-i beadási határidővel – ezért sürgős a mai döntés. A CERV a folytatás (2. évad, EU-diaszpóra bővítés) forrása, a ROVA a kommunikációs modul kiegészítő finanszírozása.</a:t>
+              <a:t>KB. 2 PERC – Három pillér: (1) ESF+ Gyermekgarancia/Roma NEETs, beadás szeptember 30-ig – ezért sürgős a döntés. (2) Hazai: az EFOP+ Tanoda-felhívás október 30-tól beadható, 5,5 Mrd Ft kerettel; a BM roma nemzetiségi felhívásai (770 M Ft) a tábor- és kulturális elemekhez. (3) A határon túli alkalmakat a helyi társrendezők BGA-pályázatai fedezik; a szerb és ukrán helyszín EU-forrásból közvetlenül nem finanszírozható, ott a BGA a járható út.</a:t>
             </a:r>
             <a:endParaRPr lang="en-US" dirty="0"/>
           </a:p>
@@ -4803,7 +4803,7 @@
                 <a:ea typeface="Arial" pitchFamily="34" charset="-122"/>
                 <a:cs typeface="Arial" pitchFamily="34" charset="-120"/>
               </a:rPr>
-              <a:t>12 alkalom – 12 közösség</a:t>
+              <a:t>6 hazai + 6 határon túli helyszín</a:t>
             </a:r>
             <a:endParaRPr lang="en-US" sz="3600" dirty="0"/>
           </a:p>
@@ -4903,7 +4903,7 @@
                 <a:ea typeface="Arial" pitchFamily="34" charset="-122"/>
                 <a:cs typeface="Arial" pitchFamily="34" charset="-120"/>
               </a:rPr>
-              <a:t>Magas roma népességarányú városok; kulturális központok és közösségi házak, minden helyszínen a helyi roma nemzetiségi önkormányzat társrendezésében.</a:t>
+              <a:t>A helyszínek fele határon túli magyar roma közösség (Felvidék–Gömör, Partium, Vajdaság, Kárpátalja); mindenhol a helyi roma és magyar közösségi szervezetek a társrendezők.</a:t>
             </a:r>
             <a:endParaRPr lang="en-US" sz="1400" dirty="0"/>
           </a:p>
@@ -4932,9 +4932,9 @@
             <a:tbl>
               <a:tblPr/>
               <a:tblGrid>
-                <a:gridCol w="3108960"/>
-                <a:gridCol w="4572000"/>
-                <a:gridCol w="3566160"/>
+                <a:gridCol w="2377440"/>
+                <a:gridCol w="3291840"/>
+                <a:gridCol w="5577840"/>
               </a:tblGrid>
               <a:tr h="320040">
                 <a:tc>
@@ -4946,7 +4946,7 @@
                         <a:buNone/>
                       </a:pPr>
                       <a:r>
-                        <a:rPr lang="en-US" sz="1150" b="1" dirty="0">
+                        <a:rPr lang="en-US" sz="1100" b="1" dirty="0">
                           <a:solidFill>
                             <a:srgbClr val="FFFFFF"/>
                           </a:solidFill>
@@ -4954,9 +4954,9 @@
                           <a:ea typeface="Arial" pitchFamily="34" charset="-122"/>
                           <a:cs typeface="Arial" pitchFamily="34" charset="-120"/>
                         </a:rPr>
-                        <a:t>Város / térség</a:t>
+                        <a:t>Régió</a:t>
                       </a:r>
-                      <a:endParaRPr lang="en-US" sz="1150" dirty="0">
+                      <a:endParaRPr lang="en-US" sz="1100" dirty="0">
                         <a:latin typeface="Arial" charset="0"/>
                         <a:ea typeface="Arial" charset="0"/>
                         <a:cs typeface="Arial" charset="0"/>
@@ -5014,7 +5014,7 @@
                         <a:buNone/>
                       </a:pPr>
                       <a:r>
-                        <a:rPr lang="en-US" sz="1150" b="1" dirty="0">
+                        <a:rPr lang="en-US" sz="1100" b="1" dirty="0">
                           <a:solidFill>
                             <a:srgbClr val="FFFFFF"/>
                           </a:solidFill>
@@ -5022,9 +5022,9 @@
                           <a:ea typeface="Arial" pitchFamily="34" charset="-122"/>
                           <a:cs typeface="Arial" pitchFamily="34" charset="-120"/>
                         </a:rPr>
-                        <a:t>Helyszín</a:t>
+                        <a:t>Város</a:t>
                       </a:r>
-                      <a:endParaRPr lang="en-US" sz="1150" dirty="0">
+                      <a:endParaRPr lang="en-US" sz="1100" dirty="0">
                         <a:latin typeface="Arial" charset="0"/>
                         <a:ea typeface="Arial" charset="0"/>
                         <a:cs typeface="Arial" charset="0"/>
@@ -5082,7 +5082,7 @@
                         <a:buNone/>
                       </a:pPr>
                       <a:r>
-                        <a:rPr lang="en-US" sz="1150" b="1" dirty="0">
+                        <a:rPr lang="en-US" sz="1100" b="1" dirty="0">
                           <a:solidFill>
                             <a:srgbClr val="FFFFFF"/>
                           </a:solidFill>
@@ -5090,9 +5090,9 @@
                           <a:ea typeface="Arial" pitchFamily="34" charset="-122"/>
                           <a:cs typeface="Arial" pitchFamily="34" charset="-120"/>
                         </a:rPr>
-                        <a:t>Cím</a:t>
+                        <a:t>Helyszín</a:t>
                       </a:r>
-                      <a:endParaRPr lang="en-US" sz="1150" dirty="0">
+                      <a:endParaRPr lang="en-US" sz="1100" dirty="0">
                         <a:latin typeface="Arial" charset="0"/>
                         <a:ea typeface="Arial" charset="0"/>
                         <a:cs typeface="Arial" charset="0"/>
@@ -5152,17 +5152,17 @@
                         <a:buNone/>
                       </a:pPr>
                       <a:r>
-                        <a:rPr lang="en-US" sz="1150" dirty="0">
+                        <a:rPr lang="en-US" sz="1100" b="1" dirty="0">
                           <a:solidFill>
-                            <a:srgbClr val="333B44"/>
+                            <a:srgbClr val="1E3A5F"/>
                           </a:solidFill>
                           <a:latin typeface="Arial" pitchFamily="34" charset="0"/>
                           <a:ea typeface="Arial" pitchFamily="34" charset="-122"/>
                           <a:cs typeface="Arial" pitchFamily="34" charset="-120"/>
                         </a:rPr>
-                        <a:t>Budapest VIII. (Magdolna-negyed)</a:t>
+                        <a:t>MAGYARORSZÁG</a:t>
                       </a:r>
-                      <a:endParaRPr lang="en-US" sz="1150" dirty="0">
+                      <a:endParaRPr lang="en-US" sz="1100" dirty="0">
                         <a:latin typeface="Arial" charset="0"/>
                         <a:ea typeface="Arial" charset="0"/>
                         <a:cs typeface="Arial" charset="0"/>
@@ -5220,7 +5220,7 @@
                         <a:buNone/>
                       </a:pPr>
                       <a:r>
-                        <a:rPr lang="en-US" sz="1150" dirty="0">
+                        <a:rPr lang="en-US" sz="1100" dirty="0">
                           <a:solidFill>
                             <a:srgbClr val="333B44"/>
                           </a:solidFill>
@@ -5228,9 +5228,9 @@
                           <a:ea typeface="Arial" pitchFamily="34" charset="-122"/>
                           <a:cs typeface="Arial" pitchFamily="34" charset="-120"/>
                         </a:rPr>
-                        <a:t>Kesztyűgyár Közösségi Ház</a:t>
+                        <a:t>Budapest VIII. (Magdolna-negyed)</a:t>
                       </a:r>
-                      <a:endParaRPr lang="en-US" sz="1150" dirty="0">
+                      <a:endParaRPr lang="en-US" sz="1100" dirty="0">
                         <a:latin typeface="Arial" charset="0"/>
                         <a:ea typeface="Arial" charset="0"/>
                         <a:cs typeface="Arial" charset="0"/>
@@ -5288,7 +5288,7 @@
                         <a:buNone/>
                       </a:pPr>
                       <a:r>
-                        <a:rPr lang="en-US" sz="1150" dirty="0">
+                        <a:rPr lang="en-US" sz="1100" dirty="0">
                           <a:solidFill>
                             <a:srgbClr val="333B44"/>
                           </a:solidFill>
@@ -5296,9 +5296,9 @@
                           <a:ea typeface="Arial" pitchFamily="34" charset="-122"/>
                           <a:cs typeface="Arial" pitchFamily="34" charset="-120"/>
                         </a:rPr>
-                        <a:t>1084 Bp., Mátyás tér 15.</a:t>
+                        <a:t>Kesztyűgyár Közösségi Ház, Mátyás tér 15.</a:t>
                       </a:r>
-                      <a:endParaRPr lang="en-US" sz="1150" dirty="0">
+                      <a:endParaRPr lang="en-US" sz="1100" dirty="0">
                         <a:latin typeface="Arial" charset="0"/>
                         <a:ea typeface="Arial" charset="0"/>
                         <a:cs typeface="Arial" charset="0"/>
@@ -5358,17 +5358,17 @@
                         <a:buNone/>
                       </a:pPr>
                       <a:r>
-                        <a:rPr lang="en-US" sz="1150" dirty="0">
+                        <a:rPr lang="en-US" sz="1100" b="1" dirty="0">
                           <a:solidFill>
-                            <a:srgbClr val="333B44"/>
+                            <a:srgbClr val="1E3A5F"/>
                           </a:solidFill>
                           <a:latin typeface="Arial" pitchFamily="34" charset="0"/>
                           <a:ea typeface="Arial" pitchFamily="34" charset="-122"/>
                           <a:cs typeface="Arial" pitchFamily="34" charset="-120"/>
                         </a:rPr>
-                        <a:t>Miskolc</a:t>
+                        <a:t>MAGYARORSZÁG</a:t>
                       </a:r>
-                      <a:endParaRPr lang="en-US" sz="1150" dirty="0">
+                      <a:endParaRPr lang="en-US" sz="1100" dirty="0">
                         <a:latin typeface="Arial" charset="0"/>
                         <a:ea typeface="Arial" charset="0"/>
                         <a:cs typeface="Arial" charset="0"/>
@@ -5426,7 +5426,7 @@
                         <a:buNone/>
                       </a:pPr>
                       <a:r>
-                        <a:rPr lang="en-US" sz="1150" dirty="0">
+                        <a:rPr lang="en-US" sz="1100" dirty="0">
                           <a:solidFill>
                             <a:srgbClr val="333B44"/>
                           </a:solidFill>
@@ -5434,9 +5434,9 @@
                           <a:ea typeface="Arial" pitchFamily="34" charset="-122"/>
                           <a:cs typeface="Arial" pitchFamily="34" charset="-120"/>
                         </a:rPr>
-                        <a:t>Ifjúsági és Szabadidő Ház</a:t>
+                        <a:t>Miskolc</a:t>
                       </a:r>
-                      <a:endParaRPr lang="en-US" sz="1150" dirty="0">
+                      <a:endParaRPr lang="en-US" sz="1100" dirty="0">
                         <a:latin typeface="Arial" charset="0"/>
                         <a:ea typeface="Arial" charset="0"/>
                         <a:cs typeface="Arial" charset="0"/>
@@ -5494,7 +5494,7 @@
                         <a:buNone/>
                       </a:pPr>
                       <a:r>
-                        <a:rPr lang="en-US" sz="1150" dirty="0">
+                        <a:rPr lang="en-US" sz="1100" dirty="0">
                           <a:solidFill>
                             <a:srgbClr val="333B44"/>
                           </a:solidFill>
@@ -5502,9 +5502,9 @@
                           <a:ea typeface="Arial" pitchFamily="34" charset="-122"/>
                           <a:cs typeface="Arial" pitchFamily="34" charset="-120"/>
                         </a:rPr>
-                        <a:t>3531 Miskolc, Győri kapu 27/A</a:t>
+                        <a:t>Ifjúsági és Szabadidő Ház, Győri kapu 27/A</a:t>
                       </a:r>
-                      <a:endParaRPr lang="en-US" sz="1150" dirty="0">
+                      <a:endParaRPr lang="en-US" sz="1100" dirty="0">
                         <a:latin typeface="Arial" charset="0"/>
                         <a:ea typeface="Arial" charset="0"/>
                         <a:cs typeface="Arial" charset="0"/>
@@ -5564,17 +5564,17 @@
                         <a:buNone/>
                       </a:pPr>
                       <a:r>
-                        <a:rPr lang="en-US" sz="1150" dirty="0">
+                        <a:rPr lang="en-US" sz="1100" b="1" dirty="0">
                           <a:solidFill>
-                            <a:srgbClr val="333B44"/>
+                            <a:srgbClr val="1E3A5F"/>
                           </a:solidFill>
                           <a:latin typeface="Arial" pitchFamily="34" charset="0"/>
                           <a:ea typeface="Arial" pitchFamily="34" charset="-122"/>
                           <a:cs typeface="Arial" pitchFamily="34" charset="-120"/>
                         </a:rPr>
-                        <a:t>Ózd</a:t>
+                        <a:t>MAGYARORSZÁG</a:t>
                       </a:r>
-                      <a:endParaRPr lang="en-US" sz="1150" dirty="0">
+                      <a:endParaRPr lang="en-US" sz="1100" dirty="0">
                         <a:latin typeface="Arial" charset="0"/>
                         <a:ea typeface="Arial" charset="0"/>
                         <a:cs typeface="Arial" charset="0"/>
@@ -5632,7 +5632,7 @@
                         <a:buNone/>
                       </a:pPr>
                       <a:r>
-                        <a:rPr lang="en-US" sz="1150" dirty="0">
+                        <a:rPr lang="en-US" sz="1100" dirty="0">
                           <a:solidFill>
                             <a:srgbClr val="333B44"/>
                           </a:solidFill>
@@ -5640,9 +5640,9 @@
                           <a:ea typeface="Arial" pitchFamily="34" charset="-122"/>
                           <a:cs typeface="Arial" pitchFamily="34" charset="-120"/>
                         </a:rPr>
-                        <a:t>ÓMÉK – „Olvasó” Művelődési Központ</a:t>
+                        <a:t>Ózd</a:t>
                       </a:r>
-                      <a:endParaRPr lang="en-US" sz="1150" dirty="0">
+                      <a:endParaRPr lang="en-US" sz="1100" dirty="0">
                         <a:latin typeface="Arial" charset="0"/>
                         <a:ea typeface="Arial" charset="0"/>
                         <a:cs typeface="Arial" charset="0"/>
@@ -5700,7 +5700,7 @@
                         <a:buNone/>
                       </a:pPr>
                       <a:r>
-                        <a:rPr lang="en-US" sz="1150" dirty="0">
+                        <a:rPr lang="en-US" sz="1100" dirty="0">
                           <a:solidFill>
                             <a:srgbClr val="333B44"/>
                           </a:solidFill>
@@ -5708,9 +5708,9 @@
                           <a:ea typeface="Arial" pitchFamily="34" charset="-122"/>
                           <a:cs typeface="Arial" pitchFamily="34" charset="-120"/>
                         </a:rPr>
-                        <a:t>3600 Ózd, Gyár út 4.</a:t>
+                        <a:t>ÓMÉK – „Olvasó” Művelődési Központ, Gyár út 4.</a:t>
                       </a:r>
-                      <a:endParaRPr lang="en-US" sz="1150" dirty="0">
+                      <a:endParaRPr lang="en-US" sz="1100" dirty="0">
                         <a:latin typeface="Arial" charset="0"/>
                         <a:ea typeface="Arial" charset="0"/>
                         <a:cs typeface="Arial" charset="0"/>
@@ -5770,17 +5770,17 @@
                         <a:buNone/>
                       </a:pPr>
                       <a:r>
-                        <a:rPr lang="en-US" sz="1150" dirty="0">
+                        <a:rPr lang="en-US" sz="1100" b="1" dirty="0">
                           <a:solidFill>
-                            <a:srgbClr val="333B44"/>
+                            <a:srgbClr val="1E3A5F"/>
                           </a:solidFill>
                           <a:latin typeface="Arial" pitchFamily="34" charset="0"/>
                           <a:ea typeface="Arial" pitchFamily="34" charset="-122"/>
                           <a:cs typeface="Arial" pitchFamily="34" charset="-120"/>
                         </a:rPr>
-                        <a:t>Salgótarján</a:t>
+                        <a:t>MAGYARORSZÁG</a:t>
                       </a:r>
-                      <a:endParaRPr lang="en-US" sz="1150" dirty="0">
+                      <a:endParaRPr lang="en-US" sz="1100" dirty="0">
                         <a:latin typeface="Arial" charset="0"/>
                         <a:ea typeface="Arial" charset="0"/>
                         <a:cs typeface="Arial" charset="0"/>
@@ -5838,7 +5838,7 @@
                         <a:buNone/>
                       </a:pPr>
                       <a:r>
-                        <a:rPr lang="en-US" sz="1150" dirty="0">
+                        <a:rPr lang="en-US" sz="1100" dirty="0">
                           <a:solidFill>
                             <a:srgbClr val="333B44"/>
                           </a:solidFill>
@@ -5846,9 +5846,9 @@
                           <a:ea typeface="Arial" pitchFamily="34" charset="-122"/>
                           <a:cs typeface="Arial" pitchFamily="34" charset="-120"/>
                         </a:rPr>
-                        <a:t>József Attila Művelődési Központ</a:t>
+                        <a:t>Salgótarján</a:t>
                       </a:r>
-                      <a:endParaRPr lang="en-US" sz="1150" dirty="0">
+                      <a:endParaRPr lang="en-US" sz="1100" dirty="0">
                         <a:latin typeface="Arial" charset="0"/>
                         <a:ea typeface="Arial" charset="0"/>
                         <a:cs typeface="Arial" charset="0"/>
@@ -5906,7 +5906,7 @@
                         <a:buNone/>
                       </a:pPr>
                       <a:r>
-                        <a:rPr lang="en-US" sz="1150" dirty="0">
+                        <a:rPr lang="en-US" sz="1100" dirty="0">
                           <a:solidFill>
                             <a:srgbClr val="333B44"/>
                           </a:solidFill>
@@ -5914,9 +5914,9 @@
                           <a:ea typeface="Arial" pitchFamily="34" charset="-122"/>
                           <a:cs typeface="Arial" pitchFamily="34" charset="-120"/>
                         </a:rPr>
-                        <a:t>3100 Salgótarján, Fő tér 5.</a:t>
+                        <a:t>József Attila Művelődési Központ, Fő tér 5.</a:t>
                       </a:r>
-                      <a:endParaRPr lang="en-US" sz="1150" dirty="0">
+                      <a:endParaRPr lang="en-US" sz="1100" dirty="0">
                         <a:latin typeface="Arial" charset="0"/>
                         <a:ea typeface="Arial" charset="0"/>
                         <a:cs typeface="Arial" charset="0"/>
@@ -5976,17 +5976,17 @@
                         <a:buNone/>
                       </a:pPr>
                       <a:r>
-                        <a:rPr lang="en-US" sz="1150" dirty="0">
+                        <a:rPr lang="en-US" sz="1100" b="1" dirty="0">
                           <a:solidFill>
-                            <a:srgbClr val="333B44"/>
+                            <a:srgbClr val="1E3A5F"/>
                           </a:solidFill>
                           <a:latin typeface="Arial" pitchFamily="34" charset="0"/>
                           <a:ea typeface="Arial" pitchFamily="34" charset="-122"/>
                           <a:cs typeface="Arial" pitchFamily="34" charset="-120"/>
                         </a:rPr>
-                        <a:t>Nyíregyháza</a:t>
+                        <a:t>MAGYARORSZÁG</a:t>
                       </a:r>
-                      <a:endParaRPr lang="en-US" sz="1150" dirty="0">
+                      <a:endParaRPr lang="en-US" sz="1100" dirty="0">
                         <a:latin typeface="Arial" charset="0"/>
                         <a:ea typeface="Arial" charset="0"/>
                         <a:cs typeface="Arial" charset="0"/>
@@ -6044,7 +6044,7 @@
                         <a:buNone/>
                       </a:pPr>
                       <a:r>
-                        <a:rPr lang="en-US" sz="1150" dirty="0">
+                        <a:rPr lang="en-US" sz="1100" dirty="0">
                           <a:solidFill>
                             <a:srgbClr val="333B44"/>
                           </a:solidFill>
@@ -6052,9 +6052,9 @@
                           <a:ea typeface="Arial" pitchFamily="34" charset="-122"/>
                           <a:cs typeface="Arial" pitchFamily="34" charset="-120"/>
                         </a:rPr>
-                        <a:t>Váci Mihály Kulturális Központ</a:t>
+                        <a:t>Nyíregyháza</a:t>
                       </a:r>
-                      <a:endParaRPr lang="en-US" sz="1150" dirty="0">
+                      <a:endParaRPr lang="en-US" sz="1100" dirty="0">
                         <a:latin typeface="Arial" charset="0"/>
                         <a:ea typeface="Arial" charset="0"/>
                         <a:cs typeface="Arial" charset="0"/>
@@ -6112,7 +6112,7 @@
                         <a:buNone/>
                       </a:pPr>
                       <a:r>
-                        <a:rPr lang="en-US" sz="1150" dirty="0">
+                        <a:rPr lang="en-US" sz="1100" dirty="0">
                           <a:solidFill>
                             <a:srgbClr val="333B44"/>
                           </a:solidFill>
@@ -6120,9 +6120,9 @@
                           <a:ea typeface="Arial" pitchFamily="34" charset="-122"/>
                           <a:cs typeface="Arial" pitchFamily="34" charset="-120"/>
                         </a:rPr>
-                        <a:t>4400 Nyíregyháza, Szabadság tér 9.</a:t>
+                        <a:t>Váci Mihály Kulturális Központ, Szabadság tér 9.</a:t>
                       </a:r>
-                      <a:endParaRPr lang="en-US" sz="1150" dirty="0">
+                      <a:endParaRPr lang="en-US" sz="1100" dirty="0">
                         <a:latin typeface="Arial" charset="0"/>
                         <a:ea typeface="Arial" charset="0"/>
                         <a:cs typeface="Arial" charset="0"/>
@@ -6182,17 +6182,17 @@
                         <a:buNone/>
                       </a:pPr>
                       <a:r>
-                        <a:rPr lang="en-US" sz="1150" dirty="0">
+                        <a:rPr lang="en-US" sz="1100" b="1" dirty="0">
                           <a:solidFill>
-                            <a:srgbClr val="333B44"/>
+                            <a:srgbClr val="1E3A5F"/>
                           </a:solidFill>
                           <a:latin typeface="Arial" pitchFamily="34" charset="0"/>
                           <a:ea typeface="Arial" pitchFamily="34" charset="-122"/>
                           <a:cs typeface="Arial" pitchFamily="34" charset="-120"/>
                         </a:rPr>
-                        <a:t>Debrecen</a:t>
+                        <a:t>MAGYARORSZÁG</a:t>
                       </a:r>
-                      <a:endParaRPr lang="en-US" sz="1150" dirty="0">
+                      <a:endParaRPr lang="en-US" sz="1100" dirty="0">
                         <a:latin typeface="Arial" charset="0"/>
                         <a:ea typeface="Arial" charset="0"/>
                         <a:cs typeface="Arial" charset="0"/>
@@ -6250,7 +6250,7 @@
                         <a:buNone/>
                       </a:pPr>
                       <a:r>
-                        <a:rPr lang="en-US" sz="1150" dirty="0">
+                        <a:rPr lang="en-US" sz="1100" dirty="0">
                           <a:solidFill>
                             <a:srgbClr val="333B44"/>
                           </a:solidFill>
@@ -6258,9 +6258,9 @@
                           <a:ea typeface="Arial" pitchFamily="34" charset="-122"/>
                           <a:cs typeface="Arial" pitchFamily="34" charset="-120"/>
                         </a:rPr>
-                        <a:t>DMK közösségi ház (egyeztetés alatt)</a:t>
+                        <a:t>Pécs</a:t>
                       </a:r>
-                      <a:endParaRPr lang="en-US" sz="1150" dirty="0">
+                      <a:endParaRPr lang="en-US" sz="1100" dirty="0">
                         <a:latin typeface="Arial" charset="0"/>
                         <a:ea typeface="Arial" charset="0"/>
                         <a:cs typeface="Arial" charset="0"/>
@@ -6318,7 +6318,7 @@
                         <a:buNone/>
                       </a:pPr>
                       <a:r>
-                        <a:rPr lang="en-US" sz="1150" dirty="0">
+                        <a:rPr lang="en-US" sz="1100" dirty="0">
                           <a:solidFill>
                             <a:srgbClr val="333B44"/>
                           </a:solidFill>
@@ -6326,9 +6326,9 @@
                           <a:ea typeface="Arial" pitchFamily="34" charset="-122"/>
                           <a:cs typeface="Arial" pitchFamily="34" charset="-120"/>
                         </a:rPr>
-                        <a:t>4024 Debrecen</a:t>
+                        <a:t>Gandhi Gimnázium díszterme, Komját Aladár u. 5.</a:t>
                       </a:r>
-                      <a:endParaRPr lang="en-US" sz="1150" dirty="0">
+                      <a:endParaRPr lang="en-US" sz="1100" dirty="0">
                         <a:latin typeface="Arial" charset="0"/>
                         <a:ea typeface="Arial" charset="0"/>
                         <a:cs typeface="Arial" charset="0"/>
@@ -6388,17 +6388,17 @@
                         <a:buNone/>
                       </a:pPr>
                       <a:r>
-                        <a:rPr lang="en-US" sz="1150" dirty="0">
+                        <a:rPr lang="en-US" sz="1100" b="1" dirty="0">
                           <a:solidFill>
-                            <a:srgbClr val="333B44"/>
+                            <a:srgbClr val="237547"/>
                           </a:solidFill>
                           <a:latin typeface="Arial" pitchFamily="34" charset="0"/>
                           <a:ea typeface="Arial" pitchFamily="34" charset="-122"/>
                           <a:cs typeface="Arial" pitchFamily="34" charset="-120"/>
                         </a:rPr>
-                        <a:t>Pécs</a:t>
+                        <a:t>FELVIDÉK (SK)</a:t>
                       </a:r>
-                      <a:endParaRPr lang="en-US" sz="1150" dirty="0">
+                      <a:endParaRPr lang="en-US" sz="1100" dirty="0">
                         <a:latin typeface="Arial" charset="0"/>
                         <a:ea typeface="Arial" charset="0"/>
                         <a:cs typeface="Arial" charset="0"/>
@@ -6443,7 +6443,7 @@
                       <a:tailEnd type="none" w="med" len="med"/>
                     </a:lnB>
                     <a:solidFill>
-                      <a:srgbClr val="F4F7FA"/>
+                      <a:srgbClr val="E8F1E9"/>
                     </a:solidFill>
                   </a:tcPr>
                 </a:tc>
@@ -6456,7 +6456,7 @@
                         <a:buNone/>
                       </a:pPr>
                       <a:r>
-                        <a:rPr lang="en-US" sz="1150" dirty="0">
+                        <a:rPr lang="en-US" sz="1100" dirty="0">
                           <a:solidFill>
                             <a:srgbClr val="333B44"/>
                           </a:solidFill>
@@ -6464,9 +6464,9 @@
                           <a:ea typeface="Arial" pitchFamily="34" charset="-122"/>
                           <a:cs typeface="Arial" pitchFamily="34" charset="-120"/>
                         </a:rPr>
-                        <a:t>Gandhi Gimnázium díszterme</a:t>
+                        <a:t>Fülek / Fiľakovo</a:t>
                       </a:r>
-                      <a:endParaRPr lang="en-US" sz="1150" dirty="0">
+                      <a:endParaRPr lang="en-US" sz="1100" dirty="0">
                         <a:latin typeface="Arial" charset="0"/>
                         <a:ea typeface="Arial" charset="0"/>
                         <a:cs typeface="Arial" charset="0"/>
@@ -6511,7 +6511,7 @@
                       <a:tailEnd type="none" w="med" len="med"/>
                     </a:lnB>
                     <a:solidFill>
-                      <a:srgbClr val="F4F7FA"/>
+                      <a:srgbClr val="E8F1E9"/>
                     </a:solidFill>
                   </a:tcPr>
                 </a:tc>
@@ -6524,7 +6524,7 @@
                         <a:buNone/>
                       </a:pPr>
                       <a:r>
-                        <a:rPr lang="en-US" sz="1150" dirty="0">
+                        <a:rPr lang="en-US" sz="1100" dirty="0">
                           <a:solidFill>
                             <a:srgbClr val="333B44"/>
                           </a:solidFill>
@@ -6532,9 +6532,9 @@
                           <a:ea typeface="Arial" pitchFamily="34" charset="-122"/>
                           <a:cs typeface="Arial" pitchFamily="34" charset="-120"/>
                         </a:rPr>
-                        <a:t>7629 Pécs, Komját Aladár u. 5.</a:t>
+                        <a:t>Füleki Vigadó (cím egyeztetés alatt)</a:t>
                       </a:r>
-                      <a:endParaRPr lang="en-US" sz="1150" dirty="0">
+                      <a:endParaRPr lang="en-US" sz="1100" dirty="0">
                         <a:latin typeface="Arial" charset="0"/>
                         <a:ea typeface="Arial" charset="0"/>
                         <a:cs typeface="Arial" charset="0"/>
@@ -6579,7 +6579,7 @@
                       <a:tailEnd type="none" w="med" len="med"/>
                     </a:lnB>
                     <a:solidFill>
-                      <a:srgbClr val="F4F7FA"/>
+                      <a:srgbClr val="E8F1E9"/>
                     </a:solidFill>
                   </a:tcPr>
                 </a:tc>
@@ -6594,17 +6594,17 @@
                         <a:buNone/>
                       </a:pPr>
                       <a:r>
-                        <a:rPr lang="en-US" sz="1150" dirty="0">
+                        <a:rPr lang="en-US" sz="1100" b="1" dirty="0">
                           <a:solidFill>
-                            <a:srgbClr val="333B44"/>
+                            <a:srgbClr val="237547"/>
                           </a:solidFill>
                           <a:latin typeface="Arial" pitchFamily="34" charset="0"/>
                           <a:ea typeface="Arial" pitchFamily="34" charset="-122"/>
                           <a:cs typeface="Arial" pitchFamily="34" charset="-120"/>
                         </a:rPr>
-                        <a:t>Szeged</a:t>
+                        <a:t>FELVIDÉK (SK)</a:t>
                       </a:r>
-                      <a:endParaRPr lang="en-US" sz="1150" dirty="0">
+                      <a:endParaRPr lang="en-US" sz="1100" dirty="0">
                         <a:latin typeface="Arial" charset="0"/>
                         <a:ea typeface="Arial" charset="0"/>
                         <a:cs typeface="Arial" charset="0"/>
@@ -6662,7 +6662,7 @@
                         <a:buNone/>
                       </a:pPr>
                       <a:r>
-                        <a:rPr lang="en-US" sz="1150" dirty="0">
+                        <a:rPr lang="en-US" sz="1100" dirty="0">
                           <a:solidFill>
                             <a:srgbClr val="333B44"/>
                           </a:solidFill>
@@ -6670,9 +6670,9 @@
                           <a:ea typeface="Arial" pitchFamily="34" charset="-122"/>
                           <a:cs typeface="Arial" pitchFamily="34" charset="-120"/>
                         </a:rPr>
-                        <a:t>Szent-Györgyi Albert Agóra</a:t>
+                        <a:t>Rimaszombat / Rim. Sobota</a:t>
                       </a:r>
-                      <a:endParaRPr lang="en-US" sz="1150" dirty="0">
+                      <a:endParaRPr lang="en-US" sz="1100" dirty="0">
                         <a:latin typeface="Arial" charset="0"/>
                         <a:ea typeface="Arial" charset="0"/>
                         <a:cs typeface="Arial" charset="0"/>
@@ -6730,7 +6730,7 @@
                         <a:buNone/>
                       </a:pPr>
                       <a:r>
-                        <a:rPr lang="en-US" sz="1150" dirty="0">
+                        <a:rPr lang="en-US" sz="1100" dirty="0">
                           <a:solidFill>
                             <a:srgbClr val="333B44"/>
                           </a:solidFill>
@@ -6738,9 +6738,9 @@
                           <a:ea typeface="Arial" pitchFamily="34" charset="-122"/>
                           <a:cs typeface="Arial" pitchFamily="34" charset="-120"/>
                         </a:rPr>
-                        <a:t>6722 Szeged, Kálvária sgt. 23.</a:t>
+                        <a:t>Városi Művelődési Központ (egyeztetés alatt)</a:t>
                       </a:r>
-                      <a:endParaRPr lang="en-US" sz="1150" dirty="0">
+                      <a:endParaRPr lang="en-US" sz="1100" dirty="0">
                         <a:latin typeface="Arial" charset="0"/>
                         <a:ea typeface="Arial" charset="0"/>
                         <a:cs typeface="Arial" charset="0"/>
@@ -6800,17 +6800,17 @@
                         <a:buNone/>
                       </a:pPr>
                       <a:r>
-                        <a:rPr lang="en-US" sz="1150" dirty="0">
+                        <a:rPr lang="en-US" sz="1100" b="1" dirty="0">
                           <a:solidFill>
-                            <a:srgbClr val="333B44"/>
+                            <a:srgbClr val="237547"/>
                           </a:solidFill>
                           <a:latin typeface="Arial" pitchFamily="34" charset="0"/>
                           <a:ea typeface="Arial" pitchFamily="34" charset="-122"/>
                           <a:cs typeface="Arial" pitchFamily="34" charset="-120"/>
                         </a:rPr>
-                        <a:t>Békéscsaba</a:t>
+                        <a:t>PARTIUM (RO)</a:t>
                       </a:r>
-                      <a:endParaRPr lang="en-US" sz="1150" dirty="0">
+                      <a:endParaRPr lang="en-US" sz="1100" dirty="0">
                         <a:latin typeface="Arial" charset="0"/>
                         <a:ea typeface="Arial" charset="0"/>
                         <a:cs typeface="Arial" charset="0"/>
@@ -6855,7 +6855,7 @@
                       <a:tailEnd type="none" w="med" len="med"/>
                     </a:lnB>
                     <a:solidFill>
-                      <a:srgbClr val="F4F7FA"/>
+                      <a:srgbClr val="E8F1E9"/>
                     </a:solidFill>
                   </a:tcPr>
                 </a:tc>
@@ -6868,7 +6868,7 @@
                         <a:buNone/>
                       </a:pPr>
                       <a:r>
-                        <a:rPr lang="en-US" sz="1150" dirty="0">
+                        <a:rPr lang="en-US" sz="1100" dirty="0">
                           <a:solidFill>
                             <a:srgbClr val="333B44"/>
                           </a:solidFill>
@@ -6876,9 +6876,9 @@
                           <a:ea typeface="Arial" pitchFamily="34" charset="-122"/>
                           <a:cs typeface="Arial" pitchFamily="34" charset="-120"/>
                         </a:rPr>
-                        <a:t>Csabagyöngye Kulturális Központ</a:t>
+                        <a:t>Nagyvárad / Oradea</a:t>
                       </a:r>
-                      <a:endParaRPr lang="en-US" sz="1150" dirty="0">
+                      <a:endParaRPr lang="en-US" sz="1100" dirty="0">
                         <a:latin typeface="Arial" charset="0"/>
                         <a:ea typeface="Arial" charset="0"/>
                         <a:cs typeface="Arial" charset="0"/>
@@ -6923,7 +6923,7 @@
                       <a:tailEnd type="none" w="med" len="med"/>
                     </a:lnB>
                     <a:solidFill>
-                      <a:srgbClr val="F4F7FA"/>
+                      <a:srgbClr val="E8F1E9"/>
                     </a:solidFill>
                   </a:tcPr>
                 </a:tc>
@@ -6936,7 +6936,7 @@
                         <a:buNone/>
                       </a:pPr>
                       <a:r>
-                        <a:rPr lang="en-US" sz="1150" dirty="0">
+                        <a:rPr lang="en-US" sz="1100" dirty="0">
                           <a:solidFill>
                             <a:srgbClr val="333B44"/>
                           </a:solidFill>
@@ -6944,9 +6944,9 @@
                           <a:ea typeface="Arial" pitchFamily="34" charset="-122"/>
                           <a:cs typeface="Arial" pitchFamily="34" charset="-120"/>
                         </a:rPr>
-                        <a:t>5600 Békéscsaba, Széchenyi u. 4.</a:t>
+                        <a:t>magyar kulturális intézmény (egyeztetés alatt)</a:t>
                       </a:r>
-                      <a:endParaRPr lang="en-US" sz="1150" dirty="0">
+                      <a:endParaRPr lang="en-US" sz="1100" dirty="0">
                         <a:latin typeface="Arial" charset="0"/>
                         <a:ea typeface="Arial" charset="0"/>
                         <a:cs typeface="Arial" charset="0"/>
@@ -6991,7 +6991,7 @@
                       <a:tailEnd type="none" w="med" len="med"/>
                     </a:lnB>
                     <a:solidFill>
-                      <a:srgbClr val="F4F7FA"/>
+                      <a:srgbClr val="E8F1E9"/>
                     </a:solidFill>
                   </a:tcPr>
                 </a:tc>
@@ -7006,17 +7006,17 @@
                         <a:buNone/>
                       </a:pPr>
                       <a:r>
-                        <a:rPr lang="en-US" sz="1150" dirty="0">
+                        <a:rPr lang="en-US" sz="1100" b="1" dirty="0">
                           <a:solidFill>
-                            <a:srgbClr val="333B44"/>
+                            <a:srgbClr val="237547"/>
                           </a:solidFill>
                           <a:latin typeface="Arial" pitchFamily="34" charset="0"/>
                           <a:ea typeface="Arial" pitchFamily="34" charset="-122"/>
                           <a:cs typeface="Arial" pitchFamily="34" charset="-120"/>
                         </a:rPr>
-                        <a:t>Tatabánya</a:t>
+                        <a:t>PARTIUM (RO)</a:t>
                       </a:r>
-                      <a:endParaRPr lang="en-US" sz="1150" dirty="0">
+                      <a:endParaRPr lang="en-US" sz="1100" dirty="0">
                         <a:latin typeface="Arial" charset="0"/>
                         <a:ea typeface="Arial" charset="0"/>
                         <a:cs typeface="Arial" charset="0"/>
@@ -7074,7 +7074,7 @@
                         <a:buNone/>
                       </a:pPr>
                       <a:r>
-                        <a:rPr lang="en-US" sz="1150" dirty="0">
+                        <a:rPr lang="en-US" sz="1100" dirty="0">
                           <a:solidFill>
                             <a:srgbClr val="333B44"/>
                           </a:solidFill>
@@ -7082,9 +7082,9 @@
                           <a:ea typeface="Arial" pitchFamily="34" charset="-122"/>
                           <a:cs typeface="Arial" pitchFamily="34" charset="-120"/>
                         </a:rPr>
-                        <a:t>A Vértes Agorája</a:t>
+                        <a:t>Szatmárnémeti / Satu Mare</a:t>
                       </a:r>
-                      <a:endParaRPr lang="en-US" sz="1150" dirty="0">
+                      <a:endParaRPr lang="en-US" sz="1100" dirty="0">
                         <a:latin typeface="Arial" charset="0"/>
                         <a:ea typeface="Arial" charset="0"/>
                         <a:cs typeface="Arial" charset="0"/>
@@ -7142,7 +7142,7 @@
                         <a:buNone/>
                       </a:pPr>
                       <a:r>
-                        <a:rPr lang="en-US" sz="1150" dirty="0">
+                        <a:rPr lang="en-US" sz="1100" dirty="0">
                           <a:solidFill>
                             <a:srgbClr val="333B44"/>
                           </a:solidFill>
@@ -7150,9 +7150,9 @@
                           <a:ea typeface="Arial" pitchFamily="34" charset="-122"/>
                           <a:cs typeface="Arial" pitchFamily="34" charset="-120"/>
                         </a:rPr>
-                        <a:t>2800 Tatabánya, Szent Borbála tér 1.</a:t>
+                        <a:t>Északi Színház – Harag Gy. Társulat (egyeztetés alatt)</a:t>
                       </a:r>
-                      <a:endParaRPr lang="en-US" sz="1150" dirty="0">
+                      <a:endParaRPr lang="en-US" sz="1100" dirty="0">
                         <a:latin typeface="Arial" charset="0"/>
                         <a:ea typeface="Arial" charset="0"/>
                         <a:cs typeface="Arial" charset="0"/>
@@ -7212,17 +7212,17 @@
                         <a:buNone/>
                       </a:pPr>
                       <a:r>
-                        <a:rPr lang="en-US" sz="1150" dirty="0">
+                        <a:rPr lang="en-US" sz="1100" b="1" dirty="0">
                           <a:solidFill>
-                            <a:srgbClr val="333B44"/>
+                            <a:srgbClr val="237547"/>
                           </a:solidFill>
                           <a:latin typeface="Arial" pitchFamily="34" charset="0"/>
                           <a:ea typeface="Arial" pitchFamily="34" charset="-122"/>
                           <a:cs typeface="Arial" pitchFamily="34" charset="-120"/>
                         </a:rPr>
-                        <a:t>Kaposvár</a:t>
+                        <a:t>VAJDASÁG (RS)</a:t>
                       </a:r>
-                      <a:endParaRPr lang="en-US" sz="1150" dirty="0">
+                      <a:endParaRPr lang="en-US" sz="1100" dirty="0">
                         <a:latin typeface="Arial" charset="0"/>
                         <a:ea typeface="Arial" charset="0"/>
                         <a:cs typeface="Arial" charset="0"/>
@@ -7267,7 +7267,7 @@
                       <a:tailEnd type="none" w="med" len="med"/>
                     </a:lnB>
                     <a:solidFill>
-                      <a:srgbClr val="F4F7FA"/>
+                      <a:srgbClr val="E8F1E9"/>
                     </a:solidFill>
                   </a:tcPr>
                 </a:tc>
@@ -7280,7 +7280,7 @@
                         <a:buNone/>
                       </a:pPr>
                       <a:r>
-                        <a:rPr lang="en-US" sz="1150" dirty="0">
+                        <a:rPr lang="en-US" sz="1100" dirty="0">
                           <a:solidFill>
                             <a:srgbClr val="333B44"/>
                           </a:solidFill>
@@ -7288,9 +7288,9 @@
                           <a:ea typeface="Arial" pitchFamily="34" charset="-122"/>
                           <a:cs typeface="Arial" pitchFamily="34" charset="-120"/>
                         </a:rPr>
-                        <a:t>Együd Árpád Kulturális Központ</a:t>
+                        <a:t>Szabadka / Subotica</a:t>
                       </a:r>
-                      <a:endParaRPr lang="en-US" sz="1150" dirty="0">
+                      <a:endParaRPr lang="en-US" sz="1100" dirty="0">
                         <a:latin typeface="Arial" charset="0"/>
                         <a:ea typeface="Arial" charset="0"/>
                         <a:cs typeface="Arial" charset="0"/>
@@ -7335,7 +7335,7 @@
                       <a:tailEnd type="none" w="med" len="med"/>
                     </a:lnB>
                     <a:solidFill>
-                      <a:srgbClr val="F4F7FA"/>
+                      <a:srgbClr val="E8F1E9"/>
                     </a:solidFill>
                   </a:tcPr>
                 </a:tc>
@@ -7348,7 +7348,7 @@
                         <a:buNone/>
                       </a:pPr>
                       <a:r>
-                        <a:rPr lang="en-US" sz="1150" dirty="0">
+                        <a:rPr lang="en-US" sz="1100" dirty="0">
                           <a:solidFill>
                             <a:srgbClr val="333B44"/>
                           </a:solidFill>
@@ -7356,9 +7356,9 @@
                           <a:ea typeface="Arial" pitchFamily="34" charset="-122"/>
                           <a:cs typeface="Arial" pitchFamily="34" charset="-120"/>
                         </a:rPr>
-                        <a:t>7400 Kaposvár, Nagy Imre tér 2.</a:t>
+                        <a:t>Népkör Magyar Művelődési Központ</a:t>
                       </a:r>
-                      <a:endParaRPr lang="en-US" sz="1150" dirty="0">
+                      <a:endParaRPr lang="en-US" sz="1100" dirty="0">
                         <a:latin typeface="Arial" charset="0"/>
                         <a:ea typeface="Arial" charset="0"/>
                         <a:cs typeface="Arial" charset="0"/>
@@ -7403,7 +7403,7 @@
                       <a:tailEnd type="none" w="med" len="med"/>
                     </a:lnB>
                     <a:solidFill>
-                      <a:srgbClr val="F4F7FA"/>
+                      <a:srgbClr val="E8F1E9"/>
                     </a:solidFill>
                   </a:tcPr>
                 </a:tc>
@@ -7418,17 +7418,17 @@
                         <a:buNone/>
                       </a:pPr>
                       <a:r>
-                        <a:rPr lang="en-US" sz="1150" dirty="0">
+                        <a:rPr lang="en-US" sz="1100" b="1" dirty="0">
                           <a:solidFill>
-                            <a:srgbClr val="333B44"/>
+                            <a:srgbClr val="237547"/>
                           </a:solidFill>
                           <a:latin typeface="Arial" pitchFamily="34" charset="0"/>
                           <a:ea typeface="Arial" pitchFamily="34" charset="-122"/>
                           <a:cs typeface="Arial" pitchFamily="34" charset="-120"/>
                         </a:rPr>
-                        <a:t>Heves térség</a:t>
+                        <a:t>KÁRPÁTALJA (UA)</a:t>
                       </a:r>
-                      <a:endParaRPr lang="en-US" sz="1150" dirty="0">
+                      <a:endParaRPr lang="en-US" sz="1100" dirty="0">
                         <a:latin typeface="Arial" charset="0"/>
                         <a:ea typeface="Arial" charset="0"/>
                         <a:cs typeface="Arial" charset="0"/>
@@ -7486,7 +7486,7 @@
                         <a:buNone/>
                       </a:pPr>
                       <a:r>
-                        <a:rPr lang="en-US" sz="1150" dirty="0">
+                        <a:rPr lang="en-US" sz="1100" dirty="0">
                           <a:solidFill>
                             <a:srgbClr val="333B44"/>
                           </a:solidFill>
@@ -7494,9 +7494,9 @@
                           <a:ea typeface="Arial" pitchFamily="34" charset="-122"/>
                           <a:cs typeface="Arial" pitchFamily="34" charset="-120"/>
                         </a:rPr>
-                        <a:t>helyi művelődési központ (egyeztetés alatt)</a:t>
+                        <a:t>Beregszász / Berehove</a:t>
                       </a:r>
-                      <a:endParaRPr lang="en-US" sz="1150" dirty="0">
+                      <a:endParaRPr lang="en-US" sz="1100" dirty="0">
                         <a:latin typeface="Arial" charset="0"/>
                         <a:ea typeface="Arial" charset="0"/>
                         <a:cs typeface="Arial" charset="0"/>
@@ -7554,7 +7554,7 @@
                         <a:buNone/>
                       </a:pPr>
                       <a:r>
-                        <a:rPr lang="en-US" sz="1150" dirty="0">
+                        <a:rPr lang="en-US" sz="1100" dirty="0">
                           <a:solidFill>
                             <a:srgbClr val="333B44"/>
                           </a:solidFill>
@@ -7562,9 +7562,9 @@
                           <a:ea typeface="Arial" pitchFamily="34" charset="-122"/>
                           <a:cs typeface="Arial" pitchFamily="34" charset="-120"/>
                         </a:rPr>
-                        <a:t>Heves</a:t>
+                        <a:t>Európa–Magyar Ház (cím egyeztetés alatt)</a:t>
                       </a:r>
-                      <a:endParaRPr lang="en-US" sz="1150" dirty="0">
+                      <a:endParaRPr lang="en-US" sz="1100" dirty="0">
                         <a:latin typeface="Arial" charset="0"/>
                         <a:ea typeface="Arial" charset="0"/>
                         <a:cs typeface="Arial" charset="0"/>
@@ -7722,7 +7722,7 @@
                 <a:ea typeface="Arial" pitchFamily="34" charset="-122"/>
                 <a:cs typeface="Arial" pitchFamily="34" charset="-120"/>
               </a:rPr>
-              <a:t>Költségvetés: 71,4 M Ft / 6 hónap</a:t>
+              <a:t>Költségvetés: 72,7 M Ft / 6 hónap</a:t>
             </a:r>
             <a:endParaRPr lang="en-US" sz="3600" dirty="0"/>
           </a:p>
@@ -8003,7 +8003,7 @@
                 <a:ea typeface="Arial" pitchFamily="34" charset="-122"/>
                 <a:cs typeface="Arial" pitchFamily="34" charset="-120"/>
               </a:rPr>
-              <a:t>~23 800 Ft / közvetlenül elért fő</a:t>
+              <a:t>~24 200 Ft / közvetlenül elért fő</a:t>
             </a:r>
             <a:endParaRPr lang="en-US" sz="1300" dirty="0"/>
           </a:p>
@@ -8024,7 +8024,7 @@
                 <a:ea typeface="Arial" pitchFamily="34" charset="-122"/>
                 <a:cs typeface="Arial" pitchFamily="34" charset="-120"/>
               </a:rPr>
-              <a:t>~70 Ft / elérés az online eléréssel együtt</a:t>
+              <a:t>~72 Ft / elérés az online eléréssel együtt</a:t>
             </a:r>
             <a:endParaRPr lang="en-US" sz="1300" dirty="0"/>
           </a:p>
@@ -8042,7 +8042,7 @@
                 <a:ea typeface="Arial" pitchFamily="34" charset="-122"/>
                 <a:cs typeface="Arial" pitchFamily="34" charset="-120"/>
               </a:rPr>
-              <a:t>≈ 178 500 EUR – a tipikus ESF+ projektméret-sávban</a:t>
+              <a:t>≈ 181 650 EUR – a tipikus ESF+ projektméret-sávban</a:t>
             </a:r>
             <a:endParaRPr lang="en-US" sz="1300" dirty="0"/>
           </a:p>
@@ -8152,7 +8152,7 @@
                 <a:ea typeface="Arial" pitchFamily="34" charset="-122"/>
                 <a:cs typeface="Arial" pitchFamily="34" charset="-120"/>
               </a:rPr>
-              <a:t>Finanszírozás: nyitott EU-források</a:t>
+              <a:t>Finanszírozás: nyitott hazai és EU-források</a:t>
             </a:r>
             <a:endParaRPr lang="en-US" sz="3600" dirty="0"/>
           </a:p>
@@ -8296,7 +8296,7 @@
                 <a:ea typeface="Arial" pitchFamily="34" charset="-122"/>
                 <a:cs typeface="Arial" pitchFamily="34" charset="-120"/>
               </a:rPr>
-              <a:t>FŐ PÁLYA</a:t>
+              <a:t>FŐ EU-PÁLYA</a:t>
             </a:r>
             <a:endParaRPr lang="en-US" sz="1100" dirty="0"/>
           </a:p>
@@ -8335,7 +8335,7 @@
                 <a:ea typeface="Arial" pitchFamily="34" charset="-122"/>
                 <a:cs typeface="Arial" pitchFamily="34" charset="-120"/>
               </a:rPr>
-              <a:t>ESF+ · Roma NEETs</a:t>
+              <a:t>ESF+ · Gyermekgarancia + Roma NEETs</a:t>
             </a:r>
             <a:endParaRPr lang="en-US" sz="1700" dirty="0"/>
           </a:p>
@@ -8374,7 +8374,7 @@
                 <a:ea typeface="Arial" pitchFamily="34" charset="-122"/>
                 <a:cs typeface="Arial" pitchFamily="34" charset="-120"/>
               </a:rPr>
-              <a:t>„Strengthening the European Child Guarantee and supporting Roma NEETs” – a Roma NEET-komponens közvetlenül a program célcsoportját támogatja.</a:t>
+              <a:t>Az Európai Gyermekgarancia komponens kifejezetten a rászoruló gyerekeknek nyújtott szolgáltatásokat támogatja (12 M EUR keret) – a FELÚT gyerekfókuszához ez a fő forrás.</a:t>
             </a:r>
             <a:endParaRPr lang="en-US" sz="1250" dirty="0"/>
           </a:p>
@@ -8458,7 +8458,7 @@
             </a:avLst>
           </a:prstGeom>
           <a:solidFill>
-            <a:srgbClr val="1B6CA8"/>
+            <a:srgbClr val="D93025"/>
           </a:solidFill>
           <a:ln/>
         </p:spPr>
@@ -8496,7 +8496,7 @@
                 <a:ea typeface="Arial" pitchFamily="34" charset="-122"/>
                 <a:cs typeface="Arial" pitchFamily="34" charset="-120"/>
               </a:rPr>
-              <a:t>FOLYTATÁS / 2. ÉVAD</a:t>
+              <a:t>MAGYAR FORRÁSOK</a:t>
             </a:r>
             <a:endParaRPr lang="en-US" sz="1100" dirty="0"/>
           </a:p>
@@ -8535,7 +8535,7 @@
                 <a:ea typeface="Arial" pitchFamily="34" charset="-122"/>
                 <a:cs typeface="Arial" pitchFamily="34" charset="-120"/>
               </a:rPr>
-              <a:t>CERV · esélyegyenlőség</a:t>
+              <a:t>Hazai felhívások</a:t>
             </a:r>
             <a:endParaRPr lang="en-US" sz="1700" dirty="0"/>
           </a:p>
@@ -8574,7 +8574,7 @@
                 <a:ea typeface="Arial" pitchFamily="34" charset="-122"/>
                 <a:cs typeface="Arial" pitchFamily="34" charset="-120"/>
               </a:rPr>
-              <a:t>A 2026-os CERV-felhívások (pl. CERV-2026-NRCP, antidiszkrimináció) az önbizalom- és kirekesztés-ellenes pillérre illeszkednek.</a:t>
+              <a:t>EFOP+ Tanoda-pályázatok (5,5 Mrd Ft keret) · BM roma nemzetiségi felhívások (770 M Ft: tábor, kultúra) · EFOP+ 3.3.3-25 roma lányok tanulmányi támogatása.</a:t>
             </a:r>
             <a:endParaRPr lang="en-US" sz="1250" dirty="0"/>
           </a:p>
@@ -8613,7 +8613,7 @@
                 <a:ea typeface="Arial" pitchFamily="34" charset="-122"/>
                 <a:cs typeface="Arial" pitchFamily="34" charset="-120"/>
               </a:rPr>
-              <a:t>Folyamatosan nyíló felhívások</a:t>
+              <a:t>Tanoda-beadás: 2026. október 30-tól</a:t>
             </a:r>
             <a:endParaRPr lang="en-US" sz="1250" dirty="0"/>
           </a:p>
@@ -8696,7 +8696,7 @@
                 <a:ea typeface="Arial" pitchFamily="34" charset="-122"/>
                 <a:cs typeface="Arial" pitchFamily="34" charset="-120"/>
               </a:rPr>
-              <a:t>KIEGÉSZÍTŐ</a:t>
+              <a:t>BGA + ERASMUS+</a:t>
             </a:r>
             <a:endParaRPr lang="en-US" sz="1100" dirty="0"/>
           </a:p>
@@ -8735,7 +8735,7 @@
                 <a:ea typeface="Arial" pitchFamily="34" charset="-122"/>
                 <a:cs typeface="Arial" pitchFamily="34" charset="-120"/>
               </a:rPr>
-              <a:t>ROVA · Roma for Change</a:t>
+              <a:t>Határon túli források</a:t>
             </a:r>
             <a:endParaRPr lang="en-US" sz="1700" dirty="0"/>
           </a:p>
@@ -8774,7 +8774,7 @@
                 <a:ea typeface="Arial" pitchFamily="34" charset="-122"/>
                 <a:cs typeface="Arial" pitchFamily="34" charset="-120"/>
               </a:rPr>
-              <a:t>Magyarországi roma és pro-roma civil szervezetek kisprojektjei – a kommunikációs modul társfinanszírozására.</a:t>
+              <a:t>A 6 határon túli alkalom helyi költségeire a társrendező magyar intézmények Bethlen Gábor Alap-pályázatai (500e–2M Ft/szervezet); SK/RO helyszínekre Erasmus+ és CERV is.</a:t>
             </a:r>
             <a:endParaRPr lang="en-US" sz="1250" dirty="0"/>
           </a:p>
@@ -8813,7 +8813,7 @@
                 <a:ea typeface="Arial" pitchFamily="34" charset="-122"/>
                 <a:cs typeface="Arial" pitchFamily="34" charset="-120"/>
               </a:rPr>
-              <a:t>Max. 25 000 EUR / projekt, 13 hónap</a:t>
+              <a:t>BGA: NIR-en, éves kiírások</a:t>
             </a:r>
             <a:endParaRPr lang="en-US" sz="1250" dirty="0"/>
           </a:p>
@@ -8888,7 +8888,7 @@
                 <a:ea typeface="Arial" pitchFamily="34" charset="-122"/>
                 <a:cs typeface="Arial" pitchFamily="34" charset="-120"/>
               </a:rPr>
-              <a:t>90% EU-s támogatás (~64,3 M Ft) + 10% önerő / vállalati CSR-szponzoráció (~7,1 M Ft). </a:t>
+              <a:t>90% pályázati támogatás (~65,4 M Ft) + 10% önerő / CSR-szponzoráció (~7,3 M Ft). </a:t>
             </a:r>
             <a:pPr indent="0" marL="0">
               <a:buNone/>
@@ -8902,7 +8902,7 @@
                 <a:ea typeface="Arial" pitchFamily="34" charset="-122"/>
                 <a:cs typeface="Arial" pitchFamily="34" charset="-120"/>
               </a:rPr>
-              <a:t>A helyszíneket az önkormányzatok kedvezményesen biztosítják.</a:t>
+              <a:t>Kiegészítés: ROVA – Roma for Change (max. 25 000 EUR) a kommunikációs modulra.</a:t>
             </a:r>
             <a:endParaRPr lang="en-US" sz="1500" dirty="0"/>
           </a:p>
@@ -9173,7 +9173,7 @@
                 <a:ea typeface="Arial" pitchFamily="34" charset="-122"/>
                 <a:cs typeface="Arial" pitchFamily="34" charset="-120"/>
               </a:rPr>
-              <a:t>közvetlen résztvevő a 12 helyszínen</a:t>
+              <a:t>elért gyerek és családtag a 12 helyszínen</a:t>
             </a:r>
             <a:endParaRPr lang="en-US" sz="1300" dirty="0"/>
           </a:p>
@@ -10743,7 +10743,7 @@
                 <a:ea typeface="Arial" pitchFamily="34" charset="-122"/>
                 <a:cs typeface="Arial" pitchFamily="34" charset="-120"/>
               </a:rPr>
-              <a:t>Pályázat beadása az ESF+ Roma NEETs felhívásra 2026. szeptember 30-ig</a:t>
+              <a:t>ESF+ pályázat beadása 2026. szeptember 30-ig, EFOP+ Tanoda-pályázat október 30-tól</a:t>
             </a:r>
             <a:endParaRPr lang="en-US" sz="1600" dirty="0"/>
           </a:p>
@@ -10782,7 +10782,7 @@
                 <a:ea typeface="Arial" pitchFamily="34" charset="-122"/>
                 <a:cs typeface="Arial" pitchFamily="34" charset="-120"/>
               </a:rPr>
-              <a:t>Helyszín-előfoglalás a 12 kulturális központban</a:t>
+              <a:t>Helyszín-egyeztetés a 6 hazai és 6 határon túli közösségi intézménnyel (BGA-pályázatokkal)</a:t>
             </a:r>
             <a:endParaRPr lang="en-US" sz="1600" dirty="0"/>
           </a:p>
@@ -11310,7 +11310,7 @@
                 <a:ea typeface="Arial" pitchFamily="34" charset="-122"/>
                 <a:cs typeface="Arial" pitchFamily="34" charset="-120"/>
               </a:rPr>
-              <a:t>A FELÚT modell: 6 hónap, 12 alkalom, 12 közösségi ház – L.L. Junior nagykövettel.</a:t>
+              <a:t>A FELÚT modell: 6 hónap, 12 alkalom, 6 hazai + 6 határon túli helyszín – L.L. Junior nagykövettel.</a:t>
             </a:r>
             <a:endParaRPr lang="en-US" sz="1350" dirty="0"/>
           </a:p>
@@ -11469,7 +11469,7 @@
                 <a:ea typeface="Arial" pitchFamily="34" charset="-122"/>
                 <a:cs typeface="Arial" pitchFamily="34" charset="-120"/>
               </a:rPr>
-              <a:t>Költségvetés, nyitott EU-források, várt eredmények, ütemterv – és a mai döntési javaslat.</a:t>
+              <a:t>Költségvetés, nyitott hazai és EU-források, várt eredmények, ütemterv – és a mai döntési javaslat.</a:t>
             </a:r>
             <a:endParaRPr lang="en-US" sz="1350" dirty="0"/>
           </a:p>
@@ -11718,7 +11718,7 @@
                 <a:ea typeface="Arial" pitchFamily="34" charset="-122"/>
                 <a:cs typeface="Arial" pitchFamily="34" charset="-120"/>
               </a:rPr>
-              <a:t>A hátrányos helyzetű roma közösségeket három lefelé húzó erő fenyegeti: a drog, az uzsora és a korai iskolaelhagyás. A tartós kirekesztés a legfontosabb erőforrást rombolja le: az önbizalmat. A hagyományos szociálpolitikai eszközök gyakran nem érik el a célcsoportot – hiteles hangra van szükség, amelyre a közösség valóban odafigyel.</a:t>
+              <a:t>A hátrányos helyzetű roma gyerekeket három lefelé húzó erő fenyegeti – és mindhárom már gyerekkorban támad: a drog, az uzsora és a korai iskolaelhagyás. A tartós kirekesztés a legfontosabb erőforrást rombolja le: az önbizalmat. A hagyományos eszközök gyakran nem érik el a gyerekeket és családjaikat – hiteles hangra van szükség, amelyre valóban odafigyelnek.</a:t>
             </a:r>
             <a:endParaRPr lang="en-US" sz="1600" dirty="0"/>
           </a:p>
@@ -14405,7 +14405,7 @@
                 <a:ea typeface="Arial" pitchFamily="34" charset="-122"/>
                 <a:cs typeface="Arial" pitchFamily="34" charset="-120"/>
               </a:rPr>
-              <a:t>Megbélyegzettség az iskolában, a munkaerőpiacon, a hétköznapokban. A fiatal előbb adja fel, mint hogy először próbálkozna.</a:t>
+              <a:t>Megbélyegzettség az iskolában és a hétköznapokban. A gyerek előbb adja fel, mint hogy először próbálkozna.</a:t>
             </a:r>
             <a:endParaRPr lang="en-US" sz="1300" dirty="0"/>
           </a:p>
@@ -14807,7 +14807,7 @@
               <a:buNone/>
             </a:pPr>
             <a:r>
-              <a:rPr lang="en-US" sz="2200" i="1" dirty="0">
+              <a:rPr lang="en-US" sz="2100" i="1" dirty="0">
                 <a:solidFill>
                   <a:srgbClr val="1B6CA8"/>
                 </a:solidFill>
@@ -14815,9 +14815,9 @@
                 <a:ea typeface="Arial" pitchFamily="34" charset="-122"/>
                 <a:cs typeface="Arial" pitchFamily="34" charset="-120"/>
               </a:rPr>
-              <a:t>Hat hónapon át, kéthetente, 12 városban L.L. Junior a helyi közösségi házakban személyesen mutatja meg a roma fiataloknak, hogyan kerülhetők el a drog, az uzsora és az iskolaelhagyás csapdái – és hogy honnan hová lehet eljutni romaként.</a:t>
-            </a:r>
-            <a:endParaRPr lang="en-US" sz="2200" dirty="0"/>
+              <a:t>Hat hónapon át, kéthetente, 6 hazai és 6 határon túli városban L.L. Junior a helyi közösségi házakban személyesen mutatja meg a roma gyerekeknek és családjaiknak, hogyan kerülhetők el a drog, az uzsora és az iskolaelhagyás csapdái – és hogy honnan hová lehet eljutni romaként.</a:t>
+            </a:r>
+            <a:endParaRPr lang="en-US" sz="2100" dirty="0"/>
           </a:p>
         </p:txBody>
       </p:sp>
@@ -15076,7 +15076,7 @@
                 <a:ea typeface="Arial" pitchFamily="34" charset="-122"/>
                 <a:cs typeface="Arial" pitchFamily="34" charset="-120"/>
               </a:rPr>
-              <a:t>12</a:t>
+              <a:t>6+6</a:t>
             </a:r>
             <a:endParaRPr lang="en-US" sz="4800" dirty="0"/>
           </a:p>
@@ -15115,7 +15115,7 @@
                 <a:ea typeface="Arial" pitchFamily="34" charset="-122"/>
                 <a:cs typeface="Arial" pitchFamily="34" charset="-120"/>
               </a:rPr>
-              <a:t>város és közösségi ház</a:t>
+              <a:t>hazai és határon túli helyszín</a:t>
             </a:r>
             <a:endParaRPr lang="en-US" sz="1400" dirty="0"/>
           </a:p>
@@ -15215,7 +15215,7 @@
                 <a:ea typeface="Arial" pitchFamily="34" charset="-122"/>
                 <a:cs typeface="Arial" pitchFamily="34" charset="-120"/>
               </a:rPr>
-              <a:t>közvetlenül elért résztvevő</a:t>
+              <a:t>elért gyerek és családtag</a:t>
             </a:r>
             <a:endParaRPr lang="en-US" sz="1400" dirty="0"/>
           </a:p>
@@ -15517,7 +15517,7 @@
                 <a:ea typeface="Arial" pitchFamily="34" charset="-122"/>
                 <a:cs typeface="Arial" pitchFamily="34" charset="-120"/>
               </a:rPr>
-              <a:t>Zenéje pontosan a legveszélyeztetettebb korosztályt (12–25 év) éri el, roma és nem roma fiatalok körében egyaránt. </a:t>
+              <a:t>Zenéjét a roma gyerekek és tizenévesek is ismerik és szeretik – pontosan azt a korosztályt éri el, amelyet a program véd. </a:t>
             </a:r>
             <a:pPr indent="0" marL="0">
               <a:buNone/>

</xml_diff>

<commit_message>
Költségvetés kivéve a prezentációból (külön egyeztetés), nézettség 600 M+
Co-Authored-By: Claude Fable 5 <noreply@anthropic.com>
Claude-Session: https://claude.ai/code/session_01NZWQf1ukuiw862VxFPR9wy
</commit_message>
<xml_diff>
--- a/eu-roma-program/prezentacio/FELUT_EU_Roma_Felzarkoztatasi_Program.pptx
+++ b/eu-roma-program/prezentacio/FELUT_EU_Roma_Felzarkoztatasi_Program.pptx
@@ -21,10 +21,9 @@
     <p:sldId id="269" r:id="rId15"/>
     <p:sldId id="270" r:id="rId16"/>
     <p:sldId id="271" r:id="rId17"/>
-    <p:sldId id="272" r:id="rId18"/>
   </p:sldIdLst>
   <p:notesMasterIdLst>
-    <p:notesMasterId r:id="rId19"/>
+    <p:notesMasterId r:id="rId18"/>
   </p:notesMasterIdLst>
   <p:sldSz cx="12192000" cy="6858000"/>
   <p:notesSz cx="6858000" cy="12192000"/>
@@ -121,288 +120,6 @@
     </a:lvl9pPr>
   </p:defaultTextStyle>
 </p:presentation>
-</file>
-
-<file path=ppt/charts/chart1.xml><?xml version="1.0" encoding="utf-8"?>
-<c:chartSpace xmlns:c="http://schemas.openxmlformats.org/drawingml/2006/chart" xmlns:a="http://schemas.openxmlformats.org/drawingml/2006/main" xmlns:r="http://schemas.openxmlformats.org/officeDocument/2006/relationships">
-  <c:date1904 val="0"/>
-  <c:roundedCorners val="1"/>
-  <c:chart>
-    <c:autoTitleDeleted val="1"/>
-    <c:plotArea>
-      <c:layout/>
-      <c:barChart>
-        <c:barDir val="bar"/>
-        <c:grouping val="clustered"/>
-        <c:varyColors val="0"/>
-        <c:ser>
-          <c:idx val="0"/>
-          <c:order val="0"/>
-          <c:tx>
-            <c:strRef>
-              <c:f>Sheet1!$B$1</c:f>
-              <c:strCache>
-                <c:ptCount val="1"/>
-                <c:pt idx="0">
-                  <c:v>Költség (M Ft)</c:v>
-                </c:pt>
-              </c:strCache>
-            </c:strRef>
-          </c:tx>
-          <c:spPr>
-            <a:solidFill>
-              <a:srgbClr val="1B6CA8"/>
-            </a:solidFill>
-            <a:effectLst/>
-          </c:spPr>
-          <c:invertIfNegative val="0"/>
-          <c:dLbls>
-            <c:numFmt formatCode="0.0" sourceLinked="0"/>
-            <c:txPr>
-              <a:bodyPr/>
-              <a:lstStyle/>
-              <a:p>
-                <a:pPr>
-                  <a:defRPr b="0" i="0" strike="noStrike" sz="1000" u="none">
-                    <a:solidFill>
-                      <a:srgbClr val="1E3A5F"/>
-                    </a:solidFill>
-                    <a:latin typeface="Arial"/>
-                  </a:defRPr>
-                </a:pPr>
-              </a:p>
-            </c:txPr>
-            <c:showLegendKey val="0"/>
-            <c:showVal val="1"/>
-            <c:showCatName val="0"/>
-            <c:showSerName val="0"/>
-            <c:showPercent val="0"/>
-            <c:showBubbleSize val="0"/>
-            <c:showLeaderLines val="0"/>
-          </c:dLbls>
-          <c:cat>
-            <c:multiLvlStrRef>
-              <c:f>Sheet1!$A$2:$A$11</c:f>
-              <c:multiLvlStrCache>
-                <c:ptCount val="10"/>
-                <c:lvl>
-                  <c:pt idx="0">
-                    <c:v>Nagyköveti díj (12×3,5 M)</c:v>
-                  </c:pt>
-                  <c:pt idx="1">
-                    <c:v>Kommunikáció, videó</c:v>
-                  </c:pt>
-                  <c:pt idx="2">
-                    <c:v>Technika (hang, fény)</c:v>
-                  </c:pt>
-                  <c:pt idx="3">
-                    <c:v>Projektmenedzsment</c:v>
-                  </c:pt>
-                  <c:pt idx="4">
-                    <c:v>Utazás, szállás (határon túli)</c:v>
-                  </c:pt>
-                  <c:pt idx="5">
-                    <c:v>Tartalék (5%)</c:v>
-                  </c:pt>
-                  <c:pt idx="6">
-                    <c:v>Helyszín, szervezés</c:v>
-                  </c:pt>
-                  <c:pt idx="7">
-                    <c:v>Monitoring, hatásmérés</c:v>
-                  </c:pt>
-                  <c:pt idx="8">
-                    <c:v>Szakértői díjak</c:v>
-                  </c:pt>
-                  <c:pt idx="9">
-                    <c:v>Arculat, kreatív</c:v>
-                  </c:pt>
-                </c:lvl>
-              </c:multiLvlStrCache>
-            </c:multiLvlStrRef>
-          </c:cat>
-          <c:val>
-            <c:numRef>
-              <c:f>Sheet1!$B$2:$B$11</c:f>
-              <c:numCache>
-                <c:formatCode>General</c:formatCode>
-                <c:ptCount val="10"/>
-                <c:pt idx="0">
-                  <c:v>42</c:v>
-                </c:pt>
-                <c:pt idx="1">
-                  <c:v>6</c:v>
-                </c:pt>
-                <c:pt idx="2">
-                  <c:v>4.8</c:v>
-                </c:pt>
-                <c:pt idx="3">
-                  <c:v>4.5</c:v>
-                </c:pt>
-                <c:pt idx="4">
-                  <c:v>3.6</c:v>
-                </c:pt>
-                <c:pt idx="5">
-                  <c:v>3.5</c:v>
-                </c:pt>
-                <c:pt idx="6">
-                  <c:v>3</c:v>
-                </c:pt>
-                <c:pt idx="7">
-                  <c:v>2</c:v>
-                </c:pt>
-                <c:pt idx="8">
-                  <c:v>1.8</c:v>
-                </c:pt>
-                <c:pt idx="9">
-                  <c:v>1.5</c:v>
-                </c:pt>
-              </c:numCache>
-            </c:numRef>
-          </c:val>
-        </c:ser>
-        <c:dLbls>
-          <c:numFmt formatCode="0.0" sourceLinked="0"/>
-          <c:txPr>
-            <a:bodyPr/>
-            <a:lstStyle/>
-            <a:p>
-              <a:pPr>
-                <a:defRPr b="0" i="0" strike="noStrike" sz="1000" u="none">
-                  <a:solidFill>
-                    <a:srgbClr val="1E3A5F"/>
-                  </a:solidFill>
-                  <a:latin typeface="Arial"/>
-                </a:defRPr>
-              </a:pPr>
-            </a:p>
-          </c:txPr>
-          <c:showLegendKey val="0"/>
-          <c:showVal val="1"/>
-          <c:showCatName val="0"/>
-          <c:showSerName val="0"/>
-          <c:showPercent val="0"/>
-          <c:showBubbleSize val="0"/>
-          <c:showLeaderLines val="0"/>
-        </c:dLbls>
-        <c:gapWidth val="150"/>
-        <c:overlap val="0"/>
-        <c:axId val="2094734554"/>
-        <c:axId val="2094734552"/>
-        <c:axId val="2094734556"/>
-      </c:barChart>
-      <c:catAx>
-        <c:axId val="2094734554"/>
-        <c:scaling>
-          <c:orientation val="minMax"/>
-        </c:scaling>
-        <c:delete val="0"/>
-        <c:axPos val="l"/>
-        <c:numFmt formatCode="General" sourceLinked="1"/>
-        <c:majorTickMark val="out"/>
-        <c:minorTickMark val="none"/>
-        <c:tickLblPos val="nextTo"/>
-        <c:spPr>
-          <a:ln w="12700" cap="flat">
-            <a:solidFill>
-              <a:srgbClr val="888888"/>
-            </a:solidFill>
-            <a:prstDash val="solid"/>
-            <a:round/>
-          </a:ln>
-        </c:spPr>
-        <c:txPr>
-          <a:bodyPr/>
-          <a:lstStyle/>
-          <a:p>
-            <a:pPr>
-              <a:defRPr sz="1000" b="0" i="0" u="none" strike="noStrike">
-                <a:solidFill>
-                  <a:srgbClr val="1E3A5F"/>
-                </a:solidFill>
-                <a:latin typeface="Arial"/>
-              </a:defRPr>
-            </a:pPr>
-            <a:endParaRPr lang="en-US"/>
-          </a:p>
-        </c:txPr>
-        <c:crossAx val="2094734552"/>
-        <c:crosses val="autoZero"/>
-        <c:auto val="1"/>
-        <c:lblAlgn val="ctr"/>
-        <c:noMultiLvlLbl val="1"/>
-      </c:catAx>
-      <c:valAx>
-        <c:axId val="2094734552"/>
-        <c:scaling>
-          <c:orientation val="minMax"/>
-        </c:scaling>
-        <c:delete val="0"/>
-        <c:axPos val="b"/>
-        <c:majorGridlines>
-          <c:spPr>
-            <a:ln w="6350" cap="flat">
-              <a:solidFill>
-                <a:srgbClr val="E4EAF0"/>
-              </a:solidFill>
-              <a:prstDash val="solid"/>
-              <a:round/>
-            </a:ln>
-          </c:spPr>
-        </c:majorGridlines>
-        <c:numFmt formatCode="General" sourceLinked="0"/>
-        <c:majorTickMark val="out"/>
-        <c:minorTickMark val="none"/>
-        <c:tickLblPos val="low"/>
-        <c:spPr>
-          <a:ln w="12700" cap="flat">
-            <a:solidFill>
-              <a:srgbClr val="888888"/>
-            </a:solidFill>
-            <a:prstDash val="solid"/>
-            <a:round/>
-          </a:ln>
-        </c:spPr>
-        <c:txPr>
-          <a:bodyPr/>
-          <a:lstStyle/>
-          <a:p>
-            <a:pPr>
-              <a:defRPr sz="900" b="0" i="0" u="none" strike="noStrike">
-                <a:solidFill>
-                  <a:srgbClr val="5B6770"/>
-                </a:solidFill>
-                <a:latin typeface="Arial"/>
-              </a:defRPr>
-            </a:pPr>
-            <a:endParaRPr lang="en-US"/>
-          </a:p>
-        </c:txPr>
-        <c:crossAx val="2094734554"/>
-        <c:crosses val="autoZero"/>
-        <c:crossBetween val="between"/>
-      </c:valAx>
-      <c:spPr>
-        <a:noFill/>
-        <a:ln>
-          <a:noFill/>
-        </a:ln>
-        <a:effectLst/>
-      </c:spPr>
-    </c:plotArea>
-    <c:plotVisOnly val="1"/>
-    <c:dispBlanksAs val="span"/>
-  </c:chart>
-  <c:spPr>
-    <a:noFill/>
-    <a:ln>
-      <a:noFill/>
-    </a:ln>
-    <a:effectLst/>
-  </c:spPr>
-  <c:externalData r:id="rId1">
-    <c:autoUpdate val="0"/>
-  </c:externalData>
-</c:chartSpace>
 </file>
 
 <file path=ppt/notesMasters/notesMaster1.xml><?xml version="1.0" encoding="utf-8"?>
@@ -1152,7 +869,7 @@
           <a:p>
             <a:r>
               <a:rPr lang="en-US" dirty="0"/>
-              <a:t>KB. 2,5 PERC – A nagyköveti díj a költségvetés legnagyobb tétele, és ezt nyíltan vállaljuk: a 3,5 M Ft/alkalom a kieső kereskedelmi fellépések ellentételezése, cserébe teljes napos jelenlét + médiafeladatok. A megemelt utazási sor a 6 határon túli alkalom többlet-útiköltségét fedezi. A fajlagos mutató a döntéshozói kulcsszám: ~72 Ft/elérés az online eléréssel együtt.</a:t>
+              <a:t>KB. 2 PERC – Három pillér: (1) ESF+ Gyermekgarancia/Roma NEETs, beadás szeptember 30-ig – ezért sürgős a döntés. (2) Hazai: az EFOP+ Tanoda-felhívás október 30-tól beadható, 5,5 Mrd Ft kerettel; a BM roma nemzetiségi felhívásai (770 M Ft) a tábor- és kulturális elemekhez. (3) A határon túli alkalmakat a helyi társrendezők BGA-pályázatai fedezik; a szerb és ukrán helyszín EU-forrásból közvetlenül nem finanszírozható, ott a BGA a járható út.</a:t>
             </a:r>
             <a:endParaRPr lang="en-US" dirty="0"/>
           </a:p>
@@ -1240,7 +957,7 @@
           <a:p>
             <a:r>
               <a:rPr lang="en-US" dirty="0"/>
-              <a:t>KB. 2 PERC – Három pillér: (1) ESF+ Gyermekgarancia/Roma NEETs, beadás szeptember 30-ig – ezért sürgős a döntés. (2) Hazai: az EFOP+ Tanoda-felhívás október 30-tól beadható, 5,5 Mrd Ft kerettel; a BM roma nemzetiségi felhívásai (770 M Ft) a tábor- és kulturális elemekhez. (3) A határon túli alkalmakat a helyi társrendezők BGA-pályázatai fedezik; a szerb és ukrán helyszín EU-forrásból közvetlenül nem finanszírozható, ott a BGA a járható út.</a:t>
+              <a:t>KB. 2 PERC – A KPI-k mérhetők és vállalhatók: részvétel, online elérés, ismeretszint-mérés, partnerségek. A SROI-érv a zárómondat: 2% érdemi fordulat már „nullára hozza” a programot társadalmi szinten.</a:t>
             </a:r>
             <a:endParaRPr lang="en-US" dirty="0"/>
           </a:p>
@@ -1328,7 +1045,7 @@
           <a:p>
             <a:r>
               <a:rPr lang="en-US" dirty="0"/>
-              <a:t>KB. 2 PERC – A KPI-k mérhetők és vállalhatók: részvétel, online elérés, ismeretszint-mérés, partnerségek. A SROI-érv a zárómondat: 2% érdemi fordulat már „nullára hozza” a programot társadalmi szinten.</a:t>
+              <a:t>KB. 1,5 PERC – Az ütemterv a pályázati naptárhoz igazodik. A kockázatlista rövid, de őszinte: mind a négy kockázatnak van kezelési terve, és mindegyik szerződéses vagy szervezési eszközzel kezelhető.</a:t>
             </a:r>
             <a:endParaRPr lang="en-US" dirty="0"/>
           </a:p>
@@ -1416,7 +1133,7 @@
           <a:p>
             <a:r>
               <a:rPr lang="en-US" dirty="0"/>
-              <a:t>KB. 1,5 PERC – Az ütemterv a pályázati naptárhoz igazodik. A kockázatlista rövid, de őszinte: mind a négy kockázatnak van kezelési terve, és mindegyik szerződéses vagy szervezési eszközzel kezelhető.</a:t>
+              <a:t>KB. 1 PERC + KÉRDÉSEK – Zárás a szlogennel és a három konkrét döntési ponttal. Ezután kérdések. Teljes előadás: kb. 30 perc, kérdésekkel együtt 40-45 perc.</a:t>
             </a:r>
             <a:endParaRPr lang="en-US" dirty="0"/>
           </a:p>
@@ -1440,94 +1157,6 @@
             <a:fld id="{F7021451-1387-4CA6-816F-3879F97B5CBC}" type="slidenum">
               <a:rPr lang="en-US"/>
               <a:t>16</a:t>
-            </a:fld>
-            <a:endParaRPr lang="en-US"/>
-          </a:p>
-        </p:txBody>
-      </p:sp>
-    </p:spTree>
-    <p:extLst>
-      <p:ext uri="{BB962C8B-B14F-4D97-AF65-F5344CB8AC3E}">
-        <p14:creationId xmlns:p14="http://schemas.microsoft.com/office/powerpoint/2010/main" val="1024086991"/>
-      </p:ext>
-    </p:extLst>
-  </p:cSld>
-  <p:clrMapOvr>
-    <a:masterClrMapping/>
-  </p:clrMapOvr>
-</p:notes>
-</file>
-
-<file path=ppt/notesSlides/notesSlide17.xml><?xml version="1.0" encoding="utf-8"?>
-<p:notes xmlns:a="http://schemas.openxmlformats.org/drawingml/2006/main" xmlns:r="http://schemas.openxmlformats.org/officeDocument/2006/relationships" xmlns:p="http://schemas.openxmlformats.org/presentationml/2006/main">
-  <p:cSld>
-    <p:spTree>
-      <p:nvGrpSpPr>
-        <p:cNvPr id="1" name=""/>
-        <p:cNvGrpSpPr/>
-        <p:nvPr/>
-      </p:nvGrpSpPr>
-      <p:grpSpPr>
-        <a:xfrm>
-          <a:off x="0" y="0"/>
-          <a:ext cx="0" cy="0"/>
-          <a:chOff x="0" y="0"/>
-          <a:chExt cx="0" cy="0"/>
-        </a:xfrm>
-      </p:grpSpPr>
-      <p:sp>
-        <p:nvSpPr>
-          <p:cNvPr id="2" name="Slide Image Placeholder 1"/>
-          <p:cNvSpPr>
-            <a:spLocks noGrp="1" noRot="1" noChangeAspect="1"/>
-          </p:cNvSpPr>
-          <p:nvPr>
-            <p:ph type="sldImg"/>
-          </p:nvPr>
-        </p:nvSpPr>
-        <p:spPr/>
-      </p:sp>
-      <p:sp>
-        <p:nvSpPr>
-          <p:cNvPr id="3" name="Notes Placeholder 2"/>
-          <p:cNvSpPr>
-            <a:spLocks noGrp="1"/>
-          </p:cNvSpPr>
-          <p:nvPr>
-            <p:ph type="body" idx="1"/>
-          </p:nvPr>
-        </p:nvSpPr>
-        <p:spPr/>
-        <p:txBody>
-          <a:bodyPr/>
-          <a:lstStyle/>
-          <a:p>
-            <a:r>
-              <a:rPr lang="en-US" dirty="0"/>
-              <a:t>KB. 1 PERC + KÉRDÉSEK – Zárás a szlogennel és a három konkrét döntési ponttal. Ezután kérdések. Teljes előadás: kb. 30 perc, kérdésekkel együtt 40-45 perc.</a:t>
-            </a:r>
-            <a:endParaRPr lang="en-US" dirty="0"/>
-          </a:p>
-        </p:txBody>
-      </p:sp>
-      <p:sp>
-        <p:nvSpPr>
-          <p:cNvPr id="4" name="Slide Number Placeholder 3"/>
-          <p:cNvSpPr>
-            <a:spLocks noGrp="1"/>
-          </p:cNvSpPr>
-          <p:nvPr>
-            <p:ph type="sldNum" sz="quarter" idx="10"/>
-          </p:nvPr>
-        </p:nvSpPr>
-        <p:spPr/>
-        <p:txBody>
-          <a:bodyPr/>
-          <a:lstStyle/>
-          <a:p>
-            <a:fld id="{F7021451-1387-4CA6-816F-3879F97B5CBC}" type="slidenum">
-              <a:rPr lang="en-US"/>
-              <a:t>17</a:t>
             </a:fld>
             <a:endParaRPr lang="en-US"/>
           </a:p>
@@ -7722,7 +7351,7 @@
                 <a:ea typeface="Arial" pitchFamily="34" charset="-122"/>
                 <a:cs typeface="Arial" pitchFamily="34" charset="-120"/>
               </a:rPr>
-              <a:t>Költségvetés: 72,7 M Ft / 6 hónap</a:t>
+              <a:t>Finanszírozás: nyitott hazai és EU-források</a:t>
             </a:r>
             <a:endParaRPr lang="en-US" sz="3600" dirty="0"/>
           </a:p>
@@ -7783,42 +7412,48 @@
                 <a:ea typeface="Arial" pitchFamily="34" charset="-122"/>
                 <a:cs typeface="Arial" pitchFamily="34" charset="-120"/>
               </a:rPr>
-              <a:t>~2,5′</a:t>
+              <a:t>~2′</a:t>
             </a:r>
             <a:endParaRPr lang="en-US" sz="1300" dirty="0"/>
           </a:p>
         </p:txBody>
       </p:sp>
-      <p:graphicFrame>
-        <p:nvGraphicFramePr>
-          <p:cNvPr id="5" name="Chart 0" descr=""/>
-          <p:cNvGraphicFramePr/>
-          <p:nvPr/>
-        </p:nvGraphicFramePr>
-        <p:xfrm>
-          <a:off x="457200" y="1280160"/>
-          <a:ext cx="6949440" cy="4846320"/>
-        </p:xfrm>
-        <a:graphic xmlns:a="http://schemas.openxmlformats.org/drawingml/2006/main">
-          <a:graphicData uri="http://schemas.openxmlformats.org/drawingml/2006/chart">
-            <c:chart xmlns:c="http://schemas.openxmlformats.org/drawingml/2006/chart" r:id="rId1"/>
-          </a:graphicData>
-        </a:graphic>
-      </p:graphicFrame>
-      <p:sp>
-        <p:nvSpPr>
-          <p:cNvPr id="6" name="Shape 3"/>
-          <p:cNvSpPr/>
-          <p:nvPr/>
-        </p:nvSpPr>
-        <p:spPr>
-          <a:xfrm>
-            <a:off x="7772400" y="1280160"/>
-            <a:ext cx="3931920" cy="2103120"/>
+      <p:sp>
+        <p:nvSpPr>
+          <p:cNvPr id="5" name="Shape 3"/>
+          <p:cNvSpPr/>
+          <p:nvPr/>
+        </p:nvSpPr>
+        <p:spPr>
+          <a:xfrm>
+            <a:off x="457200" y="1325880"/>
+            <a:ext cx="3566160" cy="3383280"/>
           </a:xfrm>
           <a:prstGeom prst="roundRect">
             <a:avLst>
-              <a:gd name="adj" fmla="val 5217"/>
+              <a:gd name="adj" fmla="val 3243"/>
+            </a:avLst>
+          </a:prstGeom>
+          <a:solidFill>
+            <a:srgbClr val="F4F7FA"/>
+          </a:solidFill>
+          <a:ln/>
+        </p:spPr>
+      </p:sp>
+      <p:sp>
+        <p:nvSpPr>
+          <p:cNvPr id="6" name="Shape 4"/>
+          <p:cNvSpPr/>
+          <p:nvPr/>
+        </p:nvSpPr>
+        <p:spPr>
+          <a:xfrm>
+            <a:off x="731520" y="1600200"/>
+            <a:ext cx="1920240" cy="384048"/>
+          </a:xfrm>
+          <a:prstGeom prst="roundRect">
+            <a:avLst>
+              <a:gd name="adj" fmla="val 19048"/>
             </a:avLst>
           </a:prstGeom>
           <a:solidFill>
@@ -7829,14 +7464,53 @@
       </p:sp>
       <p:sp>
         <p:nvSpPr>
-          <p:cNvPr id="7" name="Text 4"/>
-          <p:cNvSpPr/>
-          <p:nvPr/>
-        </p:nvSpPr>
-        <p:spPr>
-          <a:xfrm>
-            <a:off x="8046720" y="1463040"/>
-            <a:ext cx="3383280" cy="548640"/>
+          <p:cNvPr id="7" name="Text 5"/>
+          <p:cNvSpPr/>
+          <p:nvPr/>
+        </p:nvSpPr>
+        <p:spPr>
+          <a:xfrm>
+            <a:off x="731520" y="1600200"/>
+            <a:ext cx="1920240" cy="384048"/>
+          </a:xfrm>
+          <a:prstGeom prst="rect">
+            <a:avLst/>
+          </a:prstGeom>
+          <a:noFill/>
+          <a:ln/>
+        </p:spPr>
+        <p:txBody>
+          <a:bodyPr wrap="square" lIns="0" tIns="0" rIns="0" bIns="0" rtlCol="0" anchor="ctr"/>
+          <a:lstStyle/>
+          <a:p>
+            <a:pPr algn="ctr" indent="0" marL="0">
+              <a:buNone/>
+            </a:pPr>
+            <a:r>
+              <a:rPr lang="en-US" sz="1100" b="1" dirty="0">
+                <a:solidFill>
+                  <a:srgbClr val="FFFFFF"/>
+                </a:solidFill>
+                <a:latin typeface="Arial" pitchFamily="34" charset="0"/>
+                <a:ea typeface="Arial" pitchFamily="34" charset="-122"/>
+                <a:cs typeface="Arial" pitchFamily="34" charset="-120"/>
+              </a:rPr>
+              <a:t>FŐ EU-PÁLYA</a:t>
+            </a:r>
+            <a:endParaRPr lang="en-US" sz="1100" dirty="0"/>
+          </a:p>
+        </p:txBody>
+      </p:sp>
+      <p:sp>
+        <p:nvSpPr>
+          <p:cNvPr id="8" name="Text 6"/>
+          <p:cNvSpPr/>
+          <p:nvPr/>
+        </p:nvSpPr>
+        <p:spPr>
+          <a:xfrm>
+            <a:off x="731520" y="2148840"/>
+            <a:ext cx="3017520" cy="502920"/>
           </a:xfrm>
           <a:prstGeom prst="rect">
             <a:avLst/>
@@ -7852,30 +7526,30 @@
               <a:buNone/>
             </a:pPr>
             <a:r>
-              <a:rPr lang="en-US" sz="2400" b="1" dirty="0">
-                <a:solidFill>
-                  <a:srgbClr val="F5C518"/>
-                </a:solidFill>
-                <a:latin typeface="Arial" pitchFamily="34" charset="0"/>
-                <a:ea typeface="Arial" pitchFamily="34" charset="-122"/>
-                <a:cs typeface="Arial" pitchFamily="34" charset="-120"/>
-              </a:rPr>
-              <a:t>3,5 M Ft / alkalom</a:t>
-            </a:r>
-            <a:endParaRPr lang="en-US" sz="2400" dirty="0"/>
-          </a:p>
-        </p:txBody>
-      </p:sp>
-      <p:sp>
-        <p:nvSpPr>
-          <p:cNvPr id="8" name="Text 5"/>
-          <p:cNvSpPr/>
-          <p:nvPr/>
-        </p:nvSpPr>
-        <p:spPr>
-          <a:xfrm>
-            <a:off x="8046720" y="2057400"/>
-            <a:ext cx="3383280" cy="1234440"/>
+              <a:rPr lang="en-US" sz="1700" b="1" dirty="0">
+                <a:solidFill>
+                  <a:srgbClr val="1E3A5F"/>
+                </a:solidFill>
+                <a:latin typeface="Arial" pitchFamily="34" charset="0"/>
+                <a:ea typeface="Arial" pitchFamily="34" charset="-122"/>
+                <a:cs typeface="Arial" pitchFamily="34" charset="-120"/>
+              </a:rPr>
+              <a:t>ESF+ · Gyermekgarancia + Roma NEETs</a:t>
+            </a:r>
+            <a:endParaRPr lang="en-US" sz="1700" dirty="0"/>
+          </a:p>
+        </p:txBody>
+      </p:sp>
+      <p:sp>
+        <p:nvSpPr>
+          <p:cNvPr id="9" name="Text 7"/>
+          <p:cNvSpPr/>
+          <p:nvPr/>
+        </p:nvSpPr>
+        <p:spPr>
+          <a:xfrm>
+            <a:off x="731520" y="2697480"/>
+            <a:ext cx="3017520" cy="1371600"/>
           </a:xfrm>
           <a:prstGeom prst="rect">
             <a:avLst/>
@@ -7893,13 +7567,13 @@
             <a:r>
               <a:rPr lang="en-US" sz="1250" dirty="0">
                 <a:solidFill>
-                  <a:srgbClr val="CADCFC"/>
-                </a:solidFill>
-                <a:latin typeface="Arial" pitchFamily="34" charset="0"/>
-                <a:ea typeface="Arial" pitchFamily="34" charset="-122"/>
-                <a:cs typeface="Arial" pitchFamily="34" charset="-120"/>
-              </a:rPr>
-              <a:t>a nagyköveti díj: a programnapokon kieső kereskedelmi fellépések ellentételezése – tartalmazza a teljes napos jelenlétet és a médiafeladatokat is.</a:t>
+                  <a:srgbClr val="5B6770"/>
+                </a:solidFill>
+                <a:latin typeface="Arial" pitchFamily="34" charset="0"/>
+                <a:ea typeface="Arial" pitchFamily="34" charset="-122"/>
+                <a:cs typeface="Arial" pitchFamily="34" charset="-120"/>
+              </a:rPr>
+              <a:t>Az Európai Gyermekgarancia komponens kifejezetten a rászoruló gyerekeknek nyújtott szolgáltatásokat támogatja (12 M EUR keret) – a FELÚT gyerekfókuszához ez a fő forrás.</a:t>
             </a:r>
             <a:endParaRPr lang="en-US" sz="1250" dirty="0"/>
           </a:p>
@@ -7907,18 +7581,57 @@
       </p:sp>
       <p:sp>
         <p:nvSpPr>
-          <p:cNvPr id="9" name="Shape 6"/>
-          <p:cNvSpPr/>
-          <p:nvPr/>
-        </p:nvSpPr>
-        <p:spPr>
-          <a:xfrm>
-            <a:off x="7772400" y="3611880"/>
-            <a:ext cx="3931920" cy="2514600"/>
+          <p:cNvPr id="10" name="Text 8"/>
+          <p:cNvSpPr/>
+          <p:nvPr/>
+        </p:nvSpPr>
+        <p:spPr>
+          <a:xfrm>
+            <a:off x="731520" y="4114800"/>
+            <a:ext cx="3017520" cy="502920"/>
+          </a:xfrm>
+          <a:prstGeom prst="rect">
+            <a:avLst/>
+          </a:prstGeom>
+          <a:noFill/>
+          <a:ln/>
+        </p:spPr>
+        <p:txBody>
+          <a:bodyPr wrap="square" lIns="0" tIns="0" rIns="0" bIns="0" rtlCol="0" anchor="ctr"/>
+          <a:lstStyle/>
+          <a:p>
+            <a:pPr indent="0" marL="0">
+              <a:buNone/>
+            </a:pPr>
+            <a:r>
+              <a:rPr lang="en-US" sz="1250" b="1" dirty="0">
+                <a:solidFill>
+                  <a:srgbClr val="D93025"/>
+                </a:solidFill>
+                <a:latin typeface="Arial" pitchFamily="34" charset="0"/>
+                <a:ea typeface="Arial" pitchFamily="34" charset="-122"/>
+                <a:cs typeface="Arial" pitchFamily="34" charset="-120"/>
+              </a:rPr>
+              <a:t>Beadási határidő: 2026. szeptember 30.</a:t>
+            </a:r>
+            <a:endParaRPr lang="en-US" sz="1250" dirty="0"/>
+          </a:p>
+        </p:txBody>
+      </p:sp>
+      <p:sp>
+        <p:nvSpPr>
+          <p:cNvPr id="11" name="Shape 9"/>
+          <p:cNvSpPr/>
+          <p:nvPr/>
+        </p:nvSpPr>
+        <p:spPr>
+          <a:xfrm>
+            <a:off x="4297680" y="1325880"/>
+            <a:ext cx="3566160" cy="3383280"/>
           </a:xfrm>
           <a:prstGeom prst="roundRect">
             <a:avLst>
-              <a:gd name="adj" fmla="val 4364"/>
+              <a:gd name="adj" fmla="val 3243"/>
             </a:avLst>
           </a:prstGeom>
           <a:solidFill>
@@ -7929,14 +7642,75 @@
       </p:sp>
       <p:sp>
         <p:nvSpPr>
-          <p:cNvPr id="10" name="Text 7"/>
-          <p:cNvSpPr/>
-          <p:nvPr/>
-        </p:nvSpPr>
-        <p:spPr>
-          <a:xfrm>
-            <a:off x="8046720" y="3794760"/>
-            <a:ext cx="3383280" cy="365760"/>
+          <p:cNvPr id="12" name="Shape 10"/>
+          <p:cNvSpPr/>
+          <p:nvPr/>
+        </p:nvSpPr>
+        <p:spPr>
+          <a:xfrm>
+            <a:off x="4572000" y="1600200"/>
+            <a:ext cx="1920240" cy="384048"/>
+          </a:xfrm>
+          <a:prstGeom prst="roundRect">
+            <a:avLst>
+              <a:gd name="adj" fmla="val 19048"/>
+            </a:avLst>
+          </a:prstGeom>
+          <a:solidFill>
+            <a:srgbClr val="D93025"/>
+          </a:solidFill>
+          <a:ln/>
+        </p:spPr>
+      </p:sp>
+      <p:sp>
+        <p:nvSpPr>
+          <p:cNvPr id="13" name="Text 11"/>
+          <p:cNvSpPr/>
+          <p:nvPr/>
+        </p:nvSpPr>
+        <p:spPr>
+          <a:xfrm>
+            <a:off x="4572000" y="1600200"/>
+            <a:ext cx="1920240" cy="384048"/>
+          </a:xfrm>
+          <a:prstGeom prst="rect">
+            <a:avLst/>
+          </a:prstGeom>
+          <a:noFill/>
+          <a:ln/>
+        </p:spPr>
+        <p:txBody>
+          <a:bodyPr wrap="square" lIns="0" tIns="0" rIns="0" bIns="0" rtlCol="0" anchor="ctr"/>
+          <a:lstStyle/>
+          <a:p>
+            <a:pPr algn="ctr" indent="0" marL="0">
+              <a:buNone/>
+            </a:pPr>
+            <a:r>
+              <a:rPr lang="en-US" sz="1100" b="1" dirty="0">
+                <a:solidFill>
+                  <a:srgbClr val="FFFFFF"/>
+                </a:solidFill>
+                <a:latin typeface="Arial" pitchFamily="34" charset="0"/>
+                <a:ea typeface="Arial" pitchFamily="34" charset="-122"/>
+                <a:cs typeface="Arial" pitchFamily="34" charset="-120"/>
+              </a:rPr>
+              <a:t>MAGYAR FORRÁSOK</a:t>
+            </a:r>
+            <a:endParaRPr lang="en-US" sz="1100" dirty="0"/>
+          </a:p>
+        </p:txBody>
+      </p:sp>
+      <p:sp>
+        <p:nvSpPr>
+          <p:cNvPr id="14" name="Text 12"/>
+          <p:cNvSpPr/>
+          <p:nvPr/>
+        </p:nvSpPr>
+        <p:spPr>
+          <a:xfrm>
+            <a:off x="4572000" y="2148840"/>
+            <a:ext cx="3017520" cy="502920"/>
           </a:xfrm>
           <a:prstGeom prst="rect">
             <a:avLst/>
@@ -7952,15 +7726,382 @@
               <a:buNone/>
             </a:pPr>
             <a:r>
+              <a:rPr lang="en-US" sz="1700" b="1" dirty="0">
+                <a:solidFill>
+                  <a:srgbClr val="1E3A5F"/>
+                </a:solidFill>
+                <a:latin typeface="Arial" pitchFamily="34" charset="0"/>
+                <a:ea typeface="Arial" pitchFamily="34" charset="-122"/>
+                <a:cs typeface="Arial" pitchFamily="34" charset="-120"/>
+              </a:rPr>
+              <a:t>Hazai felhívások</a:t>
+            </a:r>
+            <a:endParaRPr lang="en-US" sz="1700" dirty="0"/>
+          </a:p>
+        </p:txBody>
+      </p:sp>
+      <p:sp>
+        <p:nvSpPr>
+          <p:cNvPr id="15" name="Text 13"/>
+          <p:cNvSpPr/>
+          <p:nvPr/>
+        </p:nvSpPr>
+        <p:spPr>
+          <a:xfrm>
+            <a:off x="4572000" y="2697480"/>
+            <a:ext cx="3017520" cy="1371600"/>
+          </a:xfrm>
+          <a:prstGeom prst="rect">
+            <a:avLst/>
+          </a:prstGeom>
+          <a:noFill/>
+          <a:ln/>
+        </p:spPr>
+        <p:txBody>
+          <a:bodyPr wrap="square" lIns="0" tIns="0" rIns="0" bIns="0" rtlCol="0" anchor="ctr"/>
+          <a:lstStyle/>
+          <a:p>
+            <a:pPr indent="0" marL="0">
+              <a:buNone/>
+            </a:pPr>
+            <a:r>
+              <a:rPr lang="en-US" sz="1250" dirty="0">
+                <a:solidFill>
+                  <a:srgbClr val="5B6770"/>
+                </a:solidFill>
+                <a:latin typeface="Arial" pitchFamily="34" charset="0"/>
+                <a:ea typeface="Arial" pitchFamily="34" charset="-122"/>
+                <a:cs typeface="Arial" pitchFamily="34" charset="-120"/>
+              </a:rPr>
+              <a:t>EFOP+ Tanoda-pályázatok (5,5 Mrd Ft keret) · BM roma nemzetiségi felhívások (770 M Ft: tábor, kultúra) · EFOP+ 3.3.3-25 roma lányok tanulmányi támogatása.</a:t>
+            </a:r>
+            <a:endParaRPr lang="en-US" sz="1250" dirty="0"/>
+          </a:p>
+        </p:txBody>
+      </p:sp>
+      <p:sp>
+        <p:nvSpPr>
+          <p:cNvPr id="16" name="Text 14"/>
+          <p:cNvSpPr/>
+          <p:nvPr/>
+        </p:nvSpPr>
+        <p:spPr>
+          <a:xfrm>
+            <a:off x="4572000" y="4114800"/>
+            <a:ext cx="3017520" cy="502920"/>
+          </a:xfrm>
+          <a:prstGeom prst="rect">
+            <a:avLst/>
+          </a:prstGeom>
+          <a:noFill/>
+          <a:ln/>
+        </p:spPr>
+        <p:txBody>
+          <a:bodyPr wrap="square" lIns="0" tIns="0" rIns="0" bIns="0" rtlCol="0" anchor="ctr"/>
+          <a:lstStyle/>
+          <a:p>
+            <a:pPr indent="0" marL="0">
+              <a:buNone/>
+            </a:pPr>
+            <a:r>
+              <a:rPr lang="en-US" sz="1250" b="1" dirty="0">
+                <a:solidFill>
+                  <a:srgbClr val="D93025"/>
+                </a:solidFill>
+                <a:latin typeface="Arial" pitchFamily="34" charset="0"/>
+                <a:ea typeface="Arial" pitchFamily="34" charset="-122"/>
+                <a:cs typeface="Arial" pitchFamily="34" charset="-120"/>
+              </a:rPr>
+              <a:t>Tanoda-beadás: 2026. október 30-tól</a:t>
+            </a:r>
+            <a:endParaRPr lang="en-US" sz="1250" dirty="0"/>
+          </a:p>
+        </p:txBody>
+      </p:sp>
+      <p:sp>
+        <p:nvSpPr>
+          <p:cNvPr id="17" name="Shape 15"/>
+          <p:cNvSpPr/>
+          <p:nvPr/>
+        </p:nvSpPr>
+        <p:spPr>
+          <a:xfrm>
+            <a:off x="8138160" y="1325880"/>
+            <a:ext cx="3566160" cy="3383280"/>
+          </a:xfrm>
+          <a:prstGeom prst="roundRect">
+            <a:avLst>
+              <a:gd name="adj" fmla="val 3243"/>
+            </a:avLst>
+          </a:prstGeom>
+          <a:solidFill>
+            <a:srgbClr val="F4F7FA"/>
+          </a:solidFill>
+          <a:ln/>
+        </p:spPr>
+      </p:sp>
+      <p:sp>
+        <p:nvSpPr>
+          <p:cNvPr id="18" name="Shape 16"/>
+          <p:cNvSpPr/>
+          <p:nvPr/>
+        </p:nvSpPr>
+        <p:spPr>
+          <a:xfrm>
+            <a:off x="8412480" y="1600200"/>
+            <a:ext cx="1920240" cy="384048"/>
+          </a:xfrm>
+          <a:prstGeom prst="roundRect">
+            <a:avLst>
+              <a:gd name="adj" fmla="val 19048"/>
+            </a:avLst>
+          </a:prstGeom>
+          <a:solidFill>
+            <a:srgbClr val="237547"/>
+          </a:solidFill>
+          <a:ln/>
+        </p:spPr>
+      </p:sp>
+      <p:sp>
+        <p:nvSpPr>
+          <p:cNvPr id="19" name="Text 17"/>
+          <p:cNvSpPr/>
+          <p:nvPr/>
+        </p:nvSpPr>
+        <p:spPr>
+          <a:xfrm>
+            <a:off x="8412480" y="1600200"/>
+            <a:ext cx="1920240" cy="384048"/>
+          </a:xfrm>
+          <a:prstGeom prst="rect">
+            <a:avLst/>
+          </a:prstGeom>
+          <a:noFill/>
+          <a:ln/>
+        </p:spPr>
+        <p:txBody>
+          <a:bodyPr wrap="square" lIns="0" tIns="0" rIns="0" bIns="0" rtlCol="0" anchor="ctr"/>
+          <a:lstStyle/>
+          <a:p>
+            <a:pPr algn="ctr" indent="0" marL="0">
+              <a:buNone/>
+            </a:pPr>
+            <a:r>
+              <a:rPr lang="en-US" sz="1100" b="1" dirty="0">
+                <a:solidFill>
+                  <a:srgbClr val="FFFFFF"/>
+                </a:solidFill>
+                <a:latin typeface="Arial" pitchFamily="34" charset="0"/>
+                <a:ea typeface="Arial" pitchFamily="34" charset="-122"/>
+                <a:cs typeface="Arial" pitchFamily="34" charset="-120"/>
+              </a:rPr>
+              <a:t>BGA + ERASMUS+</a:t>
+            </a:r>
+            <a:endParaRPr lang="en-US" sz="1100" dirty="0"/>
+          </a:p>
+        </p:txBody>
+      </p:sp>
+      <p:sp>
+        <p:nvSpPr>
+          <p:cNvPr id="20" name="Text 18"/>
+          <p:cNvSpPr/>
+          <p:nvPr/>
+        </p:nvSpPr>
+        <p:spPr>
+          <a:xfrm>
+            <a:off x="8412480" y="2148840"/>
+            <a:ext cx="3017520" cy="502920"/>
+          </a:xfrm>
+          <a:prstGeom prst="rect">
+            <a:avLst/>
+          </a:prstGeom>
+          <a:noFill/>
+          <a:ln/>
+        </p:spPr>
+        <p:txBody>
+          <a:bodyPr wrap="square" lIns="0" tIns="0" rIns="0" bIns="0" rtlCol="0" anchor="ctr"/>
+          <a:lstStyle/>
+          <a:p>
+            <a:pPr indent="0" marL="0">
+              <a:buNone/>
+            </a:pPr>
+            <a:r>
+              <a:rPr lang="en-US" sz="1700" b="1" dirty="0">
+                <a:solidFill>
+                  <a:srgbClr val="1E3A5F"/>
+                </a:solidFill>
+                <a:latin typeface="Arial" pitchFamily="34" charset="0"/>
+                <a:ea typeface="Arial" pitchFamily="34" charset="-122"/>
+                <a:cs typeface="Arial" pitchFamily="34" charset="-120"/>
+              </a:rPr>
+              <a:t>Határon túli források</a:t>
+            </a:r>
+            <a:endParaRPr lang="en-US" sz="1700" dirty="0"/>
+          </a:p>
+        </p:txBody>
+      </p:sp>
+      <p:sp>
+        <p:nvSpPr>
+          <p:cNvPr id="21" name="Text 19"/>
+          <p:cNvSpPr/>
+          <p:nvPr/>
+        </p:nvSpPr>
+        <p:spPr>
+          <a:xfrm>
+            <a:off x="8412480" y="2697480"/>
+            <a:ext cx="3017520" cy="1371600"/>
+          </a:xfrm>
+          <a:prstGeom prst="rect">
+            <a:avLst/>
+          </a:prstGeom>
+          <a:noFill/>
+          <a:ln/>
+        </p:spPr>
+        <p:txBody>
+          <a:bodyPr wrap="square" lIns="0" tIns="0" rIns="0" bIns="0" rtlCol="0" anchor="ctr"/>
+          <a:lstStyle/>
+          <a:p>
+            <a:pPr indent="0" marL="0">
+              <a:buNone/>
+            </a:pPr>
+            <a:r>
+              <a:rPr lang="en-US" sz="1250" dirty="0">
+                <a:solidFill>
+                  <a:srgbClr val="5B6770"/>
+                </a:solidFill>
+                <a:latin typeface="Arial" pitchFamily="34" charset="0"/>
+                <a:ea typeface="Arial" pitchFamily="34" charset="-122"/>
+                <a:cs typeface="Arial" pitchFamily="34" charset="-120"/>
+              </a:rPr>
+              <a:t>A 6 határon túli alkalom helyi költségeire a társrendező magyar intézmények Bethlen Gábor Alap-pályázatai (500e–2M Ft/szervezet); SK/RO helyszínekre Erasmus+ és CERV is.</a:t>
+            </a:r>
+            <a:endParaRPr lang="en-US" sz="1250" dirty="0"/>
+          </a:p>
+        </p:txBody>
+      </p:sp>
+      <p:sp>
+        <p:nvSpPr>
+          <p:cNvPr id="22" name="Text 20"/>
+          <p:cNvSpPr/>
+          <p:nvPr/>
+        </p:nvSpPr>
+        <p:spPr>
+          <a:xfrm>
+            <a:off x="8412480" y="4114800"/>
+            <a:ext cx="3017520" cy="502920"/>
+          </a:xfrm>
+          <a:prstGeom prst="rect">
+            <a:avLst/>
+          </a:prstGeom>
+          <a:noFill/>
+          <a:ln/>
+        </p:spPr>
+        <p:txBody>
+          <a:bodyPr wrap="square" lIns="0" tIns="0" rIns="0" bIns="0" rtlCol="0" anchor="ctr"/>
+          <a:lstStyle/>
+          <a:p>
+            <a:pPr indent="0" marL="0">
+              <a:buNone/>
+            </a:pPr>
+            <a:r>
+              <a:rPr lang="en-US" sz="1250" b="1" dirty="0">
+                <a:solidFill>
+                  <a:srgbClr val="D93025"/>
+                </a:solidFill>
+                <a:latin typeface="Arial" pitchFamily="34" charset="0"/>
+                <a:ea typeface="Arial" pitchFamily="34" charset="-122"/>
+                <a:cs typeface="Arial" pitchFamily="34" charset="-120"/>
+              </a:rPr>
+              <a:t>BGA: NIR-en, éves kiírások</a:t>
+            </a:r>
+            <a:endParaRPr lang="en-US" sz="1250" dirty="0"/>
+          </a:p>
+        </p:txBody>
+      </p:sp>
+      <p:sp>
+        <p:nvSpPr>
+          <p:cNvPr id="23" name="Shape 21"/>
+          <p:cNvSpPr/>
+          <p:nvPr/>
+        </p:nvSpPr>
+        <p:spPr>
+          <a:xfrm>
+            <a:off x="457200" y="5029200"/>
+            <a:ext cx="11247120" cy="1143000"/>
+          </a:xfrm>
+          <a:prstGeom prst="roundRect">
+            <a:avLst>
+              <a:gd name="adj" fmla="val 9600"/>
+            </a:avLst>
+          </a:prstGeom>
+          <a:solidFill>
+            <a:srgbClr val="1E3A5F"/>
+          </a:solidFill>
+          <a:ln/>
+        </p:spPr>
+      </p:sp>
+      <p:sp>
+        <p:nvSpPr>
+          <p:cNvPr id="24" name="Text 22"/>
+          <p:cNvSpPr/>
+          <p:nvPr/>
+        </p:nvSpPr>
+        <p:spPr>
+          <a:xfrm>
+            <a:off x="731520" y="5029200"/>
+            <a:ext cx="10698480" cy="1143000"/>
+          </a:xfrm>
+          <a:prstGeom prst="rect">
+            <a:avLst/>
+          </a:prstGeom>
+          <a:noFill/>
+          <a:ln/>
+        </p:spPr>
+        <p:txBody>
+          <a:bodyPr wrap="square" lIns="0" tIns="0" rIns="0" bIns="0" rtlCol="0" anchor="ctr"/>
+          <a:lstStyle/>
+          <a:p>
+            <a:pPr indent="0" marL="0">
+              <a:buNone/>
+            </a:pPr>
+            <a:r>
               <a:rPr lang="en-US" sz="1500" b="1" dirty="0">
                 <a:solidFill>
-                  <a:srgbClr val="1E3A5F"/>
-                </a:solidFill>
-                <a:latin typeface="Arial" pitchFamily="34" charset="0"/>
-                <a:ea typeface="Arial" pitchFamily="34" charset="-122"/>
-                <a:cs typeface="Arial" pitchFamily="34" charset="-120"/>
-              </a:rPr>
-              <a:t>Fajlagos költség</a:t>
+                  <a:srgbClr val="FFFFFF"/>
+                </a:solidFill>
+                <a:latin typeface="Arial" pitchFamily="34" charset="0"/>
+                <a:ea typeface="Arial" pitchFamily="34" charset="-122"/>
+                <a:cs typeface="Arial" pitchFamily="34" charset="-120"/>
+              </a:rPr>
+              <a:t>Finanszírozási szerkezet: </a:t>
+            </a:r>
+            <a:pPr indent="0" marL="0">
+              <a:buNone/>
+            </a:pPr>
+            <a:r>
+              <a:rPr lang="en-US" sz="1500" dirty="0">
+                <a:solidFill>
+                  <a:srgbClr val="CADCFC"/>
+                </a:solidFill>
+                <a:latin typeface="Arial" pitchFamily="34" charset="0"/>
+                <a:ea typeface="Arial" pitchFamily="34" charset="-122"/>
+                <a:cs typeface="Arial" pitchFamily="34" charset="-120"/>
+              </a:rPr>
+              <a:t>pályázati támogatások + önerő / vállalati CSR-szponzoráció. </a:t>
+            </a:r>
+            <a:pPr indent="0" marL="0">
+              <a:buNone/>
+            </a:pPr>
+            <a:r>
+              <a:rPr lang="en-US" sz="1500" i="1" dirty="0">
+                <a:solidFill>
+                  <a:srgbClr val="CADCFC"/>
+                </a:solidFill>
+                <a:latin typeface="Arial" pitchFamily="34" charset="0"/>
+                <a:ea typeface="Arial" pitchFamily="34" charset="-122"/>
+                <a:cs typeface="Arial" pitchFamily="34" charset="-120"/>
+              </a:rPr>
+              <a:t>A részletes költségvetés külön egyeztetés témája.</a:t>
             </a:r>
             <a:endParaRPr lang="en-US" sz="1500" dirty="0"/>
           </a:p>
@@ -7968,89 +8109,7 @@
       </p:sp>
       <p:sp>
         <p:nvSpPr>
-          <p:cNvPr id="11" name="Text 8"/>
-          <p:cNvSpPr/>
-          <p:nvPr/>
-        </p:nvSpPr>
-        <p:spPr>
-          <a:xfrm>
-            <a:off x="8092440" y="4206240"/>
-            <a:ext cx="3383280" cy="1737360"/>
-          </a:xfrm>
-          <a:prstGeom prst="rect">
-            <a:avLst/>
-          </a:prstGeom>
-          <a:noFill/>
-          <a:ln/>
-        </p:spPr>
-        <p:txBody>
-          <a:bodyPr wrap="square" lIns="0" tIns="0" rIns="0" bIns="0" rtlCol="0" anchor="ctr"/>
-          <a:lstStyle/>
-          <a:p>
-            <a:pPr marL="342900" indent="-342900">
-              <a:spcAft>
-                <a:spcPts val="600"/>
-              </a:spcAft>
-              <a:buSzPct val="100000"/>
-              <a:buChar char="•"/>
-            </a:pPr>
-            <a:r>
-              <a:rPr lang="en-US" sz="1300" dirty="0">
-                <a:solidFill>
-                  <a:srgbClr val="5B6770"/>
-                </a:solidFill>
-                <a:latin typeface="Arial" pitchFamily="34" charset="0"/>
-                <a:ea typeface="Arial" pitchFamily="34" charset="-122"/>
-                <a:cs typeface="Arial" pitchFamily="34" charset="-120"/>
-              </a:rPr>
-              <a:t>~24 200 Ft / közvetlenül elért fő</a:t>
-            </a:r>
-            <a:endParaRPr lang="en-US" sz="1300" dirty="0"/>
-          </a:p>
-          <a:p>
-            <a:pPr marL="342900" indent="-342900">
-              <a:spcAft>
-                <a:spcPts val="600"/>
-              </a:spcAft>
-              <a:buSzPct val="100000"/>
-              <a:buChar char="•"/>
-            </a:pPr>
-            <a:r>
-              <a:rPr lang="en-US" sz="1300" dirty="0">
-                <a:solidFill>
-                  <a:srgbClr val="5B6770"/>
-                </a:solidFill>
-                <a:latin typeface="Arial" pitchFamily="34" charset="0"/>
-                <a:ea typeface="Arial" pitchFamily="34" charset="-122"/>
-                <a:cs typeface="Arial" pitchFamily="34" charset="-120"/>
-              </a:rPr>
-              <a:t>~72 Ft / elérés az online eléréssel együtt</a:t>
-            </a:r>
-            <a:endParaRPr lang="en-US" sz="1300" dirty="0"/>
-          </a:p>
-          <a:p>
-            <a:pPr marL="342900" indent="-342900">
-              <a:buSzPct val="100000"/>
-              <a:buChar char="•"/>
-            </a:pPr>
-            <a:r>
-              <a:rPr lang="en-US" sz="1300" dirty="0">
-                <a:solidFill>
-                  <a:srgbClr val="5B6770"/>
-                </a:solidFill>
-                <a:latin typeface="Arial" pitchFamily="34" charset="0"/>
-                <a:ea typeface="Arial" pitchFamily="34" charset="-122"/>
-                <a:cs typeface="Arial" pitchFamily="34" charset="-120"/>
-              </a:rPr>
-              <a:t>≈ 181 650 EUR – a tipikus ESF+ projektméret-sávban</a:t>
-            </a:r>
-            <a:endParaRPr lang="en-US" sz="1300" dirty="0"/>
-          </a:p>
-        </p:txBody>
-      </p:sp>
-      <p:sp>
-        <p:nvSpPr>
-          <p:cNvPr id="12" name="Text 9"/>
+          <p:cNvPr id="25" name="Text 23"/>
           <p:cNvSpPr/>
           <p:nvPr/>
         </p:nvSpPr>
@@ -8152,7 +8211,7 @@
                 <a:ea typeface="Arial" pitchFamily="34" charset="-122"/>
                 <a:cs typeface="Arial" pitchFamily="34" charset="-120"/>
               </a:rPr>
-              <a:t>Finanszírozás: nyitott hazai és EU-források</a:t>
+              <a:t>Mit várunk a 6 hónap végére?</a:t>
             </a:r>
             <a:endParaRPr lang="en-US" sz="3600" dirty="0"/>
           </a:p>
@@ -8227,12 +8286,12 @@
         </p:nvSpPr>
         <p:spPr>
           <a:xfrm>
-            <a:off x="457200" y="1325880"/>
-            <a:ext cx="3566160" cy="3383280"/>
+            <a:off x="457200" y="1371600"/>
+            <a:ext cx="2606040" cy="2103120"/>
           </a:xfrm>
           <a:prstGeom prst="roundRect">
             <a:avLst>
-              <a:gd name="adj" fmla="val 3243"/>
+              <a:gd name="adj" fmla="val 5217"/>
             </a:avLst>
           </a:prstGeom>
           <a:solidFill>
@@ -8243,196 +8302,96 @@
       </p:sp>
       <p:sp>
         <p:nvSpPr>
-          <p:cNvPr id="6" name="Shape 4"/>
-          <p:cNvSpPr/>
-          <p:nvPr/>
-        </p:nvSpPr>
-        <p:spPr>
-          <a:xfrm>
-            <a:off x="731520" y="1600200"/>
-            <a:ext cx="1920240" cy="384048"/>
+          <p:cNvPr id="6" name="Text 4"/>
+          <p:cNvSpPr/>
+          <p:nvPr/>
+        </p:nvSpPr>
+        <p:spPr>
+          <a:xfrm>
+            <a:off x="457200" y="1600200"/>
+            <a:ext cx="2606040" cy="914400"/>
+          </a:xfrm>
+          <a:prstGeom prst="rect">
+            <a:avLst/>
+          </a:prstGeom>
+          <a:noFill/>
+          <a:ln/>
+        </p:spPr>
+        <p:txBody>
+          <a:bodyPr wrap="square" lIns="0" tIns="0" rIns="0" bIns="0" rtlCol="0" anchor="ctr"/>
+          <a:lstStyle/>
+          <a:p>
+            <a:pPr algn="ctr" indent="0" marL="0">
+              <a:buNone/>
+            </a:pPr>
+            <a:r>
+              <a:rPr lang="en-US" sz="4400" b="1" dirty="0">
+                <a:solidFill>
+                  <a:srgbClr val="D93025"/>
+                </a:solidFill>
+                <a:latin typeface="Arial" pitchFamily="34" charset="0"/>
+                <a:ea typeface="Arial" pitchFamily="34" charset="-122"/>
+                <a:cs typeface="Arial" pitchFamily="34" charset="-120"/>
+              </a:rPr>
+              <a:t>3 000+</a:t>
+            </a:r>
+            <a:endParaRPr lang="en-US" sz="4400" dirty="0"/>
+          </a:p>
+        </p:txBody>
+      </p:sp>
+      <p:sp>
+        <p:nvSpPr>
+          <p:cNvPr id="7" name="Text 5"/>
+          <p:cNvSpPr/>
+          <p:nvPr/>
+        </p:nvSpPr>
+        <p:spPr>
+          <a:xfrm>
+            <a:off x="640080" y="2560320"/>
+            <a:ext cx="2240280" cy="822960"/>
+          </a:xfrm>
+          <a:prstGeom prst="rect">
+            <a:avLst/>
+          </a:prstGeom>
+          <a:noFill/>
+          <a:ln/>
+        </p:spPr>
+        <p:txBody>
+          <a:bodyPr wrap="square" lIns="0" tIns="0" rIns="0" bIns="0" rtlCol="0" anchor="ctr"/>
+          <a:lstStyle/>
+          <a:p>
+            <a:pPr algn="ctr" indent="0" marL="0">
+              <a:buNone/>
+            </a:pPr>
+            <a:r>
+              <a:rPr lang="en-US" sz="1300" dirty="0">
+                <a:solidFill>
+                  <a:srgbClr val="5B6770"/>
+                </a:solidFill>
+                <a:latin typeface="Arial" pitchFamily="34" charset="0"/>
+                <a:ea typeface="Arial" pitchFamily="34" charset="-122"/>
+                <a:cs typeface="Arial" pitchFamily="34" charset="-120"/>
+              </a:rPr>
+              <a:t>elért gyerek és családtag a 12 helyszínen</a:t>
+            </a:r>
+            <a:endParaRPr lang="en-US" sz="1300" dirty="0"/>
+          </a:p>
+        </p:txBody>
+      </p:sp>
+      <p:sp>
+        <p:nvSpPr>
+          <p:cNvPr id="8" name="Shape 6"/>
+          <p:cNvSpPr/>
+          <p:nvPr/>
+        </p:nvSpPr>
+        <p:spPr>
+          <a:xfrm>
+            <a:off x="3337560" y="1371600"/>
+            <a:ext cx="2606040" cy="2103120"/>
           </a:xfrm>
           <a:prstGeom prst="roundRect">
             <a:avLst>
-              <a:gd name="adj" fmla="val 19048"/>
-            </a:avLst>
-          </a:prstGeom>
-          <a:solidFill>
-            <a:srgbClr val="1E3A5F"/>
-          </a:solidFill>
-          <a:ln/>
-        </p:spPr>
-      </p:sp>
-      <p:sp>
-        <p:nvSpPr>
-          <p:cNvPr id="7" name="Text 5"/>
-          <p:cNvSpPr/>
-          <p:nvPr/>
-        </p:nvSpPr>
-        <p:spPr>
-          <a:xfrm>
-            <a:off x="731520" y="1600200"/>
-            <a:ext cx="1920240" cy="384048"/>
-          </a:xfrm>
-          <a:prstGeom prst="rect">
-            <a:avLst/>
-          </a:prstGeom>
-          <a:noFill/>
-          <a:ln/>
-        </p:spPr>
-        <p:txBody>
-          <a:bodyPr wrap="square" lIns="0" tIns="0" rIns="0" bIns="0" rtlCol="0" anchor="ctr"/>
-          <a:lstStyle/>
-          <a:p>
-            <a:pPr algn="ctr" indent="0" marL="0">
-              <a:buNone/>
-            </a:pPr>
-            <a:r>
-              <a:rPr lang="en-US" sz="1100" b="1" dirty="0">
-                <a:solidFill>
-                  <a:srgbClr val="FFFFFF"/>
-                </a:solidFill>
-                <a:latin typeface="Arial" pitchFamily="34" charset="0"/>
-                <a:ea typeface="Arial" pitchFamily="34" charset="-122"/>
-                <a:cs typeface="Arial" pitchFamily="34" charset="-120"/>
-              </a:rPr>
-              <a:t>FŐ EU-PÁLYA</a:t>
-            </a:r>
-            <a:endParaRPr lang="en-US" sz="1100" dirty="0"/>
-          </a:p>
-        </p:txBody>
-      </p:sp>
-      <p:sp>
-        <p:nvSpPr>
-          <p:cNvPr id="8" name="Text 6"/>
-          <p:cNvSpPr/>
-          <p:nvPr/>
-        </p:nvSpPr>
-        <p:spPr>
-          <a:xfrm>
-            <a:off x="731520" y="2148840"/>
-            <a:ext cx="3017520" cy="502920"/>
-          </a:xfrm>
-          <a:prstGeom prst="rect">
-            <a:avLst/>
-          </a:prstGeom>
-          <a:noFill/>
-          <a:ln/>
-        </p:spPr>
-        <p:txBody>
-          <a:bodyPr wrap="square" lIns="0" tIns="0" rIns="0" bIns="0" rtlCol="0" anchor="ctr"/>
-          <a:lstStyle/>
-          <a:p>
-            <a:pPr indent="0" marL="0">
-              <a:buNone/>
-            </a:pPr>
-            <a:r>
-              <a:rPr lang="en-US" sz="1700" b="1" dirty="0">
-                <a:solidFill>
-                  <a:srgbClr val="1E3A5F"/>
-                </a:solidFill>
-                <a:latin typeface="Arial" pitchFamily="34" charset="0"/>
-                <a:ea typeface="Arial" pitchFamily="34" charset="-122"/>
-                <a:cs typeface="Arial" pitchFamily="34" charset="-120"/>
-              </a:rPr>
-              <a:t>ESF+ · Gyermekgarancia + Roma NEETs</a:t>
-            </a:r>
-            <a:endParaRPr lang="en-US" sz="1700" dirty="0"/>
-          </a:p>
-        </p:txBody>
-      </p:sp>
-      <p:sp>
-        <p:nvSpPr>
-          <p:cNvPr id="9" name="Text 7"/>
-          <p:cNvSpPr/>
-          <p:nvPr/>
-        </p:nvSpPr>
-        <p:spPr>
-          <a:xfrm>
-            <a:off x="731520" y="2697480"/>
-            <a:ext cx="3017520" cy="1371600"/>
-          </a:xfrm>
-          <a:prstGeom prst="rect">
-            <a:avLst/>
-          </a:prstGeom>
-          <a:noFill/>
-          <a:ln/>
-        </p:spPr>
-        <p:txBody>
-          <a:bodyPr wrap="square" lIns="0" tIns="0" rIns="0" bIns="0" rtlCol="0" anchor="ctr"/>
-          <a:lstStyle/>
-          <a:p>
-            <a:pPr indent="0" marL="0">
-              <a:buNone/>
-            </a:pPr>
-            <a:r>
-              <a:rPr lang="en-US" sz="1250" dirty="0">
-                <a:solidFill>
-                  <a:srgbClr val="5B6770"/>
-                </a:solidFill>
-                <a:latin typeface="Arial" pitchFamily="34" charset="0"/>
-                <a:ea typeface="Arial" pitchFamily="34" charset="-122"/>
-                <a:cs typeface="Arial" pitchFamily="34" charset="-120"/>
-              </a:rPr>
-              <a:t>Az Európai Gyermekgarancia komponens kifejezetten a rászoruló gyerekeknek nyújtott szolgáltatásokat támogatja (12 M EUR keret) – a FELÚT gyerekfókuszához ez a fő forrás.</a:t>
-            </a:r>
-            <a:endParaRPr lang="en-US" sz="1250" dirty="0"/>
-          </a:p>
-        </p:txBody>
-      </p:sp>
-      <p:sp>
-        <p:nvSpPr>
-          <p:cNvPr id="10" name="Text 8"/>
-          <p:cNvSpPr/>
-          <p:nvPr/>
-        </p:nvSpPr>
-        <p:spPr>
-          <a:xfrm>
-            <a:off x="731520" y="4114800"/>
-            <a:ext cx="3017520" cy="502920"/>
-          </a:xfrm>
-          <a:prstGeom prst="rect">
-            <a:avLst/>
-          </a:prstGeom>
-          <a:noFill/>
-          <a:ln/>
-        </p:spPr>
-        <p:txBody>
-          <a:bodyPr wrap="square" lIns="0" tIns="0" rIns="0" bIns="0" rtlCol="0" anchor="ctr"/>
-          <a:lstStyle/>
-          <a:p>
-            <a:pPr indent="0" marL="0">
-              <a:buNone/>
-            </a:pPr>
-            <a:r>
-              <a:rPr lang="en-US" sz="1250" b="1" dirty="0">
-                <a:solidFill>
-                  <a:srgbClr val="D93025"/>
-                </a:solidFill>
-                <a:latin typeface="Arial" pitchFamily="34" charset="0"/>
-                <a:ea typeface="Arial" pitchFamily="34" charset="-122"/>
-                <a:cs typeface="Arial" pitchFamily="34" charset="-120"/>
-              </a:rPr>
-              <a:t>Beadási határidő: 2026. szeptember 30.</a:t>
-            </a:r>
-            <a:endParaRPr lang="en-US" sz="1250" dirty="0"/>
-          </a:p>
-        </p:txBody>
-      </p:sp>
-      <p:sp>
-        <p:nvSpPr>
-          <p:cNvPr id="11" name="Shape 9"/>
-          <p:cNvSpPr/>
-          <p:nvPr/>
-        </p:nvSpPr>
-        <p:spPr>
-          <a:xfrm>
-            <a:off x="4297680" y="1325880"/>
-            <a:ext cx="3566160" cy="3383280"/>
-          </a:xfrm>
-          <a:prstGeom prst="roundRect">
-            <a:avLst>
-              <a:gd name="adj" fmla="val 3243"/>
+              <a:gd name="adj" fmla="val 5217"/>
             </a:avLst>
           </a:prstGeom>
           <a:solidFill>
@@ -8443,196 +8402,96 @@
       </p:sp>
       <p:sp>
         <p:nvSpPr>
-          <p:cNvPr id="12" name="Shape 10"/>
-          <p:cNvSpPr/>
-          <p:nvPr/>
-        </p:nvSpPr>
-        <p:spPr>
-          <a:xfrm>
-            <a:off x="4572000" y="1600200"/>
-            <a:ext cx="1920240" cy="384048"/>
+          <p:cNvPr id="9" name="Text 7"/>
+          <p:cNvSpPr/>
+          <p:nvPr/>
+        </p:nvSpPr>
+        <p:spPr>
+          <a:xfrm>
+            <a:off x="3337560" y="1600200"/>
+            <a:ext cx="2606040" cy="914400"/>
+          </a:xfrm>
+          <a:prstGeom prst="rect">
+            <a:avLst/>
+          </a:prstGeom>
+          <a:noFill/>
+          <a:ln/>
+        </p:spPr>
+        <p:txBody>
+          <a:bodyPr wrap="square" lIns="0" tIns="0" rIns="0" bIns="0" rtlCol="0" anchor="ctr"/>
+          <a:lstStyle/>
+          <a:p>
+            <a:pPr algn="ctr" indent="0" marL="0">
+              <a:buNone/>
+            </a:pPr>
+            <a:r>
+              <a:rPr lang="en-US" sz="4400" b="1" dirty="0">
+                <a:solidFill>
+                  <a:srgbClr val="1B6CA8"/>
+                </a:solidFill>
+                <a:latin typeface="Arial" pitchFamily="34" charset="0"/>
+                <a:ea typeface="Arial" pitchFamily="34" charset="-122"/>
+                <a:cs typeface="Arial" pitchFamily="34" charset="-120"/>
+              </a:rPr>
+              <a:t>1 M+</a:t>
+            </a:r>
+            <a:endParaRPr lang="en-US" sz="4400" dirty="0"/>
+          </a:p>
+        </p:txBody>
+      </p:sp>
+      <p:sp>
+        <p:nvSpPr>
+          <p:cNvPr id="10" name="Text 8"/>
+          <p:cNvSpPr/>
+          <p:nvPr/>
+        </p:nvSpPr>
+        <p:spPr>
+          <a:xfrm>
+            <a:off x="3520440" y="2560320"/>
+            <a:ext cx="2240280" cy="822960"/>
+          </a:xfrm>
+          <a:prstGeom prst="rect">
+            <a:avLst/>
+          </a:prstGeom>
+          <a:noFill/>
+          <a:ln/>
+        </p:spPr>
+        <p:txBody>
+          <a:bodyPr wrap="square" lIns="0" tIns="0" rIns="0" bIns="0" rtlCol="0" anchor="ctr"/>
+          <a:lstStyle/>
+          <a:p>
+            <a:pPr algn="ctr" indent="0" marL="0">
+              <a:buNone/>
+            </a:pPr>
+            <a:r>
+              <a:rPr lang="en-US" sz="1300" dirty="0">
+                <a:solidFill>
+                  <a:srgbClr val="5B6770"/>
+                </a:solidFill>
+                <a:latin typeface="Arial" pitchFamily="34" charset="0"/>
+                <a:ea typeface="Arial" pitchFamily="34" charset="-122"/>
+                <a:cs typeface="Arial" pitchFamily="34" charset="-120"/>
+              </a:rPr>
+              <a:t>online megtekintés a nagykövet csatornáin</a:t>
+            </a:r>
+            <a:endParaRPr lang="en-US" sz="1300" dirty="0"/>
+          </a:p>
+        </p:txBody>
+      </p:sp>
+      <p:sp>
+        <p:nvSpPr>
+          <p:cNvPr id="11" name="Shape 9"/>
+          <p:cNvSpPr/>
+          <p:nvPr/>
+        </p:nvSpPr>
+        <p:spPr>
+          <a:xfrm>
+            <a:off x="6217920" y="1371600"/>
+            <a:ext cx="2606040" cy="2103120"/>
           </a:xfrm>
           <a:prstGeom prst="roundRect">
             <a:avLst>
-              <a:gd name="adj" fmla="val 19048"/>
-            </a:avLst>
-          </a:prstGeom>
-          <a:solidFill>
-            <a:srgbClr val="D93025"/>
-          </a:solidFill>
-          <a:ln/>
-        </p:spPr>
-      </p:sp>
-      <p:sp>
-        <p:nvSpPr>
-          <p:cNvPr id="13" name="Text 11"/>
-          <p:cNvSpPr/>
-          <p:nvPr/>
-        </p:nvSpPr>
-        <p:spPr>
-          <a:xfrm>
-            <a:off x="4572000" y="1600200"/>
-            <a:ext cx="1920240" cy="384048"/>
-          </a:xfrm>
-          <a:prstGeom prst="rect">
-            <a:avLst/>
-          </a:prstGeom>
-          <a:noFill/>
-          <a:ln/>
-        </p:spPr>
-        <p:txBody>
-          <a:bodyPr wrap="square" lIns="0" tIns="0" rIns="0" bIns="0" rtlCol="0" anchor="ctr"/>
-          <a:lstStyle/>
-          <a:p>
-            <a:pPr algn="ctr" indent="0" marL="0">
-              <a:buNone/>
-            </a:pPr>
-            <a:r>
-              <a:rPr lang="en-US" sz="1100" b="1" dirty="0">
-                <a:solidFill>
-                  <a:srgbClr val="FFFFFF"/>
-                </a:solidFill>
-                <a:latin typeface="Arial" pitchFamily="34" charset="0"/>
-                <a:ea typeface="Arial" pitchFamily="34" charset="-122"/>
-                <a:cs typeface="Arial" pitchFamily="34" charset="-120"/>
-              </a:rPr>
-              <a:t>MAGYAR FORRÁSOK</a:t>
-            </a:r>
-            <a:endParaRPr lang="en-US" sz="1100" dirty="0"/>
-          </a:p>
-        </p:txBody>
-      </p:sp>
-      <p:sp>
-        <p:nvSpPr>
-          <p:cNvPr id="14" name="Text 12"/>
-          <p:cNvSpPr/>
-          <p:nvPr/>
-        </p:nvSpPr>
-        <p:spPr>
-          <a:xfrm>
-            <a:off x="4572000" y="2148840"/>
-            <a:ext cx="3017520" cy="502920"/>
-          </a:xfrm>
-          <a:prstGeom prst="rect">
-            <a:avLst/>
-          </a:prstGeom>
-          <a:noFill/>
-          <a:ln/>
-        </p:spPr>
-        <p:txBody>
-          <a:bodyPr wrap="square" lIns="0" tIns="0" rIns="0" bIns="0" rtlCol="0" anchor="ctr"/>
-          <a:lstStyle/>
-          <a:p>
-            <a:pPr indent="0" marL="0">
-              <a:buNone/>
-            </a:pPr>
-            <a:r>
-              <a:rPr lang="en-US" sz="1700" b="1" dirty="0">
-                <a:solidFill>
-                  <a:srgbClr val="1E3A5F"/>
-                </a:solidFill>
-                <a:latin typeface="Arial" pitchFamily="34" charset="0"/>
-                <a:ea typeface="Arial" pitchFamily="34" charset="-122"/>
-                <a:cs typeface="Arial" pitchFamily="34" charset="-120"/>
-              </a:rPr>
-              <a:t>Hazai felhívások</a:t>
-            </a:r>
-            <a:endParaRPr lang="en-US" sz="1700" dirty="0"/>
-          </a:p>
-        </p:txBody>
-      </p:sp>
-      <p:sp>
-        <p:nvSpPr>
-          <p:cNvPr id="15" name="Text 13"/>
-          <p:cNvSpPr/>
-          <p:nvPr/>
-        </p:nvSpPr>
-        <p:spPr>
-          <a:xfrm>
-            <a:off x="4572000" y="2697480"/>
-            <a:ext cx="3017520" cy="1371600"/>
-          </a:xfrm>
-          <a:prstGeom prst="rect">
-            <a:avLst/>
-          </a:prstGeom>
-          <a:noFill/>
-          <a:ln/>
-        </p:spPr>
-        <p:txBody>
-          <a:bodyPr wrap="square" lIns="0" tIns="0" rIns="0" bIns="0" rtlCol="0" anchor="ctr"/>
-          <a:lstStyle/>
-          <a:p>
-            <a:pPr indent="0" marL="0">
-              <a:buNone/>
-            </a:pPr>
-            <a:r>
-              <a:rPr lang="en-US" sz="1250" dirty="0">
-                <a:solidFill>
-                  <a:srgbClr val="5B6770"/>
-                </a:solidFill>
-                <a:latin typeface="Arial" pitchFamily="34" charset="0"/>
-                <a:ea typeface="Arial" pitchFamily="34" charset="-122"/>
-                <a:cs typeface="Arial" pitchFamily="34" charset="-120"/>
-              </a:rPr>
-              <a:t>EFOP+ Tanoda-pályázatok (5,5 Mrd Ft keret) · BM roma nemzetiségi felhívások (770 M Ft: tábor, kultúra) · EFOP+ 3.3.3-25 roma lányok tanulmányi támogatása.</a:t>
-            </a:r>
-            <a:endParaRPr lang="en-US" sz="1250" dirty="0"/>
-          </a:p>
-        </p:txBody>
-      </p:sp>
-      <p:sp>
-        <p:nvSpPr>
-          <p:cNvPr id="16" name="Text 14"/>
-          <p:cNvSpPr/>
-          <p:nvPr/>
-        </p:nvSpPr>
-        <p:spPr>
-          <a:xfrm>
-            <a:off x="4572000" y="4114800"/>
-            <a:ext cx="3017520" cy="502920"/>
-          </a:xfrm>
-          <a:prstGeom prst="rect">
-            <a:avLst/>
-          </a:prstGeom>
-          <a:noFill/>
-          <a:ln/>
-        </p:spPr>
-        <p:txBody>
-          <a:bodyPr wrap="square" lIns="0" tIns="0" rIns="0" bIns="0" rtlCol="0" anchor="ctr"/>
-          <a:lstStyle/>
-          <a:p>
-            <a:pPr indent="0" marL="0">
-              <a:buNone/>
-            </a:pPr>
-            <a:r>
-              <a:rPr lang="en-US" sz="1250" b="1" dirty="0">
-                <a:solidFill>
-                  <a:srgbClr val="D93025"/>
-                </a:solidFill>
-                <a:latin typeface="Arial" pitchFamily="34" charset="0"/>
-                <a:ea typeface="Arial" pitchFamily="34" charset="-122"/>
-                <a:cs typeface="Arial" pitchFamily="34" charset="-120"/>
-              </a:rPr>
-              <a:t>Tanoda-beadás: 2026. október 30-tól</a:t>
-            </a:r>
-            <a:endParaRPr lang="en-US" sz="1250" dirty="0"/>
-          </a:p>
-        </p:txBody>
-      </p:sp>
-      <p:sp>
-        <p:nvSpPr>
-          <p:cNvPr id="17" name="Shape 15"/>
-          <p:cNvSpPr/>
-          <p:nvPr/>
-        </p:nvSpPr>
-        <p:spPr>
-          <a:xfrm>
-            <a:off x="8138160" y="1325880"/>
-            <a:ext cx="3566160" cy="3383280"/>
-          </a:xfrm>
-          <a:prstGeom prst="roundRect">
-            <a:avLst>
-              <a:gd name="adj" fmla="val 3243"/>
+              <a:gd name="adj" fmla="val 5217"/>
             </a:avLst>
           </a:prstGeom>
           <a:solidFill>
@@ -8643,274 +8502,327 @@
       </p:sp>
       <p:sp>
         <p:nvSpPr>
-          <p:cNvPr id="18" name="Shape 16"/>
-          <p:cNvSpPr/>
-          <p:nvPr/>
-        </p:nvSpPr>
-        <p:spPr>
-          <a:xfrm>
-            <a:off x="8412480" y="1600200"/>
-            <a:ext cx="1920240" cy="384048"/>
+          <p:cNvPr id="12" name="Text 10"/>
+          <p:cNvSpPr/>
+          <p:nvPr/>
+        </p:nvSpPr>
+        <p:spPr>
+          <a:xfrm>
+            <a:off x="6217920" y="1600200"/>
+            <a:ext cx="2606040" cy="914400"/>
+          </a:xfrm>
+          <a:prstGeom prst="rect">
+            <a:avLst/>
+          </a:prstGeom>
+          <a:noFill/>
+          <a:ln/>
+        </p:spPr>
+        <p:txBody>
+          <a:bodyPr wrap="square" lIns="0" tIns="0" rIns="0" bIns="0" rtlCol="0" anchor="ctr"/>
+          <a:lstStyle/>
+          <a:p>
+            <a:pPr algn="ctr" indent="0" marL="0">
+              <a:buNone/>
+            </a:pPr>
+            <a:r>
+              <a:rPr lang="en-US" sz="4400" b="1" dirty="0">
+                <a:solidFill>
+                  <a:srgbClr val="237547"/>
+                </a:solidFill>
+                <a:latin typeface="Arial" pitchFamily="34" charset="0"/>
+                <a:ea typeface="Arial" pitchFamily="34" charset="-122"/>
+                <a:cs typeface="Arial" pitchFamily="34" charset="-120"/>
+              </a:rPr>
+              <a:t>+30%</a:t>
+            </a:r>
+            <a:endParaRPr lang="en-US" sz="4400" dirty="0"/>
+          </a:p>
+        </p:txBody>
+      </p:sp>
+      <p:sp>
+        <p:nvSpPr>
+          <p:cNvPr id="13" name="Text 11"/>
+          <p:cNvSpPr/>
+          <p:nvPr/>
+        </p:nvSpPr>
+        <p:spPr>
+          <a:xfrm>
+            <a:off x="6400800" y="2560320"/>
+            <a:ext cx="2240280" cy="822960"/>
+          </a:xfrm>
+          <a:prstGeom prst="rect">
+            <a:avLst/>
+          </a:prstGeom>
+          <a:noFill/>
+          <a:ln/>
+        </p:spPr>
+        <p:txBody>
+          <a:bodyPr wrap="square" lIns="0" tIns="0" rIns="0" bIns="0" rtlCol="0" anchor="ctr"/>
+          <a:lstStyle/>
+          <a:p>
+            <a:pPr algn="ctr" indent="0" marL="0">
+              <a:buNone/>
+            </a:pPr>
+            <a:r>
+              <a:rPr lang="en-US" sz="1300" dirty="0">
+                <a:solidFill>
+                  <a:srgbClr val="5B6770"/>
+                </a:solidFill>
+                <a:latin typeface="Arial" pitchFamily="34" charset="0"/>
+                <a:ea typeface="Arial" pitchFamily="34" charset="-122"/>
+                <a:cs typeface="Arial" pitchFamily="34" charset="-120"/>
+              </a:rPr>
+              <a:t>kockázat-ismereti szint növekedés (elő-/utómérés)</a:t>
+            </a:r>
+            <a:endParaRPr lang="en-US" sz="1300" dirty="0"/>
+          </a:p>
+        </p:txBody>
+      </p:sp>
+      <p:sp>
+        <p:nvSpPr>
+          <p:cNvPr id="14" name="Shape 12"/>
+          <p:cNvSpPr/>
+          <p:nvPr/>
+        </p:nvSpPr>
+        <p:spPr>
+          <a:xfrm>
+            <a:off x="9098280" y="1371600"/>
+            <a:ext cx="2606040" cy="2103120"/>
           </a:xfrm>
           <a:prstGeom prst="roundRect">
             <a:avLst>
-              <a:gd name="adj" fmla="val 19048"/>
+              <a:gd name="adj" fmla="val 5217"/>
             </a:avLst>
           </a:prstGeom>
           <a:solidFill>
-            <a:srgbClr val="237547"/>
+            <a:srgbClr val="F4F7FA"/>
           </a:solidFill>
           <a:ln/>
         </p:spPr>
       </p:sp>
       <p:sp>
         <p:nvSpPr>
+          <p:cNvPr id="15" name="Text 13"/>
+          <p:cNvSpPr/>
+          <p:nvPr/>
+        </p:nvSpPr>
+        <p:spPr>
+          <a:xfrm>
+            <a:off x="9098280" y="1600200"/>
+            <a:ext cx="2606040" cy="914400"/>
+          </a:xfrm>
+          <a:prstGeom prst="rect">
+            <a:avLst/>
+          </a:prstGeom>
+          <a:noFill/>
+          <a:ln/>
+        </p:spPr>
+        <p:txBody>
+          <a:bodyPr wrap="square" lIns="0" tIns="0" rIns="0" bIns="0" rtlCol="0" anchor="ctr"/>
+          <a:lstStyle/>
+          <a:p>
+            <a:pPr algn="ctr" indent="0" marL="0">
+              <a:buNone/>
+            </a:pPr>
+            <a:r>
+              <a:rPr lang="en-US" sz="4400" b="1" dirty="0">
+                <a:solidFill>
+                  <a:srgbClr val="1E3A5F"/>
+                </a:solidFill>
+                <a:latin typeface="Arial" pitchFamily="34" charset="0"/>
+                <a:ea typeface="Arial" pitchFamily="34" charset="-122"/>
+                <a:cs typeface="Arial" pitchFamily="34" charset="-120"/>
+              </a:rPr>
+              <a:t>24+</a:t>
+            </a:r>
+            <a:endParaRPr lang="en-US" sz="4400" dirty="0"/>
+          </a:p>
+        </p:txBody>
+      </p:sp>
+      <p:sp>
+        <p:nvSpPr>
+          <p:cNvPr id="16" name="Text 14"/>
+          <p:cNvSpPr/>
+          <p:nvPr/>
+        </p:nvSpPr>
+        <p:spPr>
+          <a:xfrm>
+            <a:off x="9281160" y="2560320"/>
+            <a:ext cx="2240280" cy="822960"/>
+          </a:xfrm>
+          <a:prstGeom prst="rect">
+            <a:avLst/>
+          </a:prstGeom>
+          <a:noFill/>
+          <a:ln/>
+        </p:spPr>
+        <p:txBody>
+          <a:bodyPr wrap="square" lIns="0" tIns="0" rIns="0" bIns="0" rtlCol="0" anchor="ctr"/>
+          <a:lstStyle/>
+          <a:p>
+            <a:pPr algn="ctr" indent="0" marL="0">
+              <a:buNone/>
+            </a:pPr>
+            <a:r>
+              <a:rPr lang="en-US" sz="1300" dirty="0">
+                <a:solidFill>
+                  <a:srgbClr val="5B6770"/>
+                </a:solidFill>
+                <a:latin typeface="Arial" pitchFamily="34" charset="0"/>
+                <a:ea typeface="Arial" pitchFamily="34" charset="-122"/>
+                <a:cs typeface="Arial" pitchFamily="34" charset="-120"/>
+              </a:rPr>
+              <a:t>helyi partnerség (tanodák, családsegítők)</a:t>
+            </a:r>
+            <a:endParaRPr lang="en-US" sz="1300" dirty="0"/>
+          </a:p>
+        </p:txBody>
+      </p:sp>
+      <p:sp>
+        <p:nvSpPr>
+          <p:cNvPr id="17" name="Text 15"/>
+          <p:cNvSpPr/>
+          <p:nvPr/>
+        </p:nvSpPr>
+        <p:spPr>
+          <a:xfrm>
+            <a:off x="457200" y="3840480"/>
+            <a:ext cx="11247120" cy="411480"/>
+          </a:xfrm>
+          <a:prstGeom prst="rect">
+            <a:avLst/>
+          </a:prstGeom>
+          <a:noFill/>
+          <a:ln/>
+        </p:spPr>
+        <p:txBody>
+          <a:bodyPr wrap="square" lIns="0" tIns="0" rIns="0" bIns="0" rtlCol="0" anchor="ctr"/>
+          <a:lstStyle/>
+          <a:p>
+            <a:pPr indent="0" marL="0">
+              <a:buNone/>
+            </a:pPr>
+            <a:r>
+              <a:rPr lang="en-US" sz="1600" b="1" dirty="0">
+                <a:solidFill>
+                  <a:srgbClr val="1E3A5F"/>
+                </a:solidFill>
+                <a:latin typeface="Arial" pitchFamily="34" charset="0"/>
+                <a:ea typeface="Arial" pitchFamily="34" charset="-122"/>
+                <a:cs typeface="Arial" pitchFamily="34" charset="-120"/>
+              </a:rPr>
+              <a:t>Társadalmi megtérülés (SROI-logika):</a:t>
+            </a:r>
+            <a:endParaRPr lang="en-US" sz="1600" dirty="0"/>
+          </a:p>
+        </p:txBody>
+      </p:sp>
+      <p:sp>
+        <p:nvSpPr>
+          <p:cNvPr id="18" name="Text 16"/>
+          <p:cNvSpPr/>
+          <p:nvPr/>
+        </p:nvSpPr>
+        <p:spPr>
+          <a:xfrm>
+            <a:off x="640080" y="4297680"/>
+            <a:ext cx="10881360" cy="2011680"/>
+          </a:xfrm>
+          <a:prstGeom prst="rect">
+            <a:avLst/>
+          </a:prstGeom>
+          <a:noFill/>
+          <a:ln/>
+        </p:spPr>
+        <p:txBody>
+          <a:bodyPr wrap="square" lIns="0" tIns="0" rIns="0" bIns="0" rtlCol="0" anchor="ctr"/>
+          <a:lstStyle/>
+          <a:p>
+            <a:pPr marL="342900" indent="-342900">
+              <a:spcAft>
+                <a:spcPts val="800"/>
+              </a:spcAft>
+              <a:buSzPct val="100000"/>
+              <a:buChar char="•"/>
+            </a:pPr>
+            <a:r>
+              <a:rPr lang="en-US" sz="1400" dirty="0">
+                <a:solidFill>
+                  <a:srgbClr val="5B6770"/>
+                </a:solidFill>
+                <a:latin typeface="Arial" pitchFamily="34" charset="0"/>
+                <a:ea typeface="Arial" pitchFamily="34" charset="-122"/>
+                <a:cs typeface="Arial" pitchFamily="34" charset="-120"/>
+              </a:rPr>
+              <a:t>Egyetlen megelőzött droghasználói életút társadalmi megtakarítása több tízmillió forint.</a:t>
+            </a:r>
+            <a:endParaRPr lang="en-US" sz="1400" dirty="0"/>
+          </a:p>
+          <a:p>
+            <a:pPr marL="342900" indent="-342900">
+              <a:spcAft>
+                <a:spcPts val="800"/>
+              </a:spcAft>
+              <a:buSzPct val="100000"/>
+              <a:buChar char="•"/>
+            </a:pPr>
+            <a:r>
+              <a:rPr lang="en-US" sz="1400" dirty="0">
+                <a:solidFill>
+                  <a:srgbClr val="5B6770"/>
+                </a:solidFill>
+                <a:latin typeface="Arial" pitchFamily="34" charset="0"/>
+                <a:ea typeface="Arial" pitchFamily="34" charset="-122"/>
+                <a:cs typeface="Arial" pitchFamily="34" charset="-120"/>
+              </a:rPr>
+              <a:t>Egy megelőzött korai iskolaelhagyás életpálya-szinten többletadó-bevételt hoz és csökkenti a segélyfüggőséget.</a:t>
+            </a:r>
+            <a:endParaRPr lang="en-US" sz="1400" dirty="0"/>
+          </a:p>
+          <a:p>
+            <a:pPr marL="342900" indent="-342900">
+              <a:spcAft>
+                <a:spcPts val="800"/>
+              </a:spcAft>
+              <a:buSzPct val="100000"/>
+              <a:buChar char="•"/>
+            </a:pPr>
+            <a:r>
+              <a:rPr lang="en-US" sz="1400" dirty="0">
+                <a:solidFill>
+                  <a:srgbClr val="5B6770"/>
+                </a:solidFill>
+                <a:latin typeface="Arial" pitchFamily="34" charset="0"/>
+                <a:ea typeface="Arial" pitchFamily="34" charset="-122"/>
+                <a:cs typeface="Arial" pitchFamily="34" charset="-120"/>
+              </a:rPr>
+              <a:t>Egy uzsoracsapdából kimentett család: megőrzött lakhatás, elkerült gyermekvédelmi beavatkozás.</a:t>
+            </a:r>
+            <a:endParaRPr lang="en-US" sz="1400" dirty="0"/>
+          </a:p>
+          <a:p>
+            <a:pPr marL="342900" indent="-342900">
+              <a:buSzPct val="100000"/>
+              <a:buChar char="•"/>
+            </a:pPr>
+            <a:r>
+              <a:rPr lang="en-US" sz="1400" b="1" dirty="0">
+                <a:solidFill>
+                  <a:srgbClr val="1E3A5F"/>
+                </a:solidFill>
+                <a:latin typeface="Arial" pitchFamily="34" charset="0"/>
+                <a:ea typeface="Arial" pitchFamily="34" charset="-122"/>
+                <a:cs typeface="Arial" pitchFamily="34" charset="-120"/>
+              </a:rPr>
+              <a:t>Ha az elért 3 000 főből csak 2% (60 fő) esetében történik érdemi fordulat, a program társadalmi haszna már sokszorosan megtérül.</a:t>
+            </a:r>
+            <a:endParaRPr lang="en-US" sz="1400" dirty="0"/>
+          </a:p>
+        </p:txBody>
+      </p:sp>
+      <p:sp>
+        <p:nvSpPr>
           <p:cNvPr id="19" name="Text 17"/>
-          <p:cNvSpPr/>
-          <p:nvPr/>
-        </p:nvSpPr>
-        <p:spPr>
-          <a:xfrm>
-            <a:off x="8412480" y="1600200"/>
-            <a:ext cx="1920240" cy="384048"/>
-          </a:xfrm>
-          <a:prstGeom prst="rect">
-            <a:avLst/>
-          </a:prstGeom>
-          <a:noFill/>
-          <a:ln/>
-        </p:spPr>
-        <p:txBody>
-          <a:bodyPr wrap="square" lIns="0" tIns="0" rIns="0" bIns="0" rtlCol="0" anchor="ctr"/>
-          <a:lstStyle/>
-          <a:p>
-            <a:pPr algn="ctr" indent="0" marL="0">
-              <a:buNone/>
-            </a:pPr>
-            <a:r>
-              <a:rPr lang="en-US" sz="1100" b="1" dirty="0">
-                <a:solidFill>
-                  <a:srgbClr val="FFFFFF"/>
-                </a:solidFill>
-                <a:latin typeface="Arial" pitchFamily="34" charset="0"/>
-                <a:ea typeface="Arial" pitchFamily="34" charset="-122"/>
-                <a:cs typeface="Arial" pitchFamily="34" charset="-120"/>
-              </a:rPr>
-              <a:t>BGA + ERASMUS+</a:t>
-            </a:r>
-            <a:endParaRPr lang="en-US" sz="1100" dirty="0"/>
-          </a:p>
-        </p:txBody>
-      </p:sp>
-      <p:sp>
-        <p:nvSpPr>
-          <p:cNvPr id="20" name="Text 18"/>
-          <p:cNvSpPr/>
-          <p:nvPr/>
-        </p:nvSpPr>
-        <p:spPr>
-          <a:xfrm>
-            <a:off x="8412480" y="2148840"/>
-            <a:ext cx="3017520" cy="502920"/>
-          </a:xfrm>
-          <a:prstGeom prst="rect">
-            <a:avLst/>
-          </a:prstGeom>
-          <a:noFill/>
-          <a:ln/>
-        </p:spPr>
-        <p:txBody>
-          <a:bodyPr wrap="square" lIns="0" tIns="0" rIns="0" bIns="0" rtlCol="0" anchor="ctr"/>
-          <a:lstStyle/>
-          <a:p>
-            <a:pPr indent="0" marL="0">
-              <a:buNone/>
-            </a:pPr>
-            <a:r>
-              <a:rPr lang="en-US" sz="1700" b="1" dirty="0">
-                <a:solidFill>
-                  <a:srgbClr val="1E3A5F"/>
-                </a:solidFill>
-                <a:latin typeface="Arial" pitchFamily="34" charset="0"/>
-                <a:ea typeface="Arial" pitchFamily="34" charset="-122"/>
-                <a:cs typeface="Arial" pitchFamily="34" charset="-120"/>
-              </a:rPr>
-              <a:t>Határon túli források</a:t>
-            </a:r>
-            <a:endParaRPr lang="en-US" sz="1700" dirty="0"/>
-          </a:p>
-        </p:txBody>
-      </p:sp>
-      <p:sp>
-        <p:nvSpPr>
-          <p:cNvPr id="21" name="Text 19"/>
-          <p:cNvSpPr/>
-          <p:nvPr/>
-        </p:nvSpPr>
-        <p:spPr>
-          <a:xfrm>
-            <a:off x="8412480" y="2697480"/>
-            <a:ext cx="3017520" cy="1371600"/>
-          </a:xfrm>
-          <a:prstGeom prst="rect">
-            <a:avLst/>
-          </a:prstGeom>
-          <a:noFill/>
-          <a:ln/>
-        </p:spPr>
-        <p:txBody>
-          <a:bodyPr wrap="square" lIns="0" tIns="0" rIns="0" bIns="0" rtlCol="0" anchor="ctr"/>
-          <a:lstStyle/>
-          <a:p>
-            <a:pPr indent="0" marL="0">
-              <a:buNone/>
-            </a:pPr>
-            <a:r>
-              <a:rPr lang="en-US" sz="1250" dirty="0">
-                <a:solidFill>
-                  <a:srgbClr val="5B6770"/>
-                </a:solidFill>
-                <a:latin typeface="Arial" pitchFamily="34" charset="0"/>
-                <a:ea typeface="Arial" pitchFamily="34" charset="-122"/>
-                <a:cs typeface="Arial" pitchFamily="34" charset="-120"/>
-              </a:rPr>
-              <a:t>A 6 határon túli alkalom helyi költségeire a társrendező magyar intézmények Bethlen Gábor Alap-pályázatai (500e–2M Ft/szervezet); SK/RO helyszínekre Erasmus+ és CERV is.</a:t>
-            </a:r>
-            <a:endParaRPr lang="en-US" sz="1250" dirty="0"/>
-          </a:p>
-        </p:txBody>
-      </p:sp>
-      <p:sp>
-        <p:nvSpPr>
-          <p:cNvPr id="22" name="Text 20"/>
-          <p:cNvSpPr/>
-          <p:nvPr/>
-        </p:nvSpPr>
-        <p:spPr>
-          <a:xfrm>
-            <a:off x="8412480" y="4114800"/>
-            <a:ext cx="3017520" cy="502920"/>
-          </a:xfrm>
-          <a:prstGeom prst="rect">
-            <a:avLst/>
-          </a:prstGeom>
-          <a:noFill/>
-          <a:ln/>
-        </p:spPr>
-        <p:txBody>
-          <a:bodyPr wrap="square" lIns="0" tIns="0" rIns="0" bIns="0" rtlCol="0" anchor="ctr"/>
-          <a:lstStyle/>
-          <a:p>
-            <a:pPr indent="0" marL="0">
-              <a:buNone/>
-            </a:pPr>
-            <a:r>
-              <a:rPr lang="en-US" sz="1250" b="1" dirty="0">
-                <a:solidFill>
-                  <a:srgbClr val="D93025"/>
-                </a:solidFill>
-                <a:latin typeface="Arial" pitchFamily="34" charset="0"/>
-                <a:ea typeface="Arial" pitchFamily="34" charset="-122"/>
-                <a:cs typeface="Arial" pitchFamily="34" charset="-120"/>
-              </a:rPr>
-              <a:t>BGA: NIR-en, éves kiírások</a:t>
-            </a:r>
-            <a:endParaRPr lang="en-US" sz="1250" dirty="0"/>
-          </a:p>
-        </p:txBody>
-      </p:sp>
-      <p:sp>
-        <p:nvSpPr>
-          <p:cNvPr id="23" name="Shape 21"/>
-          <p:cNvSpPr/>
-          <p:nvPr/>
-        </p:nvSpPr>
-        <p:spPr>
-          <a:xfrm>
-            <a:off x="457200" y="5029200"/>
-            <a:ext cx="11247120" cy="1143000"/>
-          </a:xfrm>
-          <a:prstGeom prst="roundRect">
-            <a:avLst>
-              <a:gd name="adj" fmla="val 9600"/>
-            </a:avLst>
-          </a:prstGeom>
-          <a:solidFill>
-            <a:srgbClr val="1E3A5F"/>
-          </a:solidFill>
-          <a:ln/>
-        </p:spPr>
-      </p:sp>
-      <p:sp>
-        <p:nvSpPr>
-          <p:cNvPr id="24" name="Text 22"/>
-          <p:cNvSpPr/>
-          <p:nvPr/>
-        </p:nvSpPr>
-        <p:spPr>
-          <a:xfrm>
-            <a:off x="731520" y="5029200"/>
-            <a:ext cx="10698480" cy="1143000"/>
-          </a:xfrm>
-          <a:prstGeom prst="rect">
-            <a:avLst/>
-          </a:prstGeom>
-          <a:noFill/>
-          <a:ln/>
-        </p:spPr>
-        <p:txBody>
-          <a:bodyPr wrap="square" lIns="0" tIns="0" rIns="0" bIns="0" rtlCol="0" anchor="ctr"/>
-          <a:lstStyle/>
-          <a:p>
-            <a:pPr indent="0" marL="0">
-              <a:buNone/>
-            </a:pPr>
-            <a:r>
-              <a:rPr lang="en-US" sz="1500" b="1" dirty="0">
-                <a:solidFill>
-                  <a:srgbClr val="FFFFFF"/>
-                </a:solidFill>
-                <a:latin typeface="Arial" pitchFamily="34" charset="0"/>
-                <a:ea typeface="Arial" pitchFamily="34" charset="-122"/>
-                <a:cs typeface="Arial" pitchFamily="34" charset="-120"/>
-              </a:rPr>
-              <a:t>Finanszírozási szerkezet: </a:t>
-            </a:r>
-            <a:pPr indent="0" marL="0">
-              <a:buNone/>
-            </a:pPr>
-            <a:r>
-              <a:rPr lang="en-US" sz="1500" dirty="0">
-                <a:solidFill>
-                  <a:srgbClr val="CADCFC"/>
-                </a:solidFill>
-                <a:latin typeface="Arial" pitchFamily="34" charset="0"/>
-                <a:ea typeface="Arial" pitchFamily="34" charset="-122"/>
-                <a:cs typeface="Arial" pitchFamily="34" charset="-120"/>
-              </a:rPr>
-              <a:t>90% pályázati támogatás (~65,4 M Ft) + 10% önerő / CSR-szponzoráció (~7,3 M Ft). </a:t>
-            </a:r>
-            <a:pPr indent="0" marL="0">
-              <a:buNone/>
-            </a:pPr>
-            <a:r>
-              <a:rPr lang="en-US" sz="1500" i="1" dirty="0">
-                <a:solidFill>
-                  <a:srgbClr val="CADCFC"/>
-                </a:solidFill>
-                <a:latin typeface="Arial" pitchFamily="34" charset="0"/>
-                <a:ea typeface="Arial" pitchFamily="34" charset="-122"/>
-                <a:cs typeface="Arial" pitchFamily="34" charset="-120"/>
-              </a:rPr>
-              <a:t>Kiegészítés: ROVA – Roma for Change (max. 25 000 EUR) a kommunikációs modulra.</a:t>
-            </a:r>
-            <a:endParaRPr lang="en-US" sz="1500" dirty="0"/>
-          </a:p>
-        </p:txBody>
-      </p:sp>
-      <p:sp>
-        <p:nvSpPr>
-          <p:cNvPr id="25" name="Text 23"/>
           <p:cNvSpPr/>
           <p:nvPr/>
         </p:nvSpPr>
@@ -9012,7 +8924,7 @@
                 <a:ea typeface="Arial" pitchFamily="34" charset="-122"/>
                 <a:cs typeface="Arial" pitchFamily="34" charset="-120"/>
               </a:rPr>
-              <a:t>Mit várunk a 6 hónap végére?</a:t>
+              <a:t>Ütemterv és kockázatkezelés</a:t>
             </a:r>
             <a:endParaRPr lang="en-US" sz="3600" dirty="0"/>
           </a:p>
@@ -9073,7 +8985,7 @@
                 <a:ea typeface="Arial" pitchFamily="34" charset="-122"/>
                 <a:cs typeface="Arial" pitchFamily="34" charset="-120"/>
               </a:rPr>
-              <a:t>~2′</a:t>
+              <a:t>~1,5′</a:t>
             </a:r>
             <a:endParaRPr lang="en-US" sz="1300" dirty="0"/>
           </a:p>
@@ -9087,12 +8999,560 @@
         </p:nvSpPr>
         <p:spPr>
           <a:xfrm>
-            <a:off x="457200" y="1371600"/>
-            <a:ext cx="2606040" cy="2103120"/>
+            <a:off x="548640" y="1481328"/>
+            <a:ext cx="502920" cy="502920"/>
+          </a:xfrm>
+          <a:prstGeom prst="ellipse">
+            <a:avLst/>
+          </a:prstGeom>
+          <a:solidFill>
+            <a:srgbClr val="D93025"/>
+          </a:solidFill>
+          <a:ln/>
+        </p:spPr>
+      </p:sp>
+      <p:sp>
+        <p:nvSpPr>
+          <p:cNvPr id="6" name="Text 4"/>
+          <p:cNvSpPr/>
+          <p:nvPr/>
+        </p:nvSpPr>
+        <p:spPr>
+          <a:xfrm>
+            <a:off x="548640" y="1481328"/>
+            <a:ext cx="502920" cy="502920"/>
+          </a:xfrm>
+          <a:prstGeom prst="rect">
+            <a:avLst/>
+          </a:prstGeom>
+          <a:noFill/>
+          <a:ln/>
+        </p:spPr>
+        <p:txBody>
+          <a:bodyPr wrap="square" lIns="0" tIns="0" rIns="0" bIns="0" rtlCol="0" anchor="ctr"/>
+          <a:lstStyle/>
+          <a:p>
+            <a:pPr algn="ctr" indent="0" marL="0">
+              <a:buNone/>
+            </a:pPr>
+            <a:r>
+              <a:rPr lang="en-US" sz="1800" b="1" dirty="0">
+                <a:solidFill>
+                  <a:srgbClr val="FFFFFF"/>
+                </a:solidFill>
+                <a:latin typeface="Arial" pitchFamily="34" charset="0"/>
+                <a:ea typeface="Arial" pitchFamily="34" charset="-122"/>
+                <a:cs typeface="Arial" pitchFamily="34" charset="-120"/>
+              </a:rPr>
+              <a:t>1</a:t>
+            </a:r>
+            <a:endParaRPr lang="en-US" sz="1800" dirty="0"/>
+          </a:p>
+        </p:txBody>
+      </p:sp>
+      <p:sp>
+        <p:nvSpPr>
+          <p:cNvPr id="7" name="Text 5"/>
+          <p:cNvSpPr/>
+          <p:nvPr/>
+        </p:nvSpPr>
+        <p:spPr>
+          <a:xfrm>
+            <a:off x="1280160" y="1371600"/>
+            <a:ext cx="4206240" cy="411480"/>
+          </a:xfrm>
+          <a:prstGeom prst="rect">
+            <a:avLst/>
+          </a:prstGeom>
+          <a:noFill/>
+          <a:ln/>
+        </p:spPr>
+        <p:txBody>
+          <a:bodyPr wrap="square" lIns="0" tIns="0" rIns="0" bIns="0" rtlCol="0" anchor="ctr"/>
+          <a:lstStyle/>
+          <a:p>
+            <a:pPr indent="0" marL="0">
+              <a:buNone/>
+            </a:pPr>
+            <a:r>
+              <a:rPr lang="en-US" sz="1600" b="1" dirty="0">
+                <a:solidFill>
+                  <a:srgbClr val="1E3A5F"/>
+                </a:solidFill>
+                <a:latin typeface="Arial" pitchFamily="34" charset="0"/>
+                <a:ea typeface="Arial" pitchFamily="34" charset="-122"/>
+                <a:cs typeface="Arial" pitchFamily="34" charset="-120"/>
+              </a:rPr>
+              <a:t>0–2. hónap</a:t>
+            </a:r>
+            <a:endParaRPr lang="en-US" sz="1600" dirty="0"/>
+          </a:p>
+        </p:txBody>
+      </p:sp>
+      <p:sp>
+        <p:nvSpPr>
+          <p:cNvPr id="8" name="Text 6"/>
+          <p:cNvSpPr/>
+          <p:nvPr/>
+        </p:nvSpPr>
+        <p:spPr>
+          <a:xfrm>
+            <a:off x="1280160" y="1783080"/>
+            <a:ext cx="4480560" cy="640080"/>
+          </a:xfrm>
+          <a:prstGeom prst="rect">
+            <a:avLst/>
+          </a:prstGeom>
+          <a:noFill/>
+          <a:ln/>
+        </p:spPr>
+        <p:txBody>
+          <a:bodyPr wrap="square" lIns="0" tIns="0" rIns="0" bIns="0" rtlCol="0" anchor="ctr"/>
+          <a:lstStyle/>
+          <a:p>
+            <a:pPr indent="0" marL="0">
+              <a:buNone/>
+            </a:pPr>
+            <a:r>
+              <a:rPr lang="en-US" sz="1250" dirty="0">
+                <a:solidFill>
+                  <a:srgbClr val="5B6770"/>
+                </a:solidFill>
+                <a:latin typeface="Arial" pitchFamily="34" charset="0"/>
+                <a:ea typeface="Arial" pitchFamily="34" charset="-122"/>
+                <a:cs typeface="Arial" pitchFamily="34" charset="-120"/>
+              </a:rPr>
+              <a:t>Pályázat beadása (2026. szept. 30.), partneri és nagyköveti szerződések</a:t>
+            </a:r>
+            <a:endParaRPr lang="en-US" sz="1250" dirty="0"/>
+          </a:p>
+        </p:txBody>
+      </p:sp>
+      <p:sp>
+        <p:nvSpPr>
+          <p:cNvPr id="9" name="Shape 7"/>
+          <p:cNvSpPr/>
+          <p:nvPr/>
+        </p:nvSpPr>
+        <p:spPr>
+          <a:xfrm>
+            <a:off x="548640" y="2670048"/>
+            <a:ext cx="502920" cy="502920"/>
+          </a:xfrm>
+          <a:prstGeom prst="ellipse">
+            <a:avLst/>
+          </a:prstGeom>
+          <a:solidFill>
+            <a:srgbClr val="D93025"/>
+          </a:solidFill>
+          <a:ln/>
+        </p:spPr>
+      </p:sp>
+      <p:sp>
+        <p:nvSpPr>
+          <p:cNvPr id="10" name="Text 8"/>
+          <p:cNvSpPr/>
+          <p:nvPr/>
+        </p:nvSpPr>
+        <p:spPr>
+          <a:xfrm>
+            <a:off x="548640" y="2670048"/>
+            <a:ext cx="502920" cy="502920"/>
+          </a:xfrm>
+          <a:prstGeom prst="rect">
+            <a:avLst/>
+          </a:prstGeom>
+          <a:noFill/>
+          <a:ln/>
+        </p:spPr>
+        <p:txBody>
+          <a:bodyPr wrap="square" lIns="0" tIns="0" rIns="0" bIns="0" rtlCol="0" anchor="ctr"/>
+          <a:lstStyle/>
+          <a:p>
+            <a:pPr algn="ctr" indent="0" marL="0">
+              <a:buNone/>
+            </a:pPr>
+            <a:r>
+              <a:rPr lang="en-US" sz="1800" b="1" dirty="0">
+                <a:solidFill>
+                  <a:srgbClr val="FFFFFF"/>
+                </a:solidFill>
+                <a:latin typeface="Arial" pitchFamily="34" charset="0"/>
+                <a:ea typeface="Arial" pitchFamily="34" charset="-122"/>
+                <a:cs typeface="Arial" pitchFamily="34" charset="-120"/>
+              </a:rPr>
+              <a:t>2</a:t>
+            </a:r>
+            <a:endParaRPr lang="en-US" sz="1800" dirty="0"/>
+          </a:p>
+        </p:txBody>
+      </p:sp>
+      <p:sp>
+        <p:nvSpPr>
+          <p:cNvPr id="11" name="Text 9"/>
+          <p:cNvSpPr/>
+          <p:nvPr/>
+        </p:nvSpPr>
+        <p:spPr>
+          <a:xfrm>
+            <a:off x="1280160" y="2560320"/>
+            <a:ext cx="4206240" cy="411480"/>
+          </a:xfrm>
+          <a:prstGeom prst="rect">
+            <a:avLst/>
+          </a:prstGeom>
+          <a:noFill/>
+          <a:ln/>
+        </p:spPr>
+        <p:txBody>
+          <a:bodyPr wrap="square" lIns="0" tIns="0" rIns="0" bIns="0" rtlCol="0" anchor="ctr"/>
+          <a:lstStyle/>
+          <a:p>
+            <a:pPr indent="0" marL="0">
+              <a:buNone/>
+            </a:pPr>
+            <a:r>
+              <a:rPr lang="en-US" sz="1600" b="1" dirty="0">
+                <a:solidFill>
+                  <a:srgbClr val="1E3A5F"/>
+                </a:solidFill>
+                <a:latin typeface="Arial" pitchFamily="34" charset="0"/>
+                <a:ea typeface="Arial" pitchFamily="34" charset="-122"/>
+                <a:cs typeface="Arial" pitchFamily="34" charset="-120"/>
+              </a:rPr>
+              <a:t>3. hónap</a:t>
+            </a:r>
+            <a:endParaRPr lang="en-US" sz="1600" dirty="0"/>
+          </a:p>
+        </p:txBody>
+      </p:sp>
+      <p:sp>
+        <p:nvSpPr>
+          <p:cNvPr id="12" name="Text 10"/>
+          <p:cNvSpPr/>
+          <p:nvPr/>
+        </p:nvSpPr>
+        <p:spPr>
+          <a:xfrm>
+            <a:off x="1280160" y="2971800"/>
+            <a:ext cx="4480560" cy="640080"/>
+          </a:xfrm>
+          <a:prstGeom prst="rect">
+            <a:avLst/>
+          </a:prstGeom>
+          <a:noFill/>
+          <a:ln/>
+        </p:spPr>
+        <p:txBody>
+          <a:bodyPr wrap="square" lIns="0" tIns="0" rIns="0" bIns="0" rtlCol="0" anchor="ctr"/>
+          <a:lstStyle/>
+          <a:p>
+            <a:pPr indent="0" marL="0">
+              <a:buNone/>
+            </a:pPr>
+            <a:r>
+              <a:rPr lang="en-US" sz="1250" dirty="0">
+                <a:solidFill>
+                  <a:srgbClr val="5B6770"/>
+                </a:solidFill>
+                <a:latin typeface="Arial" pitchFamily="34" charset="0"/>
+                <a:ea typeface="Arial" pitchFamily="34" charset="-122"/>
+                <a:cs typeface="Arial" pitchFamily="34" charset="-120"/>
+              </a:rPr>
+              <a:t>Előkészítés: helyszínfoglalás, toborzás, kampányindítás</a:t>
+            </a:r>
+            <a:endParaRPr lang="en-US" sz="1250" dirty="0"/>
+          </a:p>
+        </p:txBody>
+      </p:sp>
+      <p:sp>
+        <p:nvSpPr>
+          <p:cNvPr id="13" name="Shape 11"/>
+          <p:cNvSpPr/>
+          <p:nvPr/>
+        </p:nvSpPr>
+        <p:spPr>
+          <a:xfrm>
+            <a:off x="548640" y="3858768"/>
+            <a:ext cx="502920" cy="502920"/>
+          </a:xfrm>
+          <a:prstGeom prst="ellipse">
+            <a:avLst/>
+          </a:prstGeom>
+          <a:solidFill>
+            <a:srgbClr val="D93025"/>
+          </a:solidFill>
+          <a:ln/>
+        </p:spPr>
+      </p:sp>
+      <p:sp>
+        <p:nvSpPr>
+          <p:cNvPr id="14" name="Text 12"/>
+          <p:cNvSpPr/>
+          <p:nvPr/>
+        </p:nvSpPr>
+        <p:spPr>
+          <a:xfrm>
+            <a:off x="548640" y="3858768"/>
+            <a:ext cx="502920" cy="502920"/>
+          </a:xfrm>
+          <a:prstGeom prst="rect">
+            <a:avLst/>
+          </a:prstGeom>
+          <a:noFill/>
+          <a:ln/>
+        </p:spPr>
+        <p:txBody>
+          <a:bodyPr wrap="square" lIns="0" tIns="0" rIns="0" bIns="0" rtlCol="0" anchor="ctr"/>
+          <a:lstStyle/>
+          <a:p>
+            <a:pPr algn="ctr" indent="0" marL="0">
+              <a:buNone/>
+            </a:pPr>
+            <a:r>
+              <a:rPr lang="en-US" sz="1800" b="1" dirty="0">
+                <a:solidFill>
+                  <a:srgbClr val="FFFFFF"/>
+                </a:solidFill>
+                <a:latin typeface="Arial" pitchFamily="34" charset="0"/>
+                <a:ea typeface="Arial" pitchFamily="34" charset="-122"/>
+                <a:cs typeface="Arial" pitchFamily="34" charset="-120"/>
+              </a:rPr>
+              <a:t>3</a:t>
+            </a:r>
+            <a:endParaRPr lang="en-US" sz="1800" dirty="0"/>
+          </a:p>
+        </p:txBody>
+      </p:sp>
+      <p:sp>
+        <p:nvSpPr>
+          <p:cNvPr id="15" name="Text 13"/>
+          <p:cNvSpPr/>
+          <p:nvPr/>
+        </p:nvSpPr>
+        <p:spPr>
+          <a:xfrm>
+            <a:off x="1280160" y="3749040"/>
+            <a:ext cx="4206240" cy="411480"/>
+          </a:xfrm>
+          <a:prstGeom prst="rect">
+            <a:avLst/>
+          </a:prstGeom>
+          <a:noFill/>
+          <a:ln/>
+        </p:spPr>
+        <p:txBody>
+          <a:bodyPr wrap="square" lIns="0" tIns="0" rIns="0" bIns="0" rtlCol="0" anchor="ctr"/>
+          <a:lstStyle/>
+          <a:p>
+            <a:pPr indent="0" marL="0">
+              <a:buNone/>
+            </a:pPr>
+            <a:r>
+              <a:rPr lang="en-US" sz="1600" b="1" dirty="0">
+                <a:solidFill>
+                  <a:srgbClr val="1E3A5F"/>
+                </a:solidFill>
+                <a:latin typeface="Arial" pitchFamily="34" charset="0"/>
+                <a:ea typeface="Arial" pitchFamily="34" charset="-122"/>
+                <a:cs typeface="Arial" pitchFamily="34" charset="-120"/>
+              </a:rPr>
+              <a:t>4–9. hónap</a:t>
+            </a:r>
+            <a:endParaRPr lang="en-US" sz="1600" dirty="0"/>
+          </a:p>
+        </p:txBody>
+      </p:sp>
+      <p:sp>
+        <p:nvSpPr>
+          <p:cNvPr id="16" name="Text 14"/>
+          <p:cNvSpPr/>
+          <p:nvPr/>
+        </p:nvSpPr>
+        <p:spPr>
+          <a:xfrm>
+            <a:off x="1280160" y="4160520"/>
+            <a:ext cx="4480560" cy="640080"/>
+          </a:xfrm>
+          <a:prstGeom prst="rect">
+            <a:avLst/>
+          </a:prstGeom>
+          <a:noFill/>
+          <a:ln/>
+        </p:spPr>
+        <p:txBody>
+          <a:bodyPr wrap="square" lIns="0" tIns="0" rIns="0" bIns="0" rtlCol="0" anchor="ctr"/>
+          <a:lstStyle/>
+          <a:p>
+            <a:pPr indent="0" marL="0">
+              <a:buNone/>
+            </a:pPr>
+            <a:r>
+              <a:rPr lang="en-US" sz="1250" dirty="0">
+                <a:solidFill>
+                  <a:srgbClr val="5B6770"/>
+                </a:solidFill>
+                <a:latin typeface="Arial" pitchFamily="34" charset="0"/>
+                <a:ea typeface="Arial" pitchFamily="34" charset="-122"/>
+                <a:cs typeface="Arial" pitchFamily="34" charset="-120"/>
+              </a:rPr>
+              <a:t>A 12 alkalom megvalósítása, kéthetente</a:t>
+            </a:r>
+            <a:endParaRPr lang="en-US" sz="1250" dirty="0"/>
+          </a:p>
+        </p:txBody>
+      </p:sp>
+      <p:sp>
+        <p:nvSpPr>
+          <p:cNvPr id="17" name="Shape 15"/>
+          <p:cNvSpPr/>
+          <p:nvPr/>
+        </p:nvSpPr>
+        <p:spPr>
+          <a:xfrm>
+            <a:off x="548640" y="5047488"/>
+            <a:ext cx="502920" cy="502920"/>
+          </a:xfrm>
+          <a:prstGeom prst="ellipse">
+            <a:avLst/>
+          </a:prstGeom>
+          <a:solidFill>
+            <a:srgbClr val="D93025"/>
+          </a:solidFill>
+          <a:ln/>
+        </p:spPr>
+      </p:sp>
+      <p:sp>
+        <p:nvSpPr>
+          <p:cNvPr id="18" name="Text 16"/>
+          <p:cNvSpPr/>
+          <p:nvPr/>
+        </p:nvSpPr>
+        <p:spPr>
+          <a:xfrm>
+            <a:off x="548640" y="5047488"/>
+            <a:ext cx="502920" cy="502920"/>
+          </a:xfrm>
+          <a:prstGeom prst="rect">
+            <a:avLst/>
+          </a:prstGeom>
+          <a:noFill/>
+          <a:ln/>
+        </p:spPr>
+        <p:txBody>
+          <a:bodyPr wrap="square" lIns="0" tIns="0" rIns="0" bIns="0" rtlCol="0" anchor="ctr"/>
+          <a:lstStyle/>
+          <a:p>
+            <a:pPr algn="ctr" indent="0" marL="0">
+              <a:buNone/>
+            </a:pPr>
+            <a:r>
+              <a:rPr lang="en-US" sz="1800" b="1" dirty="0">
+                <a:solidFill>
+                  <a:srgbClr val="FFFFFF"/>
+                </a:solidFill>
+                <a:latin typeface="Arial" pitchFamily="34" charset="0"/>
+                <a:ea typeface="Arial" pitchFamily="34" charset="-122"/>
+                <a:cs typeface="Arial" pitchFamily="34" charset="-120"/>
+              </a:rPr>
+              <a:t>4</a:t>
+            </a:r>
+            <a:endParaRPr lang="en-US" sz="1800" dirty="0"/>
+          </a:p>
+        </p:txBody>
+      </p:sp>
+      <p:sp>
+        <p:nvSpPr>
+          <p:cNvPr id="19" name="Text 17"/>
+          <p:cNvSpPr/>
+          <p:nvPr/>
+        </p:nvSpPr>
+        <p:spPr>
+          <a:xfrm>
+            <a:off x="1280160" y="4937760"/>
+            <a:ext cx="4206240" cy="411480"/>
+          </a:xfrm>
+          <a:prstGeom prst="rect">
+            <a:avLst/>
+          </a:prstGeom>
+          <a:noFill/>
+          <a:ln/>
+        </p:spPr>
+        <p:txBody>
+          <a:bodyPr wrap="square" lIns="0" tIns="0" rIns="0" bIns="0" rtlCol="0" anchor="ctr"/>
+          <a:lstStyle/>
+          <a:p>
+            <a:pPr indent="0" marL="0">
+              <a:buNone/>
+            </a:pPr>
+            <a:r>
+              <a:rPr lang="en-US" sz="1600" b="1" dirty="0">
+                <a:solidFill>
+                  <a:srgbClr val="1E3A5F"/>
+                </a:solidFill>
+                <a:latin typeface="Arial" pitchFamily="34" charset="0"/>
+                <a:ea typeface="Arial" pitchFamily="34" charset="-122"/>
+                <a:cs typeface="Arial" pitchFamily="34" charset="-120"/>
+              </a:rPr>
+              <a:t>10. hónap</a:t>
+            </a:r>
+            <a:endParaRPr lang="en-US" sz="1600" dirty="0"/>
+          </a:p>
+        </p:txBody>
+      </p:sp>
+      <p:sp>
+        <p:nvSpPr>
+          <p:cNvPr id="20" name="Text 18"/>
+          <p:cNvSpPr/>
+          <p:nvPr/>
+        </p:nvSpPr>
+        <p:spPr>
+          <a:xfrm>
+            <a:off x="1280160" y="5349240"/>
+            <a:ext cx="4480560" cy="640080"/>
+          </a:xfrm>
+          <a:prstGeom prst="rect">
+            <a:avLst/>
+          </a:prstGeom>
+          <a:noFill/>
+          <a:ln/>
+        </p:spPr>
+        <p:txBody>
+          <a:bodyPr wrap="square" lIns="0" tIns="0" rIns="0" bIns="0" rtlCol="0" anchor="ctr"/>
+          <a:lstStyle/>
+          <a:p>
+            <a:pPr indent="0" marL="0">
+              <a:buNone/>
+            </a:pPr>
+            <a:r>
+              <a:rPr lang="en-US" sz="1250" dirty="0">
+                <a:solidFill>
+                  <a:srgbClr val="5B6770"/>
+                </a:solidFill>
+                <a:latin typeface="Arial" pitchFamily="34" charset="0"/>
+                <a:ea typeface="Arial" pitchFamily="34" charset="-122"/>
+                <a:cs typeface="Arial" pitchFamily="34" charset="-120"/>
+              </a:rPr>
+              <a:t>Hatásmérés, záró rendezvény, beszámoló, folytatási javaslat</a:t>
+            </a:r>
+            <a:endParaRPr lang="en-US" sz="1250" dirty="0"/>
+          </a:p>
+        </p:txBody>
+      </p:sp>
+      <p:sp>
+        <p:nvSpPr>
+          <p:cNvPr id="21" name="Shape 19"/>
+          <p:cNvSpPr/>
+          <p:nvPr/>
+        </p:nvSpPr>
+        <p:spPr>
+          <a:xfrm>
+            <a:off x="6217920" y="1371600"/>
+            <a:ext cx="5486400" cy="4663440"/>
           </a:xfrm>
           <a:prstGeom prst="roundRect">
             <a:avLst>
-              <a:gd name="adj" fmla="val 5217"/>
+              <a:gd name="adj" fmla="val 2353"/>
             </a:avLst>
           </a:prstGeom>
           <a:solidFill>
@@ -9103,330 +9563,30 @@
       </p:sp>
       <p:sp>
         <p:nvSpPr>
-          <p:cNvPr id="6" name="Text 4"/>
-          <p:cNvSpPr/>
-          <p:nvPr/>
-        </p:nvSpPr>
-        <p:spPr>
-          <a:xfrm>
-            <a:off x="457200" y="1600200"/>
-            <a:ext cx="2606040" cy="914400"/>
-          </a:xfrm>
-          <a:prstGeom prst="rect">
-            <a:avLst/>
-          </a:prstGeom>
-          <a:noFill/>
-          <a:ln/>
-        </p:spPr>
-        <p:txBody>
-          <a:bodyPr wrap="square" lIns="0" tIns="0" rIns="0" bIns="0" rtlCol="0" anchor="ctr"/>
-          <a:lstStyle/>
-          <a:p>
-            <a:pPr algn="ctr" indent="0" marL="0">
-              <a:buNone/>
-            </a:pPr>
-            <a:r>
-              <a:rPr lang="en-US" sz="4400" b="1" dirty="0">
-                <a:solidFill>
-                  <a:srgbClr val="D93025"/>
-                </a:solidFill>
-                <a:latin typeface="Arial" pitchFamily="34" charset="0"/>
-                <a:ea typeface="Arial" pitchFamily="34" charset="-122"/>
-                <a:cs typeface="Arial" pitchFamily="34" charset="-120"/>
-              </a:rPr>
-              <a:t>3 000+</a:t>
-            </a:r>
-            <a:endParaRPr lang="en-US" sz="4400" dirty="0"/>
-          </a:p>
-        </p:txBody>
-      </p:sp>
-      <p:sp>
-        <p:nvSpPr>
-          <p:cNvPr id="7" name="Text 5"/>
-          <p:cNvSpPr/>
-          <p:nvPr/>
-        </p:nvSpPr>
-        <p:spPr>
-          <a:xfrm>
-            <a:off x="640080" y="2560320"/>
-            <a:ext cx="2240280" cy="822960"/>
-          </a:xfrm>
-          <a:prstGeom prst="rect">
-            <a:avLst/>
-          </a:prstGeom>
-          <a:noFill/>
-          <a:ln/>
-        </p:spPr>
-        <p:txBody>
-          <a:bodyPr wrap="square" lIns="0" tIns="0" rIns="0" bIns="0" rtlCol="0" anchor="ctr"/>
-          <a:lstStyle/>
-          <a:p>
-            <a:pPr algn="ctr" indent="0" marL="0">
-              <a:buNone/>
-            </a:pPr>
-            <a:r>
-              <a:rPr lang="en-US" sz="1300" dirty="0">
-                <a:solidFill>
-                  <a:srgbClr val="5B6770"/>
-                </a:solidFill>
-                <a:latin typeface="Arial" pitchFamily="34" charset="0"/>
-                <a:ea typeface="Arial" pitchFamily="34" charset="-122"/>
-                <a:cs typeface="Arial" pitchFamily="34" charset="-120"/>
-              </a:rPr>
-              <a:t>elért gyerek és családtag a 12 helyszínen</a:t>
-            </a:r>
-            <a:endParaRPr lang="en-US" sz="1300" dirty="0"/>
-          </a:p>
-        </p:txBody>
-      </p:sp>
-      <p:sp>
-        <p:nvSpPr>
-          <p:cNvPr id="8" name="Shape 6"/>
-          <p:cNvSpPr/>
-          <p:nvPr/>
-        </p:nvSpPr>
-        <p:spPr>
-          <a:xfrm>
-            <a:off x="3337560" y="1371600"/>
-            <a:ext cx="2606040" cy="2103120"/>
-          </a:xfrm>
-          <a:prstGeom prst="roundRect">
-            <a:avLst>
-              <a:gd name="adj" fmla="val 5217"/>
-            </a:avLst>
-          </a:prstGeom>
-          <a:solidFill>
-            <a:srgbClr val="F4F7FA"/>
-          </a:solidFill>
-          <a:ln/>
-        </p:spPr>
-      </p:sp>
-      <p:sp>
-        <p:nvSpPr>
-          <p:cNvPr id="9" name="Text 7"/>
-          <p:cNvSpPr/>
-          <p:nvPr/>
-        </p:nvSpPr>
-        <p:spPr>
-          <a:xfrm>
-            <a:off x="3337560" y="1600200"/>
-            <a:ext cx="2606040" cy="914400"/>
-          </a:xfrm>
-          <a:prstGeom prst="rect">
-            <a:avLst/>
-          </a:prstGeom>
-          <a:noFill/>
-          <a:ln/>
-        </p:spPr>
-        <p:txBody>
-          <a:bodyPr wrap="square" lIns="0" tIns="0" rIns="0" bIns="0" rtlCol="0" anchor="ctr"/>
-          <a:lstStyle/>
-          <a:p>
-            <a:pPr algn="ctr" indent="0" marL="0">
-              <a:buNone/>
-            </a:pPr>
-            <a:r>
-              <a:rPr lang="en-US" sz="4400" b="1" dirty="0">
-                <a:solidFill>
-                  <a:srgbClr val="1B6CA8"/>
-                </a:solidFill>
-                <a:latin typeface="Arial" pitchFamily="34" charset="0"/>
-                <a:ea typeface="Arial" pitchFamily="34" charset="-122"/>
-                <a:cs typeface="Arial" pitchFamily="34" charset="-120"/>
-              </a:rPr>
-              <a:t>1 M+</a:t>
-            </a:r>
-            <a:endParaRPr lang="en-US" sz="4400" dirty="0"/>
-          </a:p>
-        </p:txBody>
-      </p:sp>
-      <p:sp>
-        <p:nvSpPr>
-          <p:cNvPr id="10" name="Text 8"/>
-          <p:cNvSpPr/>
-          <p:nvPr/>
-        </p:nvSpPr>
-        <p:spPr>
-          <a:xfrm>
-            <a:off x="3520440" y="2560320"/>
-            <a:ext cx="2240280" cy="822960"/>
-          </a:xfrm>
-          <a:prstGeom prst="rect">
-            <a:avLst/>
-          </a:prstGeom>
-          <a:noFill/>
-          <a:ln/>
-        </p:spPr>
-        <p:txBody>
-          <a:bodyPr wrap="square" lIns="0" tIns="0" rIns="0" bIns="0" rtlCol="0" anchor="ctr"/>
-          <a:lstStyle/>
-          <a:p>
-            <a:pPr algn="ctr" indent="0" marL="0">
-              <a:buNone/>
-            </a:pPr>
-            <a:r>
-              <a:rPr lang="en-US" sz="1300" dirty="0">
-                <a:solidFill>
-                  <a:srgbClr val="5B6770"/>
-                </a:solidFill>
-                <a:latin typeface="Arial" pitchFamily="34" charset="0"/>
-                <a:ea typeface="Arial" pitchFamily="34" charset="-122"/>
-                <a:cs typeface="Arial" pitchFamily="34" charset="-120"/>
-              </a:rPr>
-              <a:t>online megtekintés a nagykövet csatornáin</a:t>
-            </a:r>
-            <a:endParaRPr lang="en-US" sz="1300" dirty="0"/>
-          </a:p>
-        </p:txBody>
-      </p:sp>
-      <p:sp>
-        <p:nvSpPr>
-          <p:cNvPr id="11" name="Shape 9"/>
-          <p:cNvSpPr/>
-          <p:nvPr/>
-        </p:nvSpPr>
-        <p:spPr>
-          <a:xfrm>
-            <a:off x="6217920" y="1371600"/>
-            <a:ext cx="2606040" cy="2103120"/>
-          </a:xfrm>
-          <a:prstGeom prst="roundRect">
-            <a:avLst>
-              <a:gd name="adj" fmla="val 5217"/>
-            </a:avLst>
-          </a:prstGeom>
-          <a:solidFill>
-            <a:srgbClr val="F4F7FA"/>
-          </a:solidFill>
-          <a:ln/>
-        </p:spPr>
-      </p:sp>
-      <p:sp>
-        <p:nvSpPr>
-          <p:cNvPr id="12" name="Text 10"/>
-          <p:cNvSpPr/>
-          <p:nvPr/>
-        </p:nvSpPr>
-        <p:spPr>
-          <a:xfrm>
-            <a:off x="6217920" y="1600200"/>
-            <a:ext cx="2606040" cy="914400"/>
-          </a:xfrm>
-          <a:prstGeom prst="rect">
-            <a:avLst/>
-          </a:prstGeom>
-          <a:noFill/>
-          <a:ln/>
-        </p:spPr>
-        <p:txBody>
-          <a:bodyPr wrap="square" lIns="0" tIns="0" rIns="0" bIns="0" rtlCol="0" anchor="ctr"/>
-          <a:lstStyle/>
-          <a:p>
-            <a:pPr algn="ctr" indent="0" marL="0">
-              <a:buNone/>
-            </a:pPr>
-            <a:r>
-              <a:rPr lang="en-US" sz="4400" b="1" dirty="0">
-                <a:solidFill>
-                  <a:srgbClr val="237547"/>
-                </a:solidFill>
-                <a:latin typeface="Arial" pitchFamily="34" charset="0"/>
-                <a:ea typeface="Arial" pitchFamily="34" charset="-122"/>
-                <a:cs typeface="Arial" pitchFamily="34" charset="-120"/>
-              </a:rPr>
-              <a:t>+30%</a:t>
-            </a:r>
-            <a:endParaRPr lang="en-US" sz="4400" dirty="0"/>
-          </a:p>
-        </p:txBody>
-      </p:sp>
-      <p:sp>
-        <p:nvSpPr>
-          <p:cNvPr id="13" name="Text 11"/>
-          <p:cNvSpPr/>
-          <p:nvPr/>
-        </p:nvSpPr>
-        <p:spPr>
-          <a:xfrm>
-            <a:off x="6400800" y="2560320"/>
-            <a:ext cx="2240280" cy="822960"/>
-          </a:xfrm>
-          <a:prstGeom prst="rect">
-            <a:avLst/>
-          </a:prstGeom>
-          <a:noFill/>
-          <a:ln/>
-        </p:spPr>
-        <p:txBody>
-          <a:bodyPr wrap="square" lIns="0" tIns="0" rIns="0" bIns="0" rtlCol="0" anchor="ctr"/>
-          <a:lstStyle/>
-          <a:p>
-            <a:pPr algn="ctr" indent="0" marL="0">
-              <a:buNone/>
-            </a:pPr>
-            <a:r>
-              <a:rPr lang="en-US" sz="1300" dirty="0">
-                <a:solidFill>
-                  <a:srgbClr val="5B6770"/>
-                </a:solidFill>
-                <a:latin typeface="Arial" pitchFamily="34" charset="0"/>
-                <a:ea typeface="Arial" pitchFamily="34" charset="-122"/>
-                <a:cs typeface="Arial" pitchFamily="34" charset="-120"/>
-              </a:rPr>
-              <a:t>kockázat-ismereti szint növekedés (elő-/utómérés)</a:t>
-            </a:r>
-            <a:endParaRPr lang="en-US" sz="1300" dirty="0"/>
-          </a:p>
-        </p:txBody>
-      </p:sp>
-      <p:sp>
-        <p:nvSpPr>
-          <p:cNvPr id="14" name="Shape 12"/>
-          <p:cNvSpPr/>
-          <p:nvPr/>
-        </p:nvSpPr>
-        <p:spPr>
-          <a:xfrm>
-            <a:off x="9098280" y="1371600"/>
-            <a:ext cx="2606040" cy="2103120"/>
-          </a:xfrm>
-          <a:prstGeom prst="roundRect">
-            <a:avLst>
-              <a:gd name="adj" fmla="val 5217"/>
-            </a:avLst>
-          </a:prstGeom>
-          <a:solidFill>
-            <a:srgbClr val="F4F7FA"/>
-          </a:solidFill>
-          <a:ln/>
-        </p:spPr>
-      </p:sp>
-      <p:sp>
-        <p:nvSpPr>
-          <p:cNvPr id="15" name="Text 13"/>
-          <p:cNvSpPr/>
-          <p:nvPr/>
-        </p:nvSpPr>
-        <p:spPr>
-          <a:xfrm>
-            <a:off x="9098280" y="1600200"/>
-            <a:ext cx="2606040" cy="914400"/>
-          </a:xfrm>
-          <a:prstGeom prst="rect">
-            <a:avLst/>
-          </a:prstGeom>
-          <a:noFill/>
-          <a:ln/>
-        </p:spPr>
-        <p:txBody>
-          <a:bodyPr wrap="square" lIns="0" tIns="0" rIns="0" bIns="0" rtlCol="0" anchor="ctr"/>
-          <a:lstStyle/>
-          <a:p>
-            <a:pPr algn="ctr" indent="0" marL="0">
-              <a:buNone/>
-            </a:pPr>
-            <a:r>
-              <a:rPr lang="en-US" sz="4400" b="1" dirty="0">
+          <p:cNvPr id="22" name="Text 20"/>
+          <p:cNvSpPr/>
+          <p:nvPr/>
+        </p:nvSpPr>
+        <p:spPr>
+          <a:xfrm>
+            <a:off x="6492240" y="1600200"/>
+            <a:ext cx="4937760" cy="411480"/>
+          </a:xfrm>
+          <a:prstGeom prst="rect">
+            <a:avLst/>
+          </a:prstGeom>
+          <a:noFill/>
+          <a:ln/>
+        </p:spPr>
+        <p:txBody>
+          <a:bodyPr wrap="square" lIns="0" tIns="0" rIns="0" bIns="0" rtlCol="0" anchor="ctr"/>
+          <a:lstStyle/>
+          <a:p>
+            <a:pPr indent="0" marL="0">
+              <a:buNone/>
+            </a:pPr>
+            <a:r>
+              <a:rPr lang="en-US" sz="1600" b="1" dirty="0">
                 <a:solidFill>
                   <a:srgbClr val="1E3A5F"/>
                 </a:solidFill>
@@ -9434,85 +9594,7 @@
                 <a:ea typeface="Arial" pitchFamily="34" charset="-122"/>
                 <a:cs typeface="Arial" pitchFamily="34" charset="-120"/>
               </a:rPr>
-              <a:t>24+</a:t>
-            </a:r>
-            <a:endParaRPr lang="en-US" sz="4400" dirty="0"/>
-          </a:p>
-        </p:txBody>
-      </p:sp>
-      <p:sp>
-        <p:nvSpPr>
-          <p:cNvPr id="16" name="Text 14"/>
-          <p:cNvSpPr/>
-          <p:nvPr/>
-        </p:nvSpPr>
-        <p:spPr>
-          <a:xfrm>
-            <a:off x="9281160" y="2560320"/>
-            <a:ext cx="2240280" cy="822960"/>
-          </a:xfrm>
-          <a:prstGeom prst="rect">
-            <a:avLst/>
-          </a:prstGeom>
-          <a:noFill/>
-          <a:ln/>
-        </p:spPr>
-        <p:txBody>
-          <a:bodyPr wrap="square" lIns="0" tIns="0" rIns="0" bIns="0" rtlCol="0" anchor="ctr"/>
-          <a:lstStyle/>
-          <a:p>
-            <a:pPr algn="ctr" indent="0" marL="0">
-              <a:buNone/>
-            </a:pPr>
-            <a:r>
-              <a:rPr lang="en-US" sz="1300" dirty="0">
-                <a:solidFill>
-                  <a:srgbClr val="5B6770"/>
-                </a:solidFill>
-                <a:latin typeface="Arial" pitchFamily="34" charset="0"/>
-                <a:ea typeface="Arial" pitchFamily="34" charset="-122"/>
-                <a:cs typeface="Arial" pitchFamily="34" charset="-120"/>
-              </a:rPr>
-              <a:t>helyi partnerség (tanodák, családsegítők)</a:t>
-            </a:r>
-            <a:endParaRPr lang="en-US" sz="1300" dirty="0"/>
-          </a:p>
-        </p:txBody>
-      </p:sp>
-      <p:sp>
-        <p:nvSpPr>
-          <p:cNvPr id="17" name="Text 15"/>
-          <p:cNvSpPr/>
-          <p:nvPr/>
-        </p:nvSpPr>
-        <p:spPr>
-          <a:xfrm>
-            <a:off x="457200" y="3840480"/>
-            <a:ext cx="11247120" cy="411480"/>
-          </a:xfrm>
-          <a:prstGeom prst="rect">
-            <a:avLst/>
-          </a:prstGeom>
-          <a:noFill/>
-          <a:ln/>
-        </p:spPr>
-        <p:txBody>
-          <a:bodyPr wrap="square" lIns="0" tIns="0" rIns="0" bIns="0" rtlCol="0" anchor="ctr"/>
-          <a:lstStyle/>
-          <a:p>
-            <a:pPr indent="0" marL="0">
-              <a:buNone/>
-            </a:pPr>
-            <a:r>
-              <a:rPr lang="en-US" sz="1600" b="1" dirty="0">
-                <a:solidFill>
-                  <a:srgbClr val="1E3A5F"/>
-                </a:solidFill>
-                <a:latin typeface="Arial" pitchFamily="34" charset="0"/>
-                <a:ea typeface="Arial" pitchFamily="34" charset="-122"/>
-                <a:cs typeface="Arial" pitchFamily="34" charset="-120"/>
-              </a:rPr>
-              <a:t>Társadalmi megtérülés (SROI-logika):</a:t>
+              <a:t>A négy fő kockázat és kezelése</a:t>
             </a:r>
             <a:endParaRPr lang="en-US" sz="1600" dirty="0"/>
           </a:p>
@@ -9520,14 +9602,14 @@
       </p:sp>
       <p:sp>
         <p:nvSpPr>
-          <p:cNvPr id="18" name="Text 16"/>
-          <p:cNvSpPr/>
-          <p:nvPr/>
-        </p:nvSpPr>
-        <p:spPr>
-          <a:xfrm>
-            <a:off x="640080" y="4297680"/>
-            <a:ext cx="10881360" cy="2011680"/>
+          <p:cNvPr id="23" name="Text 21"/>
+          <p:cNvSpPr/>
+          <p:nvPr/>
+        </p:nvSpPr>
+        <p:spPr>
+          <a:xfrm>
+            <a:off x="6629400" y="2148840"/>
+            <a:ext cx="4846320" cy="3657600"/>
           </a:xfrm>
           <a:prstGeom prst="rect">
             <a:avLst/>
@@ -9541,13 +9623,13 @@
           <a:p>
             <a:pPr marL="342900" indent="-342900">
               <a:spcAft>
-                <a:spcPts val="800"/>
+                <a:spcPts val="900"/>
               </a:spcAft>
               <a:buSzPct val="100000"/>
               <a:buChar char="•"/>
             </a:pPr>
             <a:r>
-              <a:rPr lang="en-US" sz="1400" dirty="0">
+              <a:rPr lang="en-US" sz="1300" dirty="0">
                 <a:solidFill>
                   <a:srgbClr val="5B6770"/>
                 </a:solidFill>
@@ -9555,20 +9637,20 @@
                 <a:ea typeface="Arial" pitchFamily="34" charset="-122"/>
                 <a:cs typeface="Arial" pitchFamily="34" charset="-120"/>
               </a:rPr>
-              <a:t>Egyetlen megelőzött droghasználói életút társadalmi megtakarítása több tízmillió forint.</a:t>
-            </a:r>
-            <a:endParaRPr lang="en-US" sz="1400" dirty="0"/>
+              <a:t>Alacsony részvétel → roma önkormányzatok és tanodák toboroznak; a program ingyenes, a zene vonz.</a:t>
+            </a:r>
+            <a:endParaRPr lang="en-US" sz="1300" dirty="0"/>
           </a:p>
           <a:p>
             <a:pPr marL="342900" indent="-342900">
               <a:spcAft>
-                <a:spcPts val="800"/>
+                <a:spcPts val="900"/>
               </a:spcAft>
               <a:buSzPct val="100000"/>
               <a:buChar char="•"/>
             </a:pPr>
             <a:r>
-              <a:rPr lang="en-US" sz="1400" dirty="0">
+              <a:rPr lang="en-US" sz="1300" dirty="0">
                 <a:solidFill>
                   <a:srgbClr val="5B6770"/>
                 </a:solidFill>
@@ -9576,20 +9658,20 @@
                 <a:ea typeface="Arial" pitchFamily="34" charset="-122"/>
                 <a:cs typeface="Arial" pitchFamily="34" charset="-120"/>
               </a:rPr>
-              <a:t>Egy megelőzött korai iskolaelhagyás életpálya-szinten többletadó-bevételt hoz és csökkenti a segélyfüggőséget.</a:t>
-            </a:r>
-            <a:endParaRPr lang="en-US" sz="1400" dirty="0"/>
+              <a:t>Naptárütközés → a 12 időpont szerződésben rögzítve, tartalékdátumokkal.</a:t>
+            </a:r>
+            <a:endParaRPr lang="en-US" sz="1300" dirty="0"/>
           </a:p>
           <a:p>
             <a:pPr marL="342900" indent="-342900">
               <a:spcAft>
-                <a:spcPts val="800"/>
+                <a:spcPts val="900"/>
               </a:spcAft>
               <a:buSzPct val="100000"/>
               <a:buChar char="•"/>
             </a:pPr>
             <a:r>
-              <a:rPr lang="en-US" sz="1400" dirty="0">
+              <a:rPr lang="en-US" sz="1300" dirty="0">
                 <a:solidFill>
                   <a:srgbClr val="5B6770"/>
                 </a:solidFill>
@@ -9597,9 +9679,9 @@
                 <a:ea typeface="Arial" pitchFamily="34" charset="-122"/>
                 <a:cs typeface="Arial" pitchFamily="34" charset="-120"/>
               </a:rPr>
-              <a:t>Egy uzsoracsapdából kimentett család: megőrzött lakhatás, elkerült gyermekvédelmi beavatkozás.</a:t>
-            </a:r>
-            <a:endParaRPr lang="en-US" sz="1400" dirty="0"/>
+              <a:t>Pályázati csúszás → az ütemezés a támogatási szerződéshez igazítva, előkészítési szakasz beépítve.</a:t>
+            </a:r>
+            <a:endParaRPr lang="en-US" sz="1300" dirty="0"/>
           </a:p>
           <a:p>
             <a:pPr marL="342900" indent="-342900">
@@ -9607,23 +9689,23 @@
               <a:buChar char="•"/>
             </a:pPr>
             <a:r>
-              <a:rPr lang="en-US" sz="1400" b="1" dirty="0">
-                <a:solidFill>
-                  <a:srgbClr val="1E3A5F"/>
-                </a:solidFill>
-                <a:latin typeface="Arial" pitchFamily="34" charset="0"/>
-                <a:ea typeface="Arial" pitchFamily="34" charset="-122"/>
-                <a:cs typeface="Arial" pitchFamily="34" charset="-120"/>
-              </a:rPr>
-              <a:t>Ha az elért 3 000 főből csak 2% (60 fő) esetében történik érdemi fordulat, a társadalmi megtérülés meghaladja a teljes költségvetést.</a:t>
-            </a:r>
-            <a:endParaRPr lang="en-US" sz="1400" dirty="0"/>
-          </a:p>
-        </p:txBody>
-      </p:sp>
-      <p:sp>
-        <p:nvSpPr>
-          <p:cNvPr id="19" name="Text 17"/>
+              <a:rPr lang="en-US" sz="1300" dirty="0">
+                <a:solidFill>
+                  <a:srgbClr val="5B6770"/>
+                </a:solidFill>
+                <a:latin typeface="Arial" pitchFamily="34" charset="0"/>
+                <a:ea typeface="Arial" pitchFamily="34" charset="-122"/>
+                <a:cs typeface="Arial" pitchFamily="34" charset="-120"/>
+              </a:rPr>
+              <a:t>Médiakockázat → egységes kommunikációs terv, a nagyköveti szerződésben rögzített értékrend.</a:t>
+            </a:r>
+            <a:endParaRPr lang="en-US" sz="1300" dirty="0"/>
+          </a:p>
+        </p:txBody>
+      </p:sp>
+      <p:sp>
+        <p:nvSpPr>
+          <p:cNvPr id="24" name="Text 22"/>
           <p:cNvSpPr/>
           <p:nvPr/>
         </p:nvSpPr>
@@ -9671,889 +9753,6 @@
 <file path=ppt/slides/slide16.xml><?xml version="1.0" encoding="utf-8"?>
 <p:sld xmlns:a="http://schemas.openxmlformats.org/drawingml/2006/main" xmlns:r="http://schemas.openxmlformats.org/officeDocument/2006/relationships" xmlns:p="http://schemas.openxmlformats.org/presentationml/2006/main">
   <p:cSld name="Slide 16">
-    <p:bg>
-      <p:bgPr>
-        <a:solidFill>
-          <a:srgbClr val="FFFFFF"/>
-        </a:solidFill>
-      </p:bgPr>
-    </p:bg>
-    <p:spTree>
-      <p:nvGrpSpPr>
-        <p:cNvPr id="1" name=""/>
-        <p:cNvGrpSpPr/>
-        <p:nvPr/>
-      </p:nvGrpSpPr>
-      <p:grpSpPr>
-        <a:xfrm>
-          <a:off x="0" y="0"/>
-          <a:ext cx="0" cy="0"/>
-          <a:chOff x="0" y="0"/>
-          <a:chExt cx="0" cy="0"/>
-        </a:xfrm>
-      </p:grpSpPr>
-      <p:sp>
-        <p:nvSpPr>
-          <p:cNvPr id="2" name="Text 0"/>
-          <p:cNvSpPr/>
-          <p:nvPr/>
-        </p:nvSpPr>
-        <p:spPr>
-          <a:xfrm>
-            <a:off x="457200" y="365760"/>
-            <a:ext cx="9966960" cy="731520"/>
-          </a:xfrm>
-          <a:prstGeom prst="rect">
-            <a:avLst/>
-          </a:prstGeom>
-          <a:noFill/>
-          <a:ln/>
-        </p:spPr>
-        <p:txBody>
-          <a:bodyPr wrap="square" lIns="0" tIns="0" rIns="0" bIns="0" rtlCol="0" anchor="ctr"/>
-          <a:lstStyle/>
-          <a:p>
-            <a:pPr indent="0" marL="0">
-              <a:buNone/>
-            </a:pPr>
-            <a:r>
-              <a:rPr lang="en-US" sz="3600" b="1" dirty="0">
-                <a:solidFill>
-                  <a:srgbClr val="1E3A5F"/>
-                </a:solidFill>
-                <a:latin typeface="Arial" pitchFamily="34" charset="0"/>
-                <a:ea typeface="Arial" pitchFamily="34" charset="-122"/>
-                <a:cs typeface="Arial" pitchFamily="34" charset="-120"/>
-              </a:rPr>
-              <a:t>Ütemterv és kockázatkezelés</a:t>
-            </a:r>
-            <a:endParaRPr lang="en-US" sz="3600" dirty="0"/>
-          </a:p>
-        </p:txBody>
-      </p:sp>
-      <p:sp>
-        <p:nvSpPr>
-          <p:cNvPr id="3" name="Shape 1"/>
-          <p:cNvSpPr/>
-          <p:nvPr/>
-        </p:nvSpPr>
-        <p:spPr>
-          <a:xfrm>
-            <a:off x="10561320" y="457200"/>
-            <a:ext cx="1143000" cy="457200"/>
-          </a:xfrm>
-          <a:prstGeom prst="roundRect">
-            <a:avLst>
-              <a:gd name="adj" fmla="val 20000"/>
-            </a:avLst>
-          </a:prstGeom>
-          <a:solidFill>
-            <a:srgbClr val="1E3A5F"/>
-          </a:solidFill>
-          <a:ln/>
-        </p:spPr>
-      </p:sp>
-      <p:sp>
-        <p:nvSpPr>
-          <p:cNvPr id="4" name="Text 2"/>
-          <p:cNvSpPr/>
-          <p:nvPr/>
-        </p:nvSpPr>
-        <p:spPr>
-          <a:xfrm>
-            <a:off x="10561320" y="457200"/>
-            <a:ext cx="1143000" cy="457200"/>
-          </a:xfrm>
-          <a:prstGeom prst="rect">
-            <a:avLst/>
-          </a:prstGeom>
-          <a:noFill/>
-          <a:ln/>
-        </p:spPr>
-        <p:txBody>
-          <a:bodyPr wrap="square" lIns="0" tIns="0" rIns="0" bIns="0" rtlCol="0" anchor="ctr"/>
-          <a:lstStyle/>
-          <a:p>
-            <a:pPr algn="ctr" indent="0" marL="0">
-              <a:buNone/>
-            </a:pPr>
-            <a:r>
-              <a:rPr lang="en-US" sz="1300" b="1" dirty="0">
-                <a:solidFill>
-                  <a:srgbClr val="F5C518"/>
-                </a:solidFill>
-                <a:latin typeface="Arial" pitchFamily="34" charset="0"/>
-                <a:ea typeface="Arial" pitchFamily="34" charset="-122"/>
-                <a:cs typeface="Arial" pitchFamily="34" charset="-120"/>
-              </a:rPr>
-              <a:t>~1,5′</a:t>
-            </a:r>
-            <a:endParaRPr lang="en-US" sz="1300" dirty="0"/>
-          </a:p>
-        </p:txBody>
-      </p:sp>
-      <p:sp>
-        <p:nvSpPr>
-          <p:cNvPr id="5" name="Shape 3"/>
-          <p:cNvSpPr/>
-          <p:nvPr/>
-        </p:nvSpPr>
-        <p:spPr>
-          <a:xfrm>
-            <a:off x="548640" y="1481328"/>
-            <a:ext cx="502920" cy="502920"/>
-          </a:xfrm>
-          <a:prstGeom prst="ellipse">
-            <a:avLst/>
-          </a:prstGeom>
-          <a:solidFill>
-            <a:srgbClr val="D93025"/>
-          </a:solidFill>
-          <a:ln/>
-        </p:spPr>
-      </p:sp>
-      <p:sp>
-        <p:nvSpPr>
-          <p:cNvPr id="6" name="Text 4"/>
-          <p:cNvSpPr/>
-          <p:nvPr/>
-        </p:nvSpPr>
-        <p:spPr>
-          <a:xfrm>
-            <a:off x="548640" y="1481328"/>
-            <a:ext cx="502920" cy="502920"/>
-          </a:xfrm>
-          <a:prstGeom prst="rect">
-            <a:avLst/>
-          </a:prstGeom>
-          <a:noFill/>
-          <a:ln/>
-        </p:spPr>
-        <p:txBody>
-          <a:bodyPr wrap="square" lIns="0" tIns="0" rIns="0" bIns="0" rtlCol="0" anchor="ctr"/>
-          <a:lstStyle/>
-          <a:p>
-            <a:pPr algn="ctr" indent="0" marL="0">
-              <a:buNone/>
-            </a:pPr>
-            <a:r>
-              <a:rPr lang="en-US" sz="1800" b="1" dirty="0">
-                <a:solidFill>
-                  <a:srgbClr val="FFFFFF"/>
-                </a:solidFill>
-                <a:latin typeface="Arial" pitchFamily="34" charset="0"/>
-                <a:ea typeface="Arial" pitchFamily="34" charset="-122"/>
-                <a:cs typeface="Arial" pitchFamily="34" charset="-120"/>
-              </a:rPr>
-              <a:t>1</a:t>
-            </a:r>
-            <a:endParaRPr lang="en-US" sz="1800" dirty="0"/>
-          </a:p>
-        </p:txBody>
-      </p:sp>
-      <p:sp>
-        <p:nvSpPr>
-          <p:cNvPr id="7" name="Text 5"/>
-          <p:cNvSpPr/>
-          <p:nvPr/>
-        </p:nvSpPr>
-        <p:spPr>
-          <a:xfrm>
-            <a:off x="1280160" y="1371600"/>
-            <a:ext cx="4206240" cy="411480"/>
-          </a:xfrm>
-          <a:prstGeom prst="rect">
-            <a:avLst/>
-          </a:prstGeom>
-          <a:noFill/>
-          <a:ln/>
-        </p:spPr>
-        <p:txBody>
-          <a:bodyPr wrap="square" lIns="0" tIns="0" rIns="0" bIns="0" rtlCol="0" anchor="ctr"/>
-          <a:lstStyle/>
-          <a:p>
-            <a:pPr indent="0" marL="0">
-              <a:buNone/>
-            </a:pPr>
-            <a:r>
-              <a:rPr lang="en-US" sz="1600" b="1" dirty="0">
-                <a:solidFill>
-                  <a:srgbClr val="1E3A5F"/>
-                </a:solidFill>
-                <a:latin typeface="Arial" pitchFamily="34" charset="0"/>
-                <a:ea typeface="Arial" pitchFamily="34" charset="-122"/>
-                <a:cs typeface="Arial" pitchFamily="34" charset="-120"/>
-              </a:rPr>
-              <a:t>0–2. hónap</a:t>
-            </a:r>
-            <a:endParaRPr lang="en-US" sz="1600" dirty="0"/>
-          </a:p>
-        </p:txBody>
-      </p:sp>
-      <p:sp>
-        <p:nvSpPr>
-          <p:cNvPr id="8" name="Text 6"/>
-          <p:cNvSpPr/>
-          <p:nvPr/>
-        </p:nvSpPr>
-        <p:spPr>
-          <a:xfrm>
-            <a:off x="1280160" y="1783080"/>
-            <a:ext cx="4480560" cy="640080"/>
-          </a:xfrm>
-          <a:prstGeom prst="rect">
-            <a:avLst/>
-          </a:prstGeom>
-          <a:noFill/>
-          <a:ln/>
-        </p:spPr>
-        <p:txBody>
-          <a:bodyPr wrap="square" lIns="0" tIns="0" rIns="0" bIns="0" rtlCol="0" anchor="ctr"/>
-          <a:lstStyle/>
-          <a:p>
-            <a:pPr indent="0" marL="0">
-              <a:buNone/>
-            </a:pPr>
-            <a:r>
-              <a:rPr lang="en-US" sz="1250" dirty="0">
-                <a:solidFill>
-                  <a:srgbClr val="5B6770"/>
-                </a:solidFill>
-                <a:latin typeface="Arial" pitchFamily="34" charset="0"/>
-                <a:ea typeface="Arial" pitchFamily="34" charset="-122"/>
-                <a:cs typeface="Arial" pitchFamily="34" charset="-120"/>
-              </a:rPr>
-              <a:t>Pályázat beadása (2026. szept. 30.), partneri és nagyköveti szerződések</a:t>
-            </a:r>
-            <a:endParaRPr lang="en-US" sz="1250" dirty="0"/>
-          </a:p>
-        </p:txBody>
-      </p:sp>
-      <p:sp>
-        <p:nvSpPr>
-          <p:cNvPr id="9" name="Shape 7"/>
-          <p:cNvSpPr/>
-          <p:nvPr/>
-        </p:nvSpPr>
-        <p:spPr>
-          <a:xfrm>
-            <a:off x="548640" y="2670048"/>
-            <a:ext cx="502920" cy="502920"/>
-          </a:xfrm>
-          <a:prstGeom prst="ellipse">
-            <a:avLst/>
-          </a:prstGeom>
-          <a:solidFill>
-            <a:srgbClr val="D93025"/>
-          </a:solidFill>
-          <a:ln/>
-        </p:spPr>
-      </p:sp>
-      <p:sp>
-        <p:nvSpPr>
-          <p:cNvPr id="10" name="Text 8"/>
-          <p:cNvSpPr/>
-          <p:nvPr/>
-        </p:nvSpPr>
-        <p:spPr>
-          <a:xfrm>
-            <a:off x="548640" y="2670048"/>
-            <a:ext cx="502920" cy="502920"/>
-          </a:xfrm>
-          <a:prstGeom prst="rect">
-            <a:avLst/>
-          </a:prstGeom>
-          <a:noFill/>
-          <a:ln/>
-        </p:spPr>
-        <p:txBody>
-          <a:bodyPr wrap="square" lIns="0" tIns="0" rIns="0" bIns="0" rtlCol="0" anchor="ctr"/>
-          <a:lstStyle/>
-          <a:p>
-            <a:pPr algn="ctr" indent="0" marL="0">
-              <a:buNone/>
-            </a:pPr>
-            <a:r>
-              <a:rPr lang="en-US" sz="1800" b="1" dirty="0">
-                <a:solidFill>
-                  <a:srgbClr val="FFFFFF"/>
-                </a:solidFill>
-                <a:latin typeface="Arial" pitchFamily="34" charset="0"/>
-                <a:ea typeface="Arial" pitchFamily="34" charset="-122"/>
-                <a:cs typeface="Arial" pitchFamily="34" charset="-120"/>
-              </a:rPr>
-              <a:t>2</a:t>
-            </a:r>
-            <a:endParaRPr lang="en-US" sz="1800" dirty="0"/>
-          </a:p>
-        </p:txBody>
-      </p:sp>
-      <p:sp>
-        <p:nvSpPr>
-          <p:cNvPr id="11" name="Text 9"/>
-          <p:cNvSpPr/>
-          <p:nvPr/>
-        </p:nvSpPr>
-        <p:spPr>
-          <a:xfrm>
-            <a:off x="1280160" y="2560320"/>
-            <a:ext cx="4206240" cy="411480"/>
-          </a:xfrm>
-          <a:prstGeom prst="rect">
-            <a:avLst/>
-          </a:prstGeom>
-          <a:noFill/>
-          <a:ln/>
-        </p:spPr>
-        <p:txBody>
-          <a:bodyPr wrap="square" lIns="0" tIns="0" rIns="0" bIns="0" rtlCol="0" anchor="ctr"/>
-          <a:lstStyle/>
-          <a:p>
-            <a:pPr indent="0" marL="0">
-              <a:buNone/>
-            </a:pPr>
-            <a:r>
-              <a:rPr lang="en-US" sz="1600" b="1" dirty="0">
-                <a:solidFill>
-                  <a:srgbClr val="1E3A5F"/>
-                </a:solidFill>
-                <a:latin typeface="Arial" pitchFamily="34" charset="0"/>
-                <a:ea typeface="Arial" pitchFamily="34" charset="-122"/>
-                <a:cs typeface="Arial" pitchFamily="34" charset="-120"/>
-              </a:rPr>
-              <a:t>3. hónap</a:t>
-            </a:r>
-            <a:endParaRPr lang="en-US" sz="1600" dirty="0"/>
-          </a:p>
-        </p:txBody>
-      </p:sp>
-      <p:sp>
-        <p:nvSpPr>
-          <p:cNvPr id="12" name="Text 10"/>
-          <p:cNvSpPr/>
-          <p:nvPr/>
-        </p:nvSpPr>
-        <p:spPr>
-          <a:xfrm>
-            <a:off x="1280160" y="2971800"/>
-            <a:ext cx="4480560" cy="640080"/>
-          </a:xfrm>
-          <a:prstGeom prst="rect">
-            <a:avLst/>
-          </a:prstGeom>
-          <a:noFill/>
-          <a:ln/>
-        </p:spPr>
-        <p:txBody>
-          <a:bodyPr wrap="square" lIns="0" tIns="0" rIns="0" bIns="0" rtlCol="0" anchor="ctr"/>
-          <a:lstStyle/>
-          <a:p>
-            <a:pPr indent="0" marL="0">
-              <a:buNone/>
-            </a:pPr>
-            <a:r>
-              <a:rPr lang="en-US" sz="1250" dirty="0">
-                <a:solidFill>
-                  <a:srgbClr val="5B6770"/>
-                </a:solidFill>
-                <a:latin typeface="Arial" pitchFamily="34" charset="0"/>
-                <a:ea typeface="Arial" pitchFamily="34" charset="-122"/>
-                <a:cs typeface="Arial" pitchFamily="34" charset="-120"/>
-              </a:rPr>
-              <a:t>Előkészítés: helyszínfoglalás, toborzás, kampányindítás</a:t>
-            </a:r>
-            <a:endParaRPr lang="en-US" sz="1250" dirty="0"/>
-          </a:p>
-        </p:txBody>
-      </p:sp>
-      <p:sp>
-        <p:nvSpPr>
-          <p:cNvPr id="13" name="Shape 11"/>
-          <p:cNvSpPr/>
-          <p:nvPr/>
-        </p:nvSpPr>
-        <p:spPr>
-          <a:xfrm>
-            <a:off x="548640" y="3858768"/>
-            <a:ext cx="502920" cy="502920"/>
-          </a:xfrm>
-          <a:prstGeom prst="ellipse">
-            <a:avLst/>
-          </a:prstGeom>
-          <a:solidFill>
-            <a:srgbClr val="D93025"/>
-          </a:solidFill>
-          <a:ln/>
-        </p:spPr>
-      </p:sp>
-      <p:sp>
-        <p:nvSpPr>
-          <p:cNvPr id="14" name="Text 12"/>
-          <p:cNvSpPr/>
-          <p:nvPr/>
-        </p:nvSpPr>
-        <p:spPr>
-          <a:xfrm>
-            <a:off x="548640" y="3858768"/>
-            <a:ext cx="502920" cy="502920"/>
-          </a:xfrm>
-          <a:prstGeom prst="rect">
-            <a:avLst/>
-          </a:prstGeom>
-          <a:noFill/>
-          <a:ln/>
-        </p:spPr>
-        <p:txBody>
-          <a:bodyPr wrap="square" lIns="0" tIns="0" rIns="0" bIns="0" rtlCol="0" anchor="ctr"/>
-          <a:lstStyle/>
-          <a:p>
-            <a:pPr algn="ctr" indent="0" marL="0">
-              <a:buNone/>
-            </a:pPr>
-            <a:r>
-              <a:rPr lang="en-US" sz="1800" b="1" dirty="0">
-                <a:solidFill>
-                  <a:srgbClr val="FFFFFF"/>
-                </a:solidFill>
-                <a:latin typeface="Arial" pitchFamily="34" charset="0"/>
-                <a:ea typeface="Arial" pitchFamily="34" charset="-122"/>
-                <a:cs typeface="Arial" pitchFamily="34" charset="-120"/>
-              </a:rPr>
-              <a:t>3</a:t>
-            </a:r>
-            <a:endParaRPr lang="en-US" sz="1800" dirty="0"/>
-          </a:p>
-        </p:txBody>
-      </p:sp>
-      <p:sp>
-        <p:nvSpPr>
-          <p:cNvPr id="15" name="Text 13"/>
-          <p:cNvSpPr/>
-          <p:nvPr/>
-        </p:nvSpPr>
-        <p:spPr>
-          <a:xfrm>
-            <a:off x="1280160" y="3749040"/>
-            <a:ext cx="4206240" cy="411480"/>
-          </a:xfrm>
-          <a:prstGeom prst="rect">
-            <a:avLst/>
-          </a:prstGeom>
-          <a:noFill/>
-          <a:ln/>
-        </p:spPr>
-        <p:txBody>
-          <a:bodyPr wrap="square" lIns="0" tIns="0" rIns="0" bIns="0" rtlCol="0" anchor="ctr"/>
-          <a:lstStyle/>
-          <a:p>
-            <a:pPr indent="0" marL="0">
-              <a:buNone/>
-            </a:pPr>
-            <a:r>
-              <a:rPr lang="en-US" sz="1600" b="1" dirty="0">
-                <a:solidFill>
-                  <a:srgbClr val="1E3A5F"/>
-                </a:solidFill>
-                <a:latin typeface="Arial" pitchFamily="34" charset="0"/>
-                <a:ea typeface="Arial" pitchFamily="34" charset="-122"/>
-                <a:cs typeface="Arial" pitchFamily="34" charset="-120"/>
-              </a:rPr>
-              <a:t>4–9. hónap</a:t>
-            </a:r>
-            <a:endParaRPr lang="en-US" sz="1600" dirty="0"/>
-          </a:p>
-        </p:txBody>
-      </p:sp>
-      <p:sp>
-        <p:nvSpPr>
-          <p:cNvPr id="16" name="Text 14"/>
-          <p:cNvSpPr/>
-          <p:nvPr/>
-        </p:nvSpPr>
-        <p:spPr>
-          <a:xfrm>
-            <a:off x="1280160" y="4160520"/>
-            <a:ext cx="4480560" cy="640080"/>
-          </a:xfrm>
-          <a:prstGeom prst="rect">
-            <a:avLst/>
-          </a:prstGeom>
-          <a:noFill/>
-          <a:ln/>
-        </p:spPr>
-        <p:txBody>
-          <a:bodyPr wrap="square" lIns="0" tIns="0" rIns="0" bIns="0" rtlCol="0" anchor="ctr"/>
-          <a:lstStyle/>
-          <a:p>
-            <a:pPr indent="0" marL="0">
-              <a:buNone/>
-            </a:pPr>
-            <a:r>
-              <a:rPr lang="en-US" sz="1250" dirty="0">
-                <a:solidFill>
-                  <a:srgbClr val="5B6770"/>
-                </a:solidFill>
-                <a:latin typeface="Arial" pitchFamily="34" charset="0"/>
-                <a:ea typeface="Arial" pitchFamily="34" charset="-122"/>
-                <a:cs typeface="Arial" pitchFamily="34" charset="-120"/>
-              </a:rPr>
-              <a:t>A 12 alkalom megvalósítása, kéthetente</a:t>
-            </a:r>
-            <a:endParaRPr lang="en-US" sz="1250" dirty="0"/>
-          </a:p>
-        </p:txBody>
-      </p:sp>
-      <p:sp>
-        <p:nvSpPr>
-          <p:cNvPr id="17" name="Shape 15"/>
-          <p:cNvSpPr/>
-          <p:nvPr/>
-        </p:nvSpPr>
-        <p:spPr>
-          <a:xfrm>
-            <a:off x="548640" y="5047488"/>
-            <a:ext cx="502920" cy="502920"/>
-          </a:xfrm>
-          <a:prstGeom prst="ellipse">
-            <a:avLst/>
-          </a:prstGeom>
-          <a:solidFill>
-            <a:srgbClr val="D93025"/>
-          </a:solidFill>
-          <a:ln/>
-        </p:spPr>
-      </p:sp>
-      <p:sp>
-        <p:nvSpPr>
-          <p:cNvPr id="18" name="Text 16"/>
-          <p:cNvSpPr/>
-          <p:nvPr/>
-        </p:nvSpPr>
-        <p:spPr>
-          <a:xfrm>
-            <a:off x="548640" y="5047488"/>
-            <a:ext cx="502920" cy="502920"/>
-          </a:xfrm>
-          <a:prstGeom prst="rect">
-            <a:avLst/>
-          </a:prstGeom>
-          <a:noFill/>
-          <a:ln/>
-        </p:spPr>
-        <p:txBody>
-          <a:bodyPr wrap="square" lIns="0" tIns="0" rIns="0" bIns="0" rtlCol="0" anchor="ctr"/>
-          <a:lstStyle/>
-          <a:p>
-            <a:pPr algn="ctr" indent="0" marL="0">
-              <a:buNone/>
-            </a:pPr>
-            <a:r>
-              <a:rPr lang="en-US" sz="1800" b="1" dirty="0">
-                <a:solidFill>
-                  <a:srgbClr val="FFFFFF"/>
-                </a:solidFill>
-                <a:latin typeface="Arial" pitchFamily="34" charset="0"/>
-                <a:ea typeface="Arial" pitchFamily="34" charset="-122"/>
-                <a:cs typeface="Arial" pitchFamily="34" charset="-120"/>
-              </a:rPr>
-              <a:t>4</a:t>
-            </a:r>
-            <a:endParaRPr lang="en-US" sz="1800" dirty="0"/>
-          </a:p>
-        </p:txBody>
-      </p:sp>
-      <p:sp>
-        <p:nvSpPr>
-          <p:cNvPr id="19" name="Text 17"/>
-          <p:cNvSpPr/>
-          <p:nvPr/>
-        </p:nvSpPr>
-        <p:spPr>
-          <a:xfrm>
-            <a:off x="1280160" y="4937760"/>
-            <a:ext cx="4206240" cy="411480"/>
-          </a:xfrm>
-          <a:prstGeom prst="rect">
-            <a:avLst/>
-          </a:prstGeom>
-          <a:noFill/>
-          <a:ln/>
-        </p:spPr>
-        <p:txBody>
-          <a:bodyPr wrap="square" lIns="0" tIns="0" rIns="0" bIns="0" rtlCol="0" anchor="ctr"/>
-          <a:lstStyle/>
-          <a:p>
-            <a:pPr indent="0" marL="0">
-              <a:buNone/>
-            </a:pPr>
-            <a:r>
-              <a:rPr lang="en-US" sz="1600" b="1" dirty="0">
-                <a:solidFill>
-                  <a:srgbClr val="1E3A5F"/>
-                </a:solidFill>
-                <a:latin typeface="Arial" pitchFamily="34" charset="0"/>
-                <a:ea typeface="Arial" pitchFamily="34" charset="-122"/>
-                <a:cs typeface="Arial" pitchFamily="34" charset="-120"/>
-              </a:rPr>
-              <a:t>10. hónap</a:t>
-            </a:r>
-            <a:endParaRPr lang="en-US" sz="1600" dirty="0"/>
-          </a:p>
-        </p:txBody>
-      </p:sp>
-      <p:sp>
-        <p:nvSpPr>
-          <p:cNvPr id="20" name="Text 18"/>
-          <p:cNvSpPr/>
-          <p:nvPr/>
-        </p:nvSpPr>
-        <p:spPr>
-          <a:xfrm>
-            <a:off x="1280160" y="5349240"/>
-            <a:ext cx="4480560" cy="640080"/>
-          </a:xfrm>
-          <a:prstGeom prst="rect">
-            <a:avLst/>
-          </a:prstGeom>
-          <a:noFill/>
-          <a:ln/>
-        </p:spPr>
-        <p:txBody>
-          <a:bodyPr wrap="square" lIns="0" tIns="0" rIns="0" bIns="0" rtlCol="0" anchor="ctr"/>
-          <a:lstStyle/>
-          <a:p>
-            <a:pPr indent="0" marL="0">
-              <a:buNone/>
-            </a:pPr>
-            <a:r>
-              <a:rPr lang="en-US" sz="1250" dirty="0">
-                <a:solidFill>
-                  <a:srgbClr val="5B6770"/>
-                </a:solidFill>
-                <a:latin typeface="Arial" pitchFamily="34" charset="0"/>
-                <a:ea typeface="Arial" pitchFamily="34" charset="-122"/>
-                <a:cs typeface="Arial" pitchFamily="34" charset="-120"/>
-              </a:rPr>
-              <a:t>Hatásmérés, záró rendezvény, beszámoló, folytatási javaslat</a:t>
-            </a:r>
-            <a:endParaRPr lang="en-US" sz="1250" dirty="0"/>
-          </a:p>
-        </p:txBody>
-      </p:sp>
-      <p:sp>
-        <p:nvSpPr>
-          <p:cNvPr id="21" name="Shape 19"/>
-          <p:cNvSpPr/>
-          <p:nvPr/>
-        </p:nvSpPr>
-        <p:spPr>
-          <a:xfrm>
-            <a:off x="6217920" y="1371600"/>
-            <a:ext cx="5486400" cy="4663440"/>
-          </a:xfrm>
-          <a:prstGeom prst="roundRect">
-            <a:avLst>
-              <a:gd name="adj" fmla="val 2353"/>
-            </a:avLst>
-          </a:prstGeom>
-          <a:solidFill>
-            <a:srgbClr val="F4F7FA"/>
-          </a:solidFill>
-          <a:ln/>
-        </p:spPr>
-      </p:sp>
-      <p:sp>
-        <p:nvSpPr>
-          <p:cNvPr id="22" name="Text 20"/>
-          <p:cNvSpPr/>
-          <p:nvPr/>
-        </p:nvSpPr>
-        <p:spPr>
-          <a:xfrm>
-            <a:off x="6492240" y="1600200"/>
-            <a:ext cx="4937760" cy="411480"/>
-          </a:xfrm>
-          <a:prstGeom prst="rect">
-            <a:avLst/>
-          </a:prstGeom>
-          <a:noFill/>
-          <a:ln/>
-        </p:spPr>
-        <p:txBody>
-          <a:bodyPr wrap="square" lIns="0" tIns="0" rIns="0" bIns="0" rtlCol="0" anchor="ctr"/>
-          <a:lstStyle/>
-          <a:p>
-            <a:pPr indent="0" marL="0">
-              <a:buNone/>
-            </a:pPr>
-            <a:r>
-              <a:rPr lang="en-US" sz="1600" b="1" dirty="0">
-                <a:solidFill>
-                  <a:srgbClr val="1E3A5F"/>
-                </a:solidFill>
-                <a:latin typeface="Arial" pitchFamily="34" charset="0"/>
-                <a:ea typeface="Arial" pitchFamily="34" charset="-122"/>
-                <a:cs typeface="Arial" pitchFamily="34" charset="-120"/>
-              </a:rPr>
-              <a:t>A négy fő kockázat és kezelése</a:t>
-            </a:r>
-            <a:endParaRPr lang="en-US" sz="1600" dirty="0"/>
-          </a:p>
-        </p:txBody>
-      </p:sp>
-      <p:sp>
-        <p:nvSpPr>
-          <p:cNvPr id="23" name="Text 21"/>
-          <p:cNvSpPr/>
-          <p:nvPr/>
-        </p:nvSpPr>
-        <p:spPr>
-          <a:xfrm>
-            <a:off x="6629400" y="2148840"/>
-            <a:ext cx="4846320" cy="3657600"/>
-          </a:xfrm>
-          <a:prstGeom prst="rect">
-            <a:avLst/>
-          </a:prstGeom>
-          <a:noFill/>
-          <a:ln/>
-        </p:spPr>
-        <p:txBody>
-          <a:bodyPr wrap="square" lIns="0" tIns="0" rIns="0" bIns="0" rtlCol="0" anchor="ctr"/>
-          <a:lstStyle/>
-          <a:p>
-            <a:pPr marL="342900" indent="-342900">
-              <a:spcAft>
-                <a:spcPts val="900"/>
-              </a:spcAft>
-              <a:buSzPct val="100000"/>
-              <a:buChar char="•"/>
-            </a:pPr>
-            <a:r>
-              <a:rPr lang="en-US" sz="1300" dirty="0">
-                <a:solidFill>
-                  <a:srgbClr val="5B6770"/>
-                </a:solidFill>
-                <a:latin typeface="Arial" pitchFamily="34" charset="0"/>
-                <a:ea typeface="Arial" pitchFamily="34" charset="-122"/>
-                <a:cs typeface="Arial" pitchFamily="34" charset="-120"/>
-              </a:rPr>
-              <a:t>Alacsony részvétel → roma önkormányzatok és tanodák toboroznak; a program ingyenes, a zene vonz.</a:t>
-            </a:r>
-            <a:endParaRPr lang="en-US" sz="1300" dirty="0"/>
-          </a:p>
-          <a:p>
-            <a:pPr marL="342900" indent="-342900">
-              <a:spcAft>
-                <a:spcPts val="900"/>
-              </a:spcAft>
-              <a:buSzPct val="100000"/>
-              <a:buChar char="•"/>
-            </a:pPr>
-            <a:r>
-              <a:rPr lang="en-US" sz="1300" dirty="0">
-                <a:solidFill>
-                  <a:srgbClr val="5B6770"/>
-                </a:solidFill>
-                <a:latin typeface="Arial" pitchFamily="34" charset="0"/>
-                <a:ea typeface="Arial" pitchFamily="34" charset="-122"/>
-                <a:cs typeface="Arial" pitchFamily="34" charset="-120"/>
-              </a:rPr>
-              <a:t>Naptárütközés → a 12 időpont szerződésben rögzítve, tartalékdátumokkal.</a:t>
-            </a:r>
-            <a:endParaRPr lang="en-US" sz="1300" dirty="0"/>
-          </a:p>
-          <a:p>
-            <a:pPr marL="342900" indent="-342900">
-              <a:spcAft>
-                <a:spcPts val="900"/>
-              </a:spcAft>
-              <a:buSzPct val="100000"/>
-              <a:buChar char="•"/>
-            </a:pPr>
-            <a:r>
-              <a:rPr lang="en-US" sz="1300" dirty="0">
-                <a:solidFill>
-                  <a:srgbClr val="5B6770"/>
-                </a:solidFill>
-                <a:latin typeface="Arial" pitchFamily="34" charset="0"/>
-                <a:ea typeface="Arial" pitchFamily="34" charset="-122"/>
-                <a:cs typeface="Arial" pitchFamily="34" charset="-120"/>
-              </a:rPr>
-              <a:t>Pályázati csúszás → az ütemezés a támogatási szerződéshez igazítva, előkészítési szakasz beépítve.</a:t>
-            </a:r>
-            <a:endParaRPr lang="en-US" sz="1300" dirty="0"/>
-          </a:p>
-          <a:p>
-            <a:pPr marL="342900" indent="-342900">
-              <a:buSzPct val="100000"/>
-              <a:buChar char="•"/>
-            </a:pPr>
-            <a:r>
-              <a:rPr lang="en-US" sz="1300" dirty="0">
-                <a:solidFill>
-                  <a:srgbClr val="5B6770"/>
-                </a:solidFill>
-                <a:latin typeface="Arial" pitchFamily="34" charset="0"/>
-                <a:ea typeface="Arial" pitchFamily="34" charset="-122"/>
-                <a:cs typeface="Arial" pitchFamily="34" charset="-120"/>
-              </a:rPr>
-              <a:t>Médiakockázat → egységes kommunikációs terv, a nagyköveti szerződésben rögzített értékrend.</a:t>
-            </a:r>
-            <a:endParaRPr lang="en-US" sz="1300" dirty="0"/>
-          </a:p>
-        </p:txBody>
-      </p:sp>
-      <p:sp>
-        <p:nvSpPr>
-          <p:cNvPr id="24" name="Text 22"/>
-          <p:cNvSpPr/>
-          <p:nvPr/>
-        </p:nvSpPr>
-        <p:spPr>
-          <a:xfrm>
-            <a:off x="457200" y="6473952"/>
-            <a:ext cx="7315200" cy="274320"/>
-          </a:xfrm>
-          <a:prstGeom prst="rect">
-            <a:avLst/>
-          </a:prstGeom>
-          <a:noFill/>
-          <a:ln/>
-        </p:spPr>
-        <p:txBody>
-          <a:bodyPr wrap="square" lIns="0" tIns="0" rIns="0" bIns="0" rtlCol="0" anchor="ctr"/>
-          <a:lstStyle/>
-          <a:p>
-            <a:pPr indent="0" marL="0">
-              <a:buNone/>
-            </a:pPr>
-            <a:r>
-              <a:rPr lang="en-US" sz="1000" dirty="0">
-                <a:solidFill>
-                  <a:srgbClr val="5B6770"/>
-                </a:solidFill>
-                <a:latin typeface="Arial" pitchFamily="34" charset="0"/>
-                <a:ea typeface="Arial" pitchFamily="34" charset="-122"/>
-                <a:cs typeface="Arial" pitchFamily="34" charset="-120"/>
-              </a:rPr>
-              <a:t>FELÚT – EU Roma Felzárkóztatási Program  ·  16</a:t>
-            </a:r>
-            <a:endParaRPr lang="en-US" sz="1000" dirty="0"/>
-          </a:p>
-        </p:txBody>
-      </p:sp>
-    </p:spTree>
-  </p:cSld>
-  <p:clrMapOvr>
-    <a:masterClrMapping/>
-  </p:clrMapOvr>
-</p:sld>
-</file>
-
-<file path=ppt/slides/slide17.xml><?xml version="1.0" encoding="utf-8"?>
-<p:sld xmlns:a="http://schemas.openxmlformats.org/drawingml/2006/main" xmlns:r="http://schemas.openxmlformats.org/officeDocument/2006/relationships" xmlns:p="http://schemas.openxmlformats.org/presentationml/2006/main">
-  <p:cSld name="Slide 17">
     <p:bg>
       <p:bgPr>
         <a:solidFill>
@@ -10899,7 +10098,7 @@
                 <a:ea typeface="Arial" pitchFamily="34" charset="-122"/>
                 <a:cs typeface="Arial" pitchFamily="34" charset="-120"/>
               </a:rPr>
-              <a:t>FELÚT – EU Roma Felzárkóztatási Program  ·  17</a:t>
+              <a:t>FELÚT – EU Roma Felzárkóztatási Program  ·  16</a:t>
             </a:r>
             <a:endParaRPr lang="en-US" sz="1000" dirty="0"/>
           </a:p>
@@ -11430,7 +10629,7 @@
                 <a:ea typeface="Arial" pitchFamily="34" charset="-122"/>
                 <a:cs typeface="Arial" pitchFamily="34" charset="-120"/>
               </a:rPr>
-              <a:t>3 · ERŐFORRÁSOK ÉS DÖNTÉS</a:t>
+              <a:t>3 · FORRÁSOK ÉS DÖNTÉS</a:t>
             </a:r>
             <a:endParaRPr lang="en-US" sz="1800" dirty="0"/>
           </a:p>
@@ -11469,7 +10668,7 @@
                 <a:ea typeface="Arial" pitchFamily="34" charset="-122"/>
                 <a:cs typeface="Arial" pitchFamily="34" charset="-120"/>
               </a:rPr>
-              <a:t>Költségvetés, nyitott hazai és EU-források, várt eredmények, ütemterv – és a mai döntési javaslat.</a:t>
+              <a:t>Nyitott hazai és EU-s pályázati lehetőségek, várt eredmények, ütemterv – és a mai döntési javaslat.</a:t>
             </a:r>
             <a:endParaRPr lang="en-US" sz="1350" dirty="0"/>
           </a:p>
@@ -15760,7 +14959,7 @@
                 <a:ea typeface="Arial" pitchFamily="34" charset="-122"/>
                 <a:cs typeface="Arial" pitchFamily="34" charset="-120"/>
               </a:rPr>
-              <a:t>60 M+</a:t>
+              <a:t>600 M+</a:t>
             </a:r>
             <a:endParaRPr lang="en-US" sz="3000" dirty="0"/>
           </a:p>
@@ -15799,7 +14998,7 @@
                 <a:ea typeface="Arial" pitchFamily="34" charset="-122"/>
                 <a:cs typeface="Arial" pitchFamily="34" charset="-120"/>
               </a:rPr>
-              <a:t>összesített megtekintés már 2011-ben – mára többszöröse</a:t>
+              <a:t>összesített megtekintés a csatornáin</a:t>
             </a:r>
             <a:endParaRPr lang="en-US" sz="1300" dirty="0"/>
           </a:p>

</xml_diff>